<commit_message>
Add adapted visual variants for paragraph 1 companions
</commit_message>
<xml_diff>
--- a/Boek 1 - Grondslagen, vraag en aanbod/1.1 Hoofdstuk Economisch denken en rekenen/1.1.1 Schaarste en economisch denken/1.1.1 Schaarste en economisch denken – presentatie.pptx
+++ b/Boek 1 - Grondslagen, vraag en aanbod/1.1 Hoofdstuk Economisch denken en rekenen/1.1.1 Schaarste en economisch denken/1.1.1 Schaarste en economisch denken – presentatie.pptx
@@ -371,7 +371,7 @@
             <a:pPr indent="0" algn="r">
               <a:buNone/>
             </a:pPr>
-            <a:fld id="{5A4DB056-6AEB-4761-90F8-E67C7E2A26AD}" type="slidenum">
+            <a:fld id="{B024595E-1BDD-4C05-87D3-43AE21B179DF}" type="slidenum">
               <a:rPr lang="en-US" sz="1400" b="0" u="none" strike="noStrike">
                 <a:solidFill>
                   <a:srgbClr val="000000"/>
@@ -546,7 +546,7 @@
               </a:lnSpc>
               <a:buNone/>
             </a:pPr>
-            <a:fld id="{908A1CC7-B046-432F-B92C-9844235B1957}" type="slidenum">
+            <a:fld id="{9FD35869-6CB4-418A-BE0D-1A41A5257976}" type="slidenum">
               <a:rPr lang="en-US" sz="1200" b="0" u="none" strike="noStrike">
                 <a:solidFill>
                   <a:schemeClr val="dk1"/>
@@ -721,7 +721,7 @@
               </a:lnSpc>
               <a:buNone/>
             </a:pPr>
-            <a:fld id="{8F90A1A1-5473-4D33-A413-977072E87A55}" type="slidenum">
+            <a:fld id="{CDC4A8B4-BF6A-4509-919A-E38EF5052671}" type="slidenum">
               <a:rPr lang="en-US" sz="1200" b="0" u="none" strike="noStrike">
                 <a:solidFill>
                   <a:schemeClr val="dk1"/>
@@ -896,7 +896,7 @@
               </a:lnSpc>
               <a:buNone/>
             </a:pPr>
-            <a:fld id="{C81B18A3-0E2F-447C-A63D-EB768D4EEB2A}" type="slidenum">
+            <a:fld id="{16749FA8-EE00-4D26-8C25-D0764B3695B3}" type="slidenum">
               <a:rPr lang="en-US" sz="1200" b="0" u="none" strike="noStrike">
                 <a:solidFill>
                   <a:schemeClr val="dk1"/>
@@ -1071,7 +1071,7 @@
               </a:lnSpc>
               <a:buNone/>
             </a:pPr>
-            <a:fld id="{682817FB-06C1-4914-8B41-DECDEB747E83}" type="slidenum">
+            <a:fld id="{3B6CD27F-C180-4B6E-8E50-88B0F46AA398}" type="slidenum">
               <a:rPr lang="en-US" sz="1200" b="0" u="none" strike="noStrike">
                 <a:solidFill>
                   <a:schemeClr val="dk1"/>
@@ -1246,7 +1246,7 @@
               </a:lnSpc>
               <a:buNone/>
             </a:pPr>
-            <a:fld id="{D0132C31-949C-4FF7-8B99-0E64B50FD419}" type="slidenum">
+            <a:fld id="{2BCCB119-9437-4461-BC75-D144B5A7FB26}" type="slidenum">
               <a:rPr lang="en-US" sz="1200" b="0" u="none" strike="noStrike">
                 <a:solidFill>
                   <a:schemeClr val="dk1"/>
@@ -1421,7 +1421,7 @@
               </a:lnSpc>
               <a:buNone/>
             </a:pPr>
-            <a:fld id="{44AF6C7F-BB52-42CD-80F1-934F88254591}" type="slidenum">
+            <a:fld id="{7A149BCA-5A57-4B62-A18E-CA23FFFA41B1}" type="slidenum">
               <a:rPr lang="en-US" sz="1200" b="0" u="none" strike="noStrike">
                 <a:solidFill>
                   <a:schemeClr val="dk1"/>
@@ -1596,7 +1596,7 @@
               </a:lnSpc>
               <a:buNone/>
             </a:pPr>
-            <a:fld id="{9BE72AC7-57CE-40B0-A155-593F5EAE36FE}" type="slidenum">
+            <a:fld id="{BDFE3680-BFC0-4BB4-A26F-F4F375682054}" type="slidenum">
               <a:rPr lang="en-US" sz="1200" b="0" u="none" strike="noStrike">
                 <a:solidFill>
                   <a:schemeClr val="dk1"/>
@@ -1771,7 +1771,7 @@
               </a:lnSpc>
               <a:buNone/>
             </a:pPr>
-            <a:fld id="{70AF7333-9676-42AF-8BC4-E7442F96A12D}" type="slidenum">
+            <a:fld id="{D31655A8-9136-4870-B6EE-B3826023D431}" type="slidenum">
               <a:rPr lang="en-US" sz="1200" b="0" u="none" strike="noStrike">
                 <a:solidFill>
                   <a:schemeClr val="dk1"/>

</xml_diff>

<commit_message>
Start Sprint L1.3A-C companion pilot
</commit_message>
<xml_diff>
--- a/Boek 1 - Grondslagen, vraag en aanbod/1.1 Hoofdstuk Economisch denken en rekenen/1.1.1 Schaarste en economisch denken/1.1.1 Schaarste en economisch denken – presentatie.pptx
+++ b/Boek 1 - Grondslagen, vraag en aanbod/1.1 Hoofdstuk Economisch denken en rekenen/1.1.1 Schaarste en economisch denken/1.1.1 Schaarste en economisch denken – presentatie.pptx
@@ -371,7 +371,7 @@
             <a:pPr indent="0" algn="r">
               <a:buNone/>
             </a:pPr>
-            <a:fld id="{B024595E-1BDD-4C05-87D3-43AE21B179DF}" type="slidenum">
+            <a:fld id="{5CCEF286-D073-45F6-BDD7-1CA01ED256A0}" type="slidenum">
               <a:rPr lang="en-US" sz="1400" b="0" u="none" strike="noStrike">
                 <a:solidFill>
                   <a:srgbClr val="000000"/>
@@ -546,7 +546,7 @@
               </a:lnSpc>
               <a:buNone/>
             </a:pPr>
-            <a:fld id="{9FD35869-6CB4-418A-BE0D-1A41A5257976}" type="slidenum">
+            <a:fld id="{57E760C7-3886-44D0-880D-4144BEDA6DA7}" type="slidenum">
               <a:rPr lang="en-US" sz="1200" b="0" u="none" strike="noStrike">
                 <a:solidFill>
                   <a:schemeClr val="dk1"/>
@@ -721,7 +721,7 @@
               </a:lnSpc>
               <a:buNone/>
             </a:pPr>
-            <a:fld id="{CDC4A8B4-BF6A-4509-919A-E38EF5052671}" type="slidenum">
+            <a:fld id="{A067D3F6-440E-45C7-8563-6C55C7C985C9}" type="slidenum">
               <a:rPr lang="en-US" sz="1200" b="0" u="none" strike="noStrike">
                 <a:solidFill>
                   <a:schemeClr val="dk1"/>
@@ -896,7 +896,7 @@
               </a:lnSpc>
               <a:buNone/>
             </a:pPr>
-            <a:fld id="{16749FA8-EE00-4D26-8C25-D0764B3695B3}" type="slidenum">
+            <a:fld id="{C61CAD27-887F-43B2-94DD-7027C95FFDB2}" type="slidenum">
               <a:rPr lang="en-US" sz="1200" b="0" u="none" strike="noStrike">
                 <a:solidFill>
                   <a:schemeClr val="dk1"/>
@@ -1071,7 +1071,7 @@
               </a:lnSpc>
               <a:buNone/>
             </a:pPr>
-            <a:fld id="{3B6CD27F-C180-4B6E-8E50-88B0F46AA398}" type="slidenum">
+            <a:fld id="{2BE5053D-5289-4547-845D-BEF1872CC72B}" type="slidenum">
               <a:rPr lang="en-US" sz="1200" b="0" u="none" strike="noStrike">
                 <a:solidFill>
                   <a:schemeClr val="dk1"/>
@@ -1246,7 +1246,7 @@
               </a:lnSpc>
               <a:buNone/>
             </a:pPr>
-            <a:fld id="{2BCCB119-9437-4461-BC75-D144B5A7FB26}" type="slidenum">
+            <a:fld id="{F3DE6840-B562-43C5-9977-08EAAB4D64A7}" type="slidenum">
               <a:rPr lang="en-US" sz="1200" b="0" u="none" strike="noStrike">
                 <a:solidFill>
                   <a:schemeClr val="dk1"/>
@@ -1421,7 +1421,7 @@
               </a:lnSpc>
               <a:buNone/>
             </a:pPr>
-            <a:fld id="{7A149BCA-5A57-4B62-A18E-CA23FFFA41B1}" type="slidenum">
+            <a:fld id="{F587CB94-8E92-4AB9-89E3-E4E07B5E88D5}" type="slidenum">
               <a:rPr lang="en-US" sz="1200" b="0" u="none" strike="noStrike">
                 <a:solidFill>
                   <a:schemeClr val="dk1"/>
@@ -1596,7 +1596,7 @@
               </a:lnSpc>
               <a:buNone/>
             </a:pPr>
-            <a:fld id="{BDFE3680-BFC0-4BB4-A26F-F4F375682054}" type="slidenum">
+            <a:fld id="{049A27B0-C432-49EF-8671-6A15CFE8803C}" type="slidenum">
               <a:rPr lang="en-US" sz="1200" b="0" u="none" strike="noStrike">
                 <a:solidFill>
                   <a:schemeClr val="dk1"/>
@@ -1771,7 +1771,7 @@
               </a:lnSpc>
               <a:buNone/>
             </a:pPr>
-            <a:fld id="{D31655A8-9136-4870-B6EE-B3826023D431}" type="slidenum">
+            <a:fld id="{51C9EE46-C293-4D2D-9CCC-E3DE974000F4}" type="slidenum">
               <a:rPr lang="en-US" sz="1200" b="0" u="none" strike="noStrike">
                 <a:solidFill>
                   <a:schemeClr val="dk1"/>

</xml_diff>

<commit_message>
content(1.1.1): regenerated presentatie.pptx with meaningful alt-text on 5 slide pictures
All slide pictures now carry meaningful Dutch alt-text (descr) sourced
from the canonical b1-111-alt-text registry — fig_1 on S3, fig_2 on S4,
fig_3 on S5, we_1 on S6 and S7. Closes the slide alt-text gap that
L1.5V A4 explicitly deferred; pre-condition for L1.5D D2 (PPTX-as-web).
Built by platform commit on b1-111-presentatie.js.

Co-Authored-By: Claude Opus 4.7 (1M context) <noreply@anthropic.com>
</commit_message>
<xml_diff>
--- a/Boek 1 - Grondslagen, vraag en aanbod/1.1 Hoofdstuk Economisch denken en rekenen/1.1.1 Schaarste en economisch denken/1.1.1 Schaarste en economisch denken – presentatie.pptx
+++ b/Boek 1 - Grondslagen, vraag en aanbod/1.1 Hoofdstuk Economisch denken en rekenen/1.1.1 Schaarste en economisch denken/1.1.1 Schaarste en economisch denken – presentatie.pptx
@@ -372,7 +372,7 @@
             <a:pPr indent="0" algn="r">
               <a:buNone/>
             </a:pPr>
-            <a:fld id="{3529A6A4-20A6-48E2-B37B-5F601BB016A8}" type="slidenum">
+            <a:fld id="{B0D31928-26E1-4EC2-8472-29FECA61F995}" type="slidenum">
               <a:rPr lang="en-US" sz="1400" b="0" u="none" strike="noStrike">
                 <a:solidFill>
                   <a:srgbClr val="000000"/>
@@ -619,7 +619,7 @@
               </a:lnSpc>
               <a:buNone/>
             </a:pPr>
-            <a:fld id="{E38FA1E1-3E63-46D6-AE44-127D9AA571BD}" type="slidenum">
+            <a:fld id="{82BBBA0D-FACA-458E-940F-B69ABB5FE045}" type="slidenum">
               <a:rPr lang="en-US" sz="1200" b="0" u="none" strike="noStrike">
                 <a:solidFill>
                   <a:schemeClr val="dk1"/>
@@ -866,7 +866,7 @@
               </a:lnSpc>
               <a:buNone/>
             </a:pPr>
-            <a:fld id="{B63AA1B8-CAAA-44FF-801D-DCD57F22DE47}" type="slidenum">
+            <a:fld id="{60724216-13F7-4F38-8825-FBB42C3A1012}" type="slidenum">
               <a:rPr lang="en-US" sz="1200" b="0" u="none" strike="noStrike">
                 <a:solidFill>
                   <a:schemeClr val="dk1"/>
@@ -1185,7 +1185,7 @@
               </a:lnSpc>
               <a:buNone/>
             </a:pPr>
-            <a:fld id="{0BC5A08A-DBD7-42FE-9EEC-9C84C845EC74}" type="slidenum">
+            <a:fld id="{8303A28C-F270-4818-BC68-FE085444DA89}" type="slidenum">
               <a:rPr lang="en-US" sz="1200" b="0" u="none" strike="noStrike">
                 <a:solidFill>
                   <a:schemeClr val="dk1"/>
@@ -1528,7 +1528,7 @@
               </a:lnSpc>
               <a:buNone/>
             </a:pPr>
-            <a:fld id="{AD150191-FA73-446B-983A-8153F732B0F0}" type="slidenum">
+            <a:fld id="{FD2FD34E-258C-4819-B30B-C0C49F47787F}" type="slidenum">
               <a:rPr lang="en-US" sz="1200" b="0" u="none" strike="noStrike">
                 <a:solidFill>
                   <a:schemeClr val="dk1"/>
@@ -1775,7 +1775,7 @@
               </a:lnSpc>
               <a:buNone/>
             </a:pPr>
-            <a:fld id="{1F5D9F12-1053-4B69-8B9D-2023FFBE41D7}" type="slidenum">
+            <a:fld id="{563CA921-AD97-4DBC-8FA1-46195E718DF4}" type="slidenum">
               <a:rPr lang="en-US" sz="1200" b="0" u="none" strike="noStrike">
                 <a:solidFill>
                   <a:schemeClr val="dk1"/>
@@ -2022,7 +2022,7 @@
               </a:lnSpc>
               <a:buNone/>
             </a:pPr>
-            <a:fld id="{872780B4-1F02-4AA4-92EE-8A5EA5C1B81F}" type="slidenum">
+            <a:fld id="{CCB7179C-7758-45C7-B4CD-CF04D6D8A735}" type="slidenum">
               <a:rPr lang="en-US" sz="1200" b="0" u="none" strike="noStrike">
                 <a:solidFill>
                   <a:schemeClr val="dk1"/>
@@ -2293,7 +2293,7 @@
               </a:lnSpc>
               <a:buNone/>
             </a:pPr>
-            <a:fld id="{B50537FF-01D5-4A89-A93F-469335DEE2D0}" type="slidenum">
+            <a:fld id="{F43DEABA-273A-49DA-A1C7-635AC943EFCD}" type="slidenum">
               <a:rPr lang="en-US" sz="1200" b="0" u="none" strike="noStrike">
                 <a:solidFill>
                   <a:schemeClr val="dk1"/>
@@ -2540,7 +2540,7 @@
               </a:lnSpc>
               <a:buNone/>
             </a:pPr>
-            <a:fld id="{80322659-FB1A-4443-87A0-1B2E20374500}" type="slidenum">
+            <a:fld id="{9C6A8071-AF93-43A1-994E-7C5C25489AD8}" type="slidenum">
               <a:rPr lang="en-US" sz="1200" b="0" u="none" strike="noStrike">
                 <a:solidFill>
                   <a:schemeClr val="dk1"/>
@@ -2787,7 +2787,7 @@
               </a:lnSpc>
               <a:buNone/>
             </a:pPr>
-            <a:fld id="{2FA6EEEF-0B1C-4321-97BC-FCD8F12D066E}" type="slidenum">
+            <a:fld id="{19FF319A-CE97-4B28-8BB6-716EB5FC284E}" type="slidenum">
               <a:rPr lang="en-US" sz="1200" b="0" u="none" strike="noStrike">
                 <a:solidFill>
                   <a:schemeClr val="dk1"/>
@@ -5780,7 +5780,7 @@
       </p:sp>
       <p:pic>
         <p:nvPicPr>
-          <p:cNvPr id="45" name="Image 0" descr="preencoded.png"/>
+          <p:cNvPr id="45" name="Image 0" descr="Infographic: brede behoeften-trechter (zakgeld, vrije tijd, ruimte, aandacht) loopt door een schaarste-filter naar een smal keuze-uitstroompunt — illustreert dat behoeften groter zijn dan beschikbare middelen."/>
           <p:cNvPicPr/>
           <p:nvPr/>
         </p:nvPicPr>
@@ -6103,7 +6103,7 @@
       </p:sp>
       <p:pic>
         <p:nvPicPr>
-          <p:cNvPr id="51" name="Image 0" descr="preencoded.png"/>
+          <p:cNvPr id="51" name="Image 0" descr="Keuzediagram met twee alternatieven naast elkaar; de gekozen optie levert de opbrengst, het beste niet-gekozen alternatief wordt aangewezen als de alternatieve kosten."/>
           <p:cNvPicPr/>
           <p:nvPr/>
         </p:nvPicPr>
@@ -7367,7 +7367,7 @@
       </p:sp>
       <p:pic>
         <p:nvPicPr>
-          <p:cNvPr id="74" name="Image 0" descr="preencoded.png"/>
+          <p:cNvPr id="74" name="Image 0" descr="Flowchart van de vier stappen om alternatieve kosten en nettowaarde te bepalen: (1) alternatieven benoemen, (2) opbrengst per alternatief berekenen, (3) beste niet-gekozen alternatief = alternatieve kosten, (4) nettowaarde = opbrengst gekozen min alternatieve kosten."/>
           <p:cNvPicPr/>
           <p:nvPr/>
         </p:nvPicPr>
@@ -8478,7 +8478,7 @@
       </p:sp>
       <p:pic>
         <p:nvPicPr>
-          <p:cNvPr id="94" name="Image 0" descr="preencoded.png"/>
+          <p:cNvPr id="94" name="Image 0" descr="Uitgewerkt voorbeeld tarwe versus maïs op 10 hectare: tarwe levert €500 per hectare op (totaal €5.000), maïs €350 per hectare (totaal €3.500); de alternatieve kosten van tarwe kiezen zijn €3.500 en de nettowaarde €1.500."/>
           <p:cNvPicPr/>
           <p:nvPr/>
         </p:nvPicPr>
@@ -8923,7 +8923,7 @@
       </p:sp>
       <p:pic>
         <p:nvPicPr>
-          <p:cNvPr id="102" name="Image 0" descr="preencoded.png"/>
+          <p:cNvPr id="102" name="Image 0" descr="Uitgewerkt voorbeeld tarwe versus maïs op 10 hectare: tarwe levert €500 per hectare op (totaal €5.000), maïs €350 per hectare (totaal €3.500); de alternatieve kosten van tarwe kiezen zijn €3.500 en de nettowaarde €1.500."/>
           <p:cNvPicPr/>
           <p:nvPr/>
         </p:nvPicPr>

</xml_diff>

<commit_message>
content(1.1.1): regenerated presentatie.pptx with B8 accessibility fixes
Built by platform B8 commit. Audit confirms 0 runs below 14pt, 0
explicit contrast violations. Speaker notes uniformly at 14pt across
all 9 notesSlide files.

Co-Authored-By: Claude Opus 4.7 (1M context) <noreply@anthropic.com>
</commit_message>
<xml_diff>
--- a/Boek 1 - Grondslagen, vraag en aanbod/1.1 Hoofdstuk Economisch denken en rekenen/1.1.1 Schaarste en economisch denken/1.1.1 Schaarste en economisch denken – presentatie.pptx
+++ b/Boek 1 - Grondslagen, vraag en aanbod/1.1 Hoofdstuk Economisch denken en rekenen/1.1.1 Schaarste en economisch denken/1.1.1 Schaarste en economisch denken – presentatie.pptx
@@ -372,7 +372,7 @@
             <a:pPr indent="0" algn="r">
               <a:buNone/>
             </a:pPr>
-            <a:fld id="{B0D31928-26E1-4EC2-8472-29FECA61F995}" type="slidenum">
+            <a:fld id="{5EF2FF7F-9CA6-416B-9F24-D18A1174E12C}" type="slidenum">
               <a:rPr lang="en-US" sz="1400" b="0" u="none" strike="noStrike">
                 <a:solidFill>
                   <a:srgbClr val="000000"/>
@@ -472,7 +472,7 @@
               <a:buNone/>
             </a:pPr>
             <a:r>
-              <a:rPr lang="en-US" sz="2000" b="0" u="none" strike="noStrike">
+              <a:rPr lang="en-US" sz="1400" b="0" u="none" strike="noStrike">
                 <a:solidFill>
                   <a:srgbClr val="000000"/>
                 </a:solidFill>
@@ -496,7 +496,7 @@
               <a:buNone/>
             </a:pPr>
             <a:r>
-              <a:rPr lang="en-US" sz="2000" b="0" u="none" strike="noStrike">
+              <a:rPr lang="en-US" sz="1400" b="0" u="none" strike="noStrike">
                 <a:solidFill>
                   <a:srgbClr val="000000"/>
                 </a:solidFill>
@@ -520,7 +520,7 @@
               <a:buNone/>
             </a:pPr>
             <a:r>
-              <a:rPr lang="en-US" sz="2000" b="0" u="none" strike="noStrike">
+              <a:rPr lang="en-US" sz="1400" b="0" u="none" strike="noStrike">
                 <a:solidFill>
                   <a:srgbClr val="000000"/>
                 </a:solidFill>
@@ -547,7 +547,7 @@
               <a:buNone/>
             </a:pPr>
             <a:r>
-              <a:rPr lang="en-US" sz="2000" b="0" u="none" strike="noStrike">
+              <a:rPr lang="en-US" sz="1400" b="0" u="none" strike="noStrike">
                 <a:solidFill>
                   <a:srgbClr val="000000"/>
                 </a:solidFill>
@@ -619,8 +619,8 @@
               </a:lnSpc>
               <a:buNone/>
             </a:pPr>
-            <a:fld id="{82BBBA0D-FACA-458E-940F-B69ABB5FE045}" type="slidenum">
-              <a:rPr lang="en-US" sz="1200" b="0" u="none" strike="noStrike">
+            <a:fld id="{7B7B47FD-7F08-4AB1-9043-CB66140F82E2}" type="slidenum">
+              <a:rPr lang="en-US" sz="1400" b="0" u="none" strike="noStrike">
                 <a:solidFill>
                   <a:schemeClr val="dk1"/>
                 </a:solidFill>
@@ -719,7 +719,7 @@
               <a:buNone/>
             </a:pPr>
             <a:r>
-              <a:rPr lang="en-US" sz="2000" b="0" u="none" strike="noStrike">
+              <a:rPr lang="en-US" sz="1400" b="0" u="none" strike="noStrike">
                 <a:solidFill>
                   <a:srgbClr val="000000"/>
                 </a:solidFill>
@@ -743,7 +743,7 @@
               <a:buNone/>
             </a:pPr>
             <a:r>
-              <a:rPr lang="en-US" sz="2000" b="0" u="none" strike="noStrike">
+              <a:rPr lang="en-US" sz="1400" b="0" u="none" strike="noStrike">
                 <a:solidFill>
                   <a:srgbClr val="000000"/>
                 </a:solidFill>
@@ -767,7 +767,7 @@
               <a:buNone/>
             </a:pPr>
             <a:r>
-              <a:rPr lang="en-US" sz="2000" b="0" u="none" strike="noStrike">
+              <a:rPr lang="en-US" sz="1400" b="0" u="none" strike="noStrike">
                 <a:solidFill>
                   <a:srgbClr val="000000"/>
                 </a:solidFill>
@@ -794,7 +794,7 @@
               <a:buNone/>
             </a:pPr>
             <a:r>
-              <a:rPr lang="en-US" sz="2000" b="0" u="none" strike="noStrike">
+              <a:rPr lang="en-US" sz="1400" b="0" u="none" strike="noStrike">
                 <a:solidFill>
                   <a:srgbClr val="000000"/>
                 </a:solidFill>
@@ -866,8 +866,8 @@
               </a:lnSpc>
               <a:buNone/>
             </a:pPr>
-            <a:fld id="{60724216-13F7-4F38-8825-FBB42C3A1012}" type="slidenum">
-              <a:rPr lang="en-US" sz="1200" b="0" u="none" strike="noStrike">
+            <a:fld id="{3B0993E3-08CA-4A28-9262-EAA5E2985867}" type="slidenum">
+              <a:rPr lang="en-US" sz="1400" b="0" u="none" strike="noStrike">
                 <a:solidFill>
                   <a:schemeClr val="dk1"/>
                 </a:solidFill>
@@ -966,7 +966,7 @@
               <a:buNone/>
             </a:pPr>
             <a:r>
-              <a:rPr lang="en-US" sz="2000" b="0" u="none" strike="noStrike">
+              <a:rPr lang="en-US" sz="1400" b="0" u="none" strike="noStrike">
                 <a:solidFill>
                   <a:srgbClr val="000000"/>
                 </a:solidFill>
@@ -990,7 +990,7 @@
               <a:buNone/>
             </a:pPr>
             <a:r>
-              <a:rPr lang="en-US" sz="2000" b="0" u="none" strike="noStrike">
+              <a:rPr lang="en-US" sz="1400" b="0" u="none" strike="noStrike">
                 <a:solidFill>
                   <a:srgbClr val="000000"/>
                 </a:solidFill>
@@ -1014,7 +1014,7 @@
               <a:buNone/>
             </a:pPr>
             <a:r>
-              <a:rPr lang="en-US" sz="2000" b="0" u="none" strike="noStrike">
+              <a:rPr lang="en-US" sz="1400" b="0" u="none" strike="noStrike">
                 <a:solidFill>
                   <a:srgbClr val="000000"/>
                 </a:solidFill>
@@ -1038,7 +1038,7 @@
               <a:buNone/>
             </a:pPr>
             <a:r>
-              <a:rPr lang="en-US" sz="2000" b="0" u="none" strike="noStrike">
+              <a:rPr lang="en-US" sz="1400" b="0" u="none" strike="noStrike">
                 <a:solidFill>
                   <a:srgbClr val="000000"/>
                 </a:solidFill>
@@ -1062,7 +1062,7 @@
               <a:buNone/>
             </a:pPr>
             <a:r>
-              <a:rPr lang="en-US" sz="2000" b="0" u="none" strike="noStrike">
+              <a:rPr lang="en-US" sz="1400" b="0" u="none" strike="noStrike">
                 <a:solidFill>
                   <a:srgbClr val="000000"/>
                 </a:solidFill>
@@ -1086,7 +1086,7 @@
               <a:buNone/>
             </a:pPr>
             <a:r>
-              <a:rPr lang="en-US" sz="2000" b="0" u="none" strike="noStrike">
+              <a:rPr lang="en-US" sz="1400" b="0" u="none" strike="noStrike">
                 <a:solidFill>
                   <a:srgbClr val="000000"/>
                 </a:solidFill>
@@ -1113,7 +1113,7 @@
               <a:buNone/>
             </a:pPr>
             <a:r>
-              <a:rPr lang="en-US" sz="2000" b="0" u="none" strike="noStrike">
+              <a:rPr lang="en-US" sz="1400" b="0" u="none" strike="noStrike">
                 <a:solidFill>
                   <a:srgbClr val="000000"/>
                 </a:solidFill>
@@ -1185,8 +1185,8 @@
               </a:lnSpc>
               <a:buNone/>
             </a:pPr>
-            <a:fld id="{8303A28C-F270-4818-BC68-FE085444DA89}" type="slidenum">
-              <a:rPr lang="en-US" sz="1200" b="0" u="none" strike="noStrike">
+            <a:fld id="{2938FC43-80E8-480A-AEE9-7C7BC96597D9}" type="slidenum">
+              <a:rPr lang="en-US" sz="1400" b="0" u="none" strike="noStrike">
                 <a:solidFill>
                   <a:schemeClr val="dk1"/>
                 </a:solidFill>
@@ -1285,7 +1285,7 @@
               <a:buNone/>
             </a:pPr>
             <a:r>
-              <a:rPr lang="en-US" sz="2000" b="0" u="none" strike="noStrike">
+              <a:rPr lang="en-US" sz="1400" b="0" u="none" strike="noStrike">
                 <a:solidFill>
                   <a:srgbClr val="000000"/>
                 </a:solidFill>
@@ -1309,7 +1309,7 @@
               <a:buNone/>
             </a:pPr>
             <a:r>
-              <a:rPr lang="en-US" sz="2000" b="0" u="none" strike="noStrike">
+              <a:rPr lang="en-US" sz="1400" b="0" u="none" strike="noStrike">
                 <a:solidFill>
                   <a:srgbClr val="000000"/>
                 </a:solidFill>
@@ -1333,7 +1333,7 @@
               <a:buNone/>
             </a:pPr>
             <a:r>
-              <a:rPr lang="en-US" sz="2000" b="0" u="none" strike="noStrike">
+              <a:rPr lang="en-US" sz="1400" b="0" u="none" strike="noStrike">
                 <a:solidFill>
                   <a:srgbClr val="000000"/>
                 </a:solidFill>
@@ -1357,7 +1357,7 @@
               <a:buNone/>
             </a:pPr>
             <a:r>
-              <a:rPr lang="en-US" sz="2000" b="0" u="none" strike="noStrike">
+              <a:rPr lang="en-US" sz="1400" b="0" u="none" strike="noStrike">
                 <a:solidFill>
                   <a:srgbClr val="000000"/>
                 </a:solidFill>
@@ -1381,7 +1381,7 @@
               <a:buNone/>
             </a:pPr>
             <a:r>
-              <a:rPr lang="en-US" sz="2000" b="0" u="none" strike="noStrike">
+              <a:rPr lang="en-US" sz="1400" b="0" u="none" strike="noStrike">
                 <a:solidFill>
                   <a:srgbClr val="000000"/>
                 </a:solidFill>
@@ -1405,7 +1405,7 @@
               <a:buNone/>
             </a:pPr>
             <a:r>
-              <a:rPr lang="en-US" sz="2000" b="0" u="none" strike="noStrike">
+              <a:rPr lang="en-US" sz="1400" b="0" u="none" strike="noStrike">
                 <a:solidFill>
                   <a:srgbClr val="000000"/>
                 </a:solidFill>
@@ -1429,7 +1429,7 @@
               <a:buNone/>
             </a:pPr>
             <a:r>
-              <a:rPr lang="en-US" sz="2000" b="0" u="none" strike="noStrike">
+              <a:rPr lang="en-US" sz="1400" b="0" u="none" strike="noStrike">
                 <a:solidFill>
                   <a:srgbClr val="000000"/>
                 </a:solidFill>
@@ -1456,7 +1456,7 @@
               <a:buNone/>
             </a:pPr>
             <a:r>
-              <a:rPr lang="en-US" sz="2000" b="0" u="none" strike="noStrike">
+              <a:rPr lang="en-US" sz="1400" b="0" u="none" strike="noStrike">
                 <a:solidFill>
                   <a:srgbClr val="000000"/>
                 </a:solidFill>
@@ -1528,8 +1528,8 @@
               </a:lnSpc>
               <a:buNone/>
             </a:pPr>
-            <a:fld id="{FD2FD34E-258C-4819-B30B-C0C49F47787F}" type="slidenum">
-              <a:rPr lang="en-US" sz="1200" b="0" u="none" strike="noStrike">
+            <a:fld id="{46E6AAB7-6B70-47EE-B0D4-9030B95D7A9C}" type="slidenum">
+              <a:rPr lang="en-US" sz="1400" b="0" u="none" strike="noStrike">
                 <a:solidFill>
                   <a:schemeClr val="dk1"/>
                 </a:solidFill>
@@ -1628,7 +1628,7 @@
               <a:buNone/>
             </a:pPr>
             <a:r>
-              <a:rPr lang="en-US" sz="2000" b="0" u="none" strike="noStrike">
+              <a:rPr lang="en-US" sz="1400" b="0" u="none" strike="noStrike">
                 <a:solidFill>
                   <a:srgbClr val="000000"/>
                 </a:solidFill>
@@ -1652,7 +1652,7 @@
               <a:buNone/>
             </a:pPr>
             <a:r>
-              <a:rPr lang="en-US" sz="2000" b="0" u="none" strike="noStrike">
+              <a:rPr lang="en-US" sz="1400" b="0" u="none" strike="noStrike">
                 <a:solidFill>
                   <a:srgbClr val="000000"/>
                 </a:solidFill>
@@ -1676,7 +1676,7 @@
               <a:buNone/>
             </a:pPr>
             <a:r>
-              <a:rPr lang="en-US" sz="2000" b="0" u="none" strike="noStrike">
+              <a:rPr lang="en-US" sz="1400" b="0" u="none" strike="noStrike">
                 <a:solidFill>
                   <a:srgbClr val="000000"/>
                 </a:solidFill>
@@ -1703,7 +1703,7 @@
               <a:buNone/>
             </a:pPr>
             <a:r>
-              <a:rPr lang="en-US" sz="2000" b="0" u="none" strike="noStrike">
+              <a:rPr lang="en-US" sz="1400" b="0" u="none" strike="noStrike">
                 <a:solidFill>
                   <a:srgbClr val="000000"/>
                 </a:solidFill>
@@ -1775,8 +1775,8 @@
               </a:lnSpc>
               <a:buNone/>
             </a:pPr>
-            <a:fld id="{563CA921-AD97-4DBC-8FA1-46195E718DF4}" type="slidenum">
-              <a:rPr lang="en-US" sz="1200" b="0" u="none" strike="noStrike">
+            <a:fld id="{8A481C97-5AEA-441F-87E7-A692BD379B71}" type="slidenum">
+              <a:rPr lang="en-US" sz="1400" b="0" u="none" strike="noStrike">
                 <a:solidFill>
                   <a:schemeClr val="dk1"/>
                 </a:solidFill>
@@ -1875,7 +1875,7 @@
               <a:buNone/>
             </a:pPr>
             <a:r>
-              <a:rPr lang="en-US" sz="2000" b="0" u="none" strike="noStrike">
+              <a:rPr lang="en-US" sz="1400" b="0" u="none" strike="noStrike">
                 <a:solidFill>
                   <a:srgbClr val="000000"/>
                 </a:solidFill>
@@ -1899,7 +1899,7 @@
               <a:buNone/>
             </a:pPr>
             <a:r>
-              <a:rPr lang="en-US" sz="2000" b="0" u="none" strike="noStrike">
+              <a:rPr lang="en-US" sz="1400" b="0" u="none" strike="noStrike">
                 <a:solidFill>
                   <a:srgbClr val="000000"/>
                 </a:solidFill>
@@ -1923,7 +1923,7 @@
               <a:buNone/>
             </a:pPr>
             <a:r>
-              <a:rPr lang="en-US" sz="2000" b="0" u="none" strike="noStrike">
+              <a:rPr lang="en-US" sz="1400" b="0" u="none" strike="noStrike">
                 <a:solidFill>
                   <a:srgbClr val="000000"/>
                 </a:solidFill>
@@ -1950,7 +1950,7 @@
               <a:buNone/>
             </a:pPr>
             <a:r>
-              <a:rPr lang="en-US" sz="2000" b="0" u="none" strike="noStrike">
+              <a:rPr lang="en-US" sz="1400" b="0" u="none" strike="noStrike">
                 <a:solidFill>
                   <a:srgbClr val="000000"/>
                 </a:solidFill>
@@ -2022,8 +2022,8 @@
               </a:lnSpc>
               <a:buNone/>
             </a:pPr>
-            <a:fld id="{CCB7179C-7758-45C7-B4CD-CF04D6D8A735}" type="slidenum">
-              <a:rPr lang="en-US" sz="1200" b="0" u="none" strike="noStrike">
+            <a:fld id="{529A6605-2952-464D-800D-1D9B4CD13AAB}" type="slidenum">
+              <a:rPr lang="en-US" sz="1400" b="0" u="none" strike="noStrike">
                 <a:solidFill>
                   <a:schemeClr val="dk1"/>
                 </a:solidFill>
@@ -2122,7 +2122,7 @@
               <a:buNone/>
             </a:pPr>
             <a:r>
-              <a:rPr lang="en-US" sz="2000" b="0" u="none" strike="noStrike">
+              <a:rPr lang="en-US" sz="1400" b="0" u="none" strike="noStrike">
                 <a:solidFill>
                   <a:srgbClr val="000000"/>
                 </a:solidFill>
@@ -2146,7 +2146,7 @@
               <a:buNone/>
             </a:pPr>
             <a:r>
-              <a:rPr lang="en-US" sz="2000" b="0" u="none" strike="noStrike">
+              <a:rPr lang="en-US" sz="1400" b="0" u="none" strike="noStrike">
                 <a:solidFill>
                   <a:srgbClr val="000000"/>
                 </a:solidFill>
@@ -2170,7 +2170,7 @@
               <a:buNone/>
             </a:pPr>
             <a:r>
-              <a:rPr lang="en-US" sz="2000" b="0" u="none" strike="noStrike">
+              <a:rPr lang="en-US" sz="1400" b="0" u="none" strike="noStrike">
                 <a:solidFill>
                   <a:srgbClr val="000000"/>
                 </a:solidFill>
@@ -2194,7 +2194,7 @@
               <a:buNone/>
             </a:pPr>
             <a:r>
-              <a:rPr lang="en-US" sz="2000" b="0" u="none" strike="noStrike">
+              <a:rPr lang="en-US" sz="1400" b="0" u="none" strike="noStrike">
                 <a:solidFill>
                   <a:srgbClr val="000000"/>
                 </a:solidFill>
@@ -2221,7 +2221,7 @@
               <a:buNone/>
             </a:pPr>
             <a:r>
-              <a:rPr lang="en-US" sz="2000" b="0" u="none" strike="noStrike">
+              <a:rPr lang="en-US" sz="1400" b="0" u="none" strike="noStrike">
                 <a:solidFill>
                   <a:srgbClr val="000000"/>
                 </a:solidFill>
@@ -2293,8 +2293,8 @@
               </a:lnSpc>
               <a:buNone/>
             </a:pPr>
-            <a:fld id="{F43DEABA-273A-49DA-A1C7-635AC943EFCD}" type="slidenum">
-              <a:rPr lang="en-US" sz="1200" b="0" u="none" strike="noStrike">
+            <a:fld id="{BACF90C4-5773-46DA-A27C-B69D8966C2E6}" type="slidenum">
+              <a:rPr lang="en-US" sz="1400" b="0" u="none" strike="noStrike">
                 <a:solidFill>
                   <a:schemeClr val="dk1"/>
                 </a:solidFill>
@@ -2393,7 +2393,7 @@
               <a:buNone/>
             </a:pPr>
             <a:r>
-              <a:rPr lang="en-US" sz="2000" b="0" u="none" strike="noStrike">
+              <a:rPr lang="en-US" sz="1400" b="0" u="none" strike="noStrike">
                 <a:solidFill>
                   <a:srgbClr val="000000"/>
                 </a:solidFill>
@@ -2417,7 +2417,7 @@
               <a:buNone/>
             </a:pPr>
             <a:r>
-              <a:rPr lang="en-US" sz="2000" b="0" u="none" strike="noStrike">
+              <a:rPr lang="en-US" sz="1400" b="0" u="none" strike="noStrike">
                 <a:solidFill>
                   <a:srgbClr val="000000"/>
                 </a:solidFill>
@@ -2441,7 +2441,7 @@
               <a:buNone/>
             </a:pPr>
             <a:r>
-              <a:rPr lang="en-US" sz="2000" b="0" u="none" strike="noStrike">
+              <a:rPr lang="en-US" sz="1400" b="0" u="none" strike="noStrike">
                 <a:solidFill>
                   <a:srgbClr val="000000"/>
                 </a:solidFill>
@@ -2468,7 +2468,7 @@
               <a:buNone/>
             </a:pPr>
             <a:r>
-              <a:rPr lang="en-US" sz="2000" b="0" u="none" strike="noStrike">
+              <a:rPr lang="en-US" sz="1400" b="0" u="none" strike="noStrike">
                 <a:solidFill>
                   <a:srgbClr val="000000"/>
                 </a:solidFill>
@@ -2540,8 +2540,8 @@
               </a:lnSpc>
               <a:buNone/>
             </a:pPr>
-            <a:fld id="{9C6A8071-AF93-43A1-994E-7C5C25489AD8}" type="slidenum">
-              <a:rPr lang="en-US" sz="1200" b="0" u="none" strike="noStrike">
+            <a:fld id="{30144A15-205D-4C99-B457-DF9630D20145}" type="slidenum">
+              <a:rPr lang="en-US" sz="1400" b="0" u="none" strike="noStrike">
                 <a:solidFill>
                   <a:schemeClr val="dk1"/>
                 </a:solidFill>
@@ -2640,7 +2640,7 @@
               <a:buNone/>
             </a:pPr>
             <a:r>
-              <a:rPr lang="en-US" sz="2000" b="0" u="none" strike="noStrike">
+              <a:rPr lang="en-US" sz="1400" b="0" u="none" strike="noStrike">
                 <a:solidFill>
                   <a:srgbClr val="000000"/>
                 </a:solidFill>
@@ -2664,7 +2664,7 @@
               <a:buNone/>
             </a:pPr>
             <a:r>
-              <a:rPr lang="en-US" sz="2000" b="0" u="none" strike="noStrike">
+              <a:rPr lang="en-US" sz="1400" b="0" u="none" strike="noStrike">
                 <a:solidFill>
                   <a:srgbClr val="000000"/>
                 </a:solidFill>
@@ -2688,7 +2688,7 @@
               <a:buNone/>
             </a:pPr>
             <a:r>
-              <a:rPr lang="en-US" sz="2000" b="0" u="none" strike="noStrike">
+              <a:rPr lang="en-US" sz="1400" b="0" u="none" strike="noStrike">
                 <a:solidFill>
                   <a:srgbClr val="000000"/>
                 </a:solidFill>
@@ -2715,7 +2715,7 @@
               <a:buNone/>
             </a:pPr>
             <a:r>
-              <a:rPr lang="en-US" sz="2000" b="0" u="none" strike="noStrike">
+              <a:rPr lang="en-US" sz="1400" b="0" u="none" strike="noStrike">
                 <a:solidFill>
                   <a:srgbClr val="000000"/>
                 </a:solidFill>
@@ -2787,8 +2787,8 @@
               </a:lnSpc>
               <a:buNone/>
             </a:pPr>
-            <a:fld id="{19FF319A-CE97-4B28-8BB6-716EB5FC284E}" type="slidenum">
-              <a:rPr lang="en-US" sz="1200" b="0" u="none" strike="noStrike">
+            <a:fld id="{9B9E917E-42D8-42DE-9FF9-2A6E5959FFA5}" type="slidenum">
+              <a:rPr lang="en-US" sz="1400" b="0" u="none" strike="noStrike">
                 <a:solidFill>
                   <a:schemeClr val="dk1"/>
                 </a:solidFill>
@@ -2950,9 +2950,9 @@
               </a:tabLst>
             </a:pPr>
             <a:r>
-              <a:rPr lang="en-US" sz="900" b="1" u="none" spc="400" strike="noStrike">
-                <a:solidFill>
-                  <a:srgbClr val="3A4F7F"/>
+              <a:rPr lang="en-US" sz="1200" b="1" u="none" spc="400" strike="noStrike">
+                <a:solidFill>
+                  <a:srgbClr val="D4D1CA"/>
                 </a:solidFill>
                 <a:effectLst/>
                 <a:uFillTx/>
@@ -2961,7 +2961,7 @@
               </a:rPr>
               <a:t>PARAGRAAF  ·  §1.1.1</a:t>
             </a:r>
-            <a:endParaRPr lang="en-US" sz="900" b="0" u="none" strike="noStrike">
+            <a:endParaRPr lang="en-US" sz="1200" b="0" u="none" strike="noStrike">
               <a:solidFill>
                 <a:srgbClr val="FFFFFF"/>
               </a:solidFill>
@@ -3537,9 +3537,9 @@
               </a:tabLst>
             </a:pPr>
             <a:r>
-              <a:rPr lang="en-US" sz="900" b="1" u="none" spc="300" strike="noStrike">
-                <a:solidFill>
-                  <a:srgbClr val="8B8779"/>
+              <a:rPr lang="en-US" sz="1200" b="1" u="none" spc="300" strike="noStrike">
+                <a:solidFill>
+                  <a:srgbClr val="2D3748"/>
                 </a:solidFill>
                 <a:effectLst/>
                 <a:uFillTx/>
@@ -3548,7 +3548,7 @@
               </a:rPr>
               <a:t>§ 1.1.1  ·  SCHAARSTE EN ECONOMISCH DENKEN</a:t>
             </a:r>
-            <a:endParaRPr lang="en-US" sz="900" b="0" u="none" strike="noStrike">
+            <a:endParaRPr lang="en-US" sz="1200" b="0" u="none" strike="noStrike">
               <a:solidFill>
                 <a:srgbClr val="000000"/>
               </a:solidFill>
@@ -4535,7 +4535,7 @@
         <p:spPr>
           <a:xfrm>
             <a:off x="457200" y="274320"/>
-            <a:ext cx="8229240" cy="273960"/>
+            <a:ext cx="8229240" cy="292320"/>
           </a:xfrm>
           <a:prstGeom prst="rect">
             <a:avLst/>
@@ -4565,9 +4565,9 @@
               </a:tabLst>
             </a:pPr>
             <a:r>
-              <a:rPr lang="en-US" sz="1100" b="1" u="none" spc="400" strike="noStrike">
-                <a:solidFill>
-                  <a:srgbClr val="FF6B5B"/>
+              <a:rPr lang="en-US" sz="1400" b="1" u="none" spc="400" strike="noStrike">
+                <a:solidFill>
+                  <a:srgbClr val="D94A3A"/>
                 </a:solidFill>
                 <a:effectLst/>
                 <a:uFillTx/>
@@ -4576,7 +4576,7 @@
               </a:rPr>
               <a:t>NARRATIEF VERHAAL</a:t>
             </a:r>
-            <a:endParaRPr lang="en-US" sz="1100" b="0" u="none" strike="noStrike">
+            <a:endParaRPr lang="en-US" sz="1400" b="0" u="none" strike="noStrike">
               <a:solidFill>
                 <a:srgbClr val="000000"/>
               </a:solidFill>
@@ -4807,7 +4807,7 @@
         <p:spPr>
           <a:xfrm>
             <a:off x="777240" y="2286000"/>
-            <a:ext cx="3382920" cy="273960"/>
+            <a:ext cx="3382920" cy="292320"/>
           </a:xfrm>
           <a:prstGeom prst="rect">
             <a:avLst/>
@@ -4837,9 +4837,9 @@
               </a:tabLst>
             </a:pPr>
             <a:r>
-              <a:rPr lang="en-US" sz="1200" b="1" u="none" spc="400" strike="noStrike">
-                <a:solidFill>
-                  <a:srgbClr val="0FA3A3"/>
+              <a:rPr lang="en-US" sz="1400" b="1" u="none" spc="400" strike="noStrike">
+                <a:solidFill>
+                  <a:srgbClr val="076E6E"/>
                 </a:solidFill>
                 <a:effectLst/>
                 <a:uFillTx/>
@@ -4848,7 +4848,7 @@
               </a:rPr>
               <a:t>OPTIE A</a:t>
             </a:r>
-            <a:endParaRPr lang="en-US" sz="1200" b="0" u="none" strike="noStrike">
+            <a:endParaRPr lang="en-US" sz="1400" b="0" u="none" strike="noStrike">
               <a:solidFill>
                 <a:srgbClr val="000000"/>
               </a:solidFill>
@@ -5140,7 +5140,7 @@
         <p:spPr>
           <a:xfrm>
             <a:off x="4983480" y="2286000"/>
-            <a:ext cx="3382920" cy="273960"/>
+            <a:ext cx="3382920" cy="292320"/>
           </a:xfrm>
           <a:prstGeom prst="rect">
             <a:avLst/>
@@ -5170,9 +5170,9 @@
               </a:tabLst>
             </a:pPr>
             <a:r>
-              <a:rPr lang="en-US" sz="1200" b="1" u="none" spc="400" strike="noStrike">
-                <a:solidFill>
-                  <a:srgbClr val="C78E1F"/>
+              <a:rPr lang="en-US" sz="1400" b="1" u="none" spc="400" strike="noStrike">
+                <a:solidFill>
+                  <a:srgbClr val="8A5A0E"/>
                 </a:solidFill>
                 <a:effectLst/>
                 <a:uFillTx/>
@@ -5181,7 +5181,7 @@
               </a:rPr>
               <a:t>OPTIE B</a:t>
             </a:r>
-            <a:endParaRPr lang="en-US" sz="1200" b="0" u="none" strike="noStrike">
+            <a:endParaRPr lang="en-US" sz="1400" b="0" u="none" strike="noStrike">
               <a:solidFill>
                 <a:srgbClr val="000000"/>
               </a:solidFill>
@@ -5294,7 +5294,7 @@
             <a:r>
               <a:rPr lang="en-US" sz="4800" b="1" u="none" spc="-99" strike="noStrike">
                 <a:solidFill>
-                  <a:srgbClr val="C78E1F"/>
+                  <a:srgbClr val="8A5A0E"/>
                 </a:solidFill>
                 <a:effectLst/>
                 <a:uFillTx/>
@@ -5518,7 +5518,7 @@
         <p:spPr>
           <a:xfrm>
             <a:off x="457200" y="274320"/>
-            <a:ext cx="8229240" cy="273960"/>
+            <a:ext cx="8229240" cy="292320"/>
           </a:xfrm>
           <a:prstGeom prst="rect">
             <a:avLst/>
@@ -5548,9 +5548,9 @@
               </a:tabLst>
             </a:pPr>
             <a:r>
-              <a:rPr lang="en-US" sz="1100" b="1" u="none" spc="400" strike="noStrike">
-                <a:solidFill>
-                  <a:srgbClr val="FF6B5B"/>
+              <a:rPr lang="en-US" sz="1400" b="1" u="none" spc="400" strike="noStrike">
+                <a:solidFill>
+                  <a:srgbClr val="D94A3A"/>
                 </a:solidFill>
                 <a:effectLst/>
                 <a:uFillTx/>
@@ -5559,7 +5559,7 @@
               </a:rPr>
               <a:t>KERNBEGRIP 1</a:t>
             </a:r>
-            <a:endParaRPr lang="en-US" sz="1100" b="0" u="none" strike="noStrike">
+            <a:endParaRPr lang="en-US" sz="1400" b="0" u="none" strike="noStrike">
               <a:solidFill>
                 <a:srgbClr val="000000"/>
               </a:solidFill>
@@ -5841,7 +5841,7 @@
         <p:spPr>
           <a:xfrm>
             <a:off x="457200" y="274320"/>
-            <a:ext cx="8229240" cy="273960"/>
+            <a:ext cx="8229240" cy="292320"/>
           </a:xfrm>
           <a:prstGeom prst="rect">
             <a:avLst/>
@@ -5871,9 +5871,9 @@
               </a:tabLst>
             </a:pPr>
             <a:r>
-              <a:rPr lang="en-US" sz="1100" b="1" u="none" spc="400" strike="noStrike">
-                <a:solidFill>
-                  <a:srgbClr val="FF6B5B"/>
+              <a:rPr lang="en-US" sz="1400" b="1" u="none" spc="400" strike="noStrike">
+                <a:solidFill>
+                  <a:srgbClr val="D94A3A"/>
                 </a:solidFill>
                 <a:effectLst/>
                 <a:uFillTx/>
@@ -5882,7 +5882,7 @@
               </a:rPr>
               <a:t>KERNBEGRIP 2</a:t>
             </a:r>
-            <a:endParaRPr lang="en-US" sz="1100" b="0" u="none" strike="noStrike">
+            <a:endParaRPr lang="en-US" sz="1400" b="0" u="none" strike="noStrike">
               <a:solidFill>
                 <a:srgbClr val="000000"/>
               </a:solidFill>
@@ -6164,7 +6164,7 @@
         <p:spPr>
           <a:xfrm>
             <a:off x="457200" y="274320"/>
-            <a:ext cx="8229240" cy="273960"/>
+            <a:ext cx="8229240" cy="292320"/>
           </a:xfrm>
           <a:prstGeom prst="rect">
             <a:avLst/>
@@ -6194,9 +6194,9 @@
               </a:tabLst>
             </a:pPr>
             <a:r>
-              <a:rPr lang="en-US" sz="1100" b="1" u="none" spc="400" strike="noStrike">
-                <a:solidFill>
-                  <a:srgbClr val="FF6B5B"/>
+              <a:rPr lang="en-US" sz="1400" b="1" u="none" spc="400" strike="noStrike">
+                <a:solidFill>
+                  <a:srgbClr val="D94A3A"/>
                 </a:solidFill>
                 <a:effectLst/>
                 <a:uFillTx/>
@@ -6205,7 +6205,7 @@
               </a:rPr>
               <a:t>KERNBEGRIP 3</a:t>
             </a:r>
-            <a:endParaRPr lang="en-US" sz="1100" b="0" u="none" strike="noStrike">
+            <a:endParaRPr lang="en-US" sz="1400" b="0" u="none" strike="noStrike">
               <a:solidFill>
                 <a:srgbClr val="000000"/>
               </a:solidFill>
@@ -6407,7 +6407,7 @@
             <a:r>
               <a:rPr lang="en-US" sz="2600" b="1" u="none" spc="-51" strike="noStrike">
                 <a:solidFill>
-                  <a:srgbClr val="FF6B5B"/>
+                  <a:srgbClr val="D94A3A"/>
                 </a:solidFill>
                 <a:effectLst/>
                 <a:uFillTx/>
@@ -6466,7 +6466,7 @@
               </a:tabLst>
             </a:pPr>
             <a:r>
-              <a:rPr lang="en-US" sz="1600" b="1" u="none" strike="noStrike">
+              <a:rPr lang="en-US" sz="1800" b="1" u="none" strike="noStrike">
                 <a:solidFill>
                   <a:srgbClr val="0B1B3D"/>
                 </a:solidFill>
@@ -6477,7 +6477,7 @@
               </a:rPr>
               <a:t>Benoem alternatieven</a:t>
             </a:r>
-            <a:endParaRPr lang="en-US" sz="1600" b="0" u="none" strike="noStrike">
+            <a:endParaRPr lang="en-US" sz="1800" b="0" u="none" strike="noStrike">
               <a:solidFill>
                 <a:srgbClr val="000000"/>
               </a:solidFill>
@@ -6527,7 +6527,7 @@
               </a:tabLst>
             </a:pPr>
             <a:r>
-              <a:rPr lang="en-US" sz="1200" b="0" i="1" u="none" strike="noStrike">
+              <a:rPr lang="en-US" sz="1400" b="0" i="1" u="none" strike="noStrike">
                 <a:solidFill>
                   <a:srgbClr val="2D3748"/>
                 </a:solidFill>
@@ -6538,7 +6538,7 @@
               </a:rPr>
               <a:t>Welke opties heb je?</a:t>
             </a:r>
-            <a:endParaRPr lang="en-US" sz="1200" b="0" u="none" strike="noStrike">
+            <a:endParaRPr lang="en-US" sz="1400" b="0" u="none" strike="noStrike">
               <a:solidFill>
                 <a:srgbClr val="000000"/>
               </a:solidFill>
@@ -6679,7 +6679,7 @@
             <a:r>
               <a:rPr lang="en-US" sz="2600" b="1" u="none" spc="-51" strike="noStrike">
                 <a:solidFill>
-                  <a:srgbClr val="FF6B5B"/>
+                  <a:srgbClr val="D94A3A"/>
                 </a:solidFill>
                 <a:effectLst/>
                 <a:uFillTx/>
@@ -6738,7 +6738,7 @@
               </a:tabLst>
             </a:pPr>
             <a:r>
-              <a:rPr lang="en-US" sz="1600" b="1" u="none" strike="noStrike">
+              <a:rPr lang="en-US" sz="1800" b="1" u="none" strike="noStrike">
                 <a:solidFill>
                   <a:srgbClr val="0B1B3D"/>
                 </a:solidFill>
@@ -6749,7 +6749,7 @@
               </a:rPr>
               <a:t>Bereken opbrengsten</a:t>
             </a:r>
-            <a:endParaRPr lang="en-US" sz="1600" b="0" u="none" strike="noStrike">
+            <a:endParaRPr lang="en-US" sz="1800" b="0" u="none" strike="noStrike">
               <a:solidFill>
                 <a:srgbClr val="000000"/>
               </a:solidFill>
@@ -6799,7 +6799,7 @@
               </a:tabLst>
             </a:pPr>
             <a:r>
-              <a:rPr lang="en-US" sz="1200" b="0" i="1" u="none" strike="noStrike">
+              <a:rPr lang="en-US" sz="1400" b="0" i="1" u="none" strike="noStrike">
                 <a:solidFill>
                   <a:srgbClr val="2D3748"/>
                 </a:solidFill>
@@ -6810,7 +6810,7 @@
               </a:rPr>
               <a:t>Wat levert elk alternatief op?</a:t>
             </a:r>
-            <a:endParaRPr lang="en-US" sz="1200" b="0" u="none" strike="noStrike">
+            <a:endParaRPr lang="en-US" sz="1400" b="0" u="none" strike="noStrike">
               <a:solidFill>
                 <a:srgbClr val="000000"/>
               </a:solidFill>
@@ -6951,7 +6951,7 @@
             <a:r>
               <a:rPr lang="en-US" sz="2600" b="1" u="none" spc="-51" strike="noStrike">
                 <a:solidFill>
-                  <a:srgbClr val="FF6B5B"/>
+                  <a:srgbClr val="D94A3A"/>
                 </a:solidFill>
                 <a:effectLst/>
                 <a:uFillTx/>
@@ -7010,7 +7010,7 @@
               </a:tabLst>
             </a:pPr>
             <a:r>
-              <a:rPr lang="en-US" sz="1600" b="1" u="none" strike="noStrike">
+              <a:rPr lang="en-US" sz="1800" b="1" u="none" strike="noStrike">
                 <a:solidFill>
                   <a:srgbClr val="0B1B3D"/>
                 </a:solidFill>
@@ -7021,7 +7021,7 @@
               </a:rPr>
               <a:t>Rangschik</a:t>
             </a:r>
-            <a:endParaRPr lang="en-US" sz="1600" b="0" u="none" strike="noStrike">
+            <a:endParaRPr lang="en-US" sz="1800" b="0" u="none" strike="noStrike">
               <a:solidFill>
                 <a:srgbClr val="000000"/>
               </a:solidFill>
@@ -7071,7 +7071,7 @@
               </a:tabLst>
             </a:pPr>
             <a:r>
-              <a:rPr lang="en-US" sz="1200" b="0" i="1" u="none" strike="noStrike">
+              <a:rPr lang="en-US" sz="1400" b="0" i="1" u="none" strike="noStrike">
                 <a:solidFill>
                   <a:srgbClr val="2D3748"/>
                 </a:solidFill>
@@ -7082,7 +7082,7 @@
               </a:rPr>
               <a:t>Beste niet-gekozen = alternatieve kosten.</a:t>
             </a:r>
-            <a:endParaRPr lang="en-US" sz="1200" b="0" u="none" strike="noStrike">
+            <a:endParaRPr lang="en-US" sz="1400" b="0" u="none" strike="noStrike">
               <a:solidFill>
                 <a:srgbClr val="000000"/>
               </a:solidFill>
@@ -7223,7 +7223,7 @@
             <a:r>
               <a:rPr lang="en-US" sz="2600" b="1" u="none" spc="-51" strike="noStrike">
                 <a:solidFill>
-                  <a:srgbClr val="FF6B5B"/>
+                  <a:srgbClr val="D94A3A"/>
                 </a:solidFill>
                 <a:effectLst/>
                 <a:uFillTx/>
@@ -7282,7 +7282,7 @@
               </a:tabLst>
             </a:pPr>
             <a:r>
-              <a:rPr lang="en-US" sz="1600" b="1" u="none" strike="noStrike">
+              <a:rPr lang="en-US" sz="1800" b="1" u="none" strike="noStrike">
                 <a:solidFill>
                   <a:srgbClr val="0B1B3D"/>
                 </a:solidFill>
@@ -7293,7 +7293,7 @@
               </a:rPr>
               <a:t>Bereken nettowaarde</a:t>
             </a:r>
-            <a:endParaRPr lang="en-US" sz="1600" b="0" u="none" strike="noStrike">
+            <a:endParaRPr lang="en-US" sz="1800" b="0" u="none" strike="noStrike">
               <a:solidFill>
                 <a:srgbClr val="000000"/>
               </a:solidFill>
@@ -7343,7 +7343,7 @@
               </a:tabLst>
             </a:pPr>
             <a:r>
-              <a:rPr lang="en-US" sz="1200" b="0" i="1" u="none" strike="noStrike">
+              <a:rPr lang="en-US" sz="1400" b="0" i="1" u="none" strike="noStrike">
                 <a:solidFill>
                   <a:srgbClr val="2D3748"/>
                 </a:solidFill>
@@ -7354,7 +7354,7 @@
               </a:rPr>
               <a:t>Opbrengst − alternatieve kosten.</a:t>
             </a:r>
-            <a:endParaRPr lang="en-US" sz="1200" b="0" u="none" strike="noStrike">
+            <a:endParaRPr lang="en-US" sz="1400" b="0" u="none" strike="noStrike">
               <a:solidFill>
                 <a:srgbClr val="000000"/>
               </a:solidFill>
@@ -7398,7 +7398,7 @@
         <p:spPr>
           <a:xfrm>
             <a:off x="5166360" y="4206240"/>
-            <a:ext cx="3520080" cy="228240"/>
+            <a:ext cx="3520080" cy="292320"/>
           </a:xfrm>
           <a:prstGeom prst="rect">
             <a:avLst/>
@@ -7428,9 +7428,9 @@
               </a:tabLst>
             </a:pPr>
             <a:r>
-              <a:rPr lang="en-US" sz="1000" b="0" i="1" u="none" strike="noStrike">
-                <a:solidFill>
-                  <a:srgbClr val="8B8779"/>
+              <a:rPr lang="en-US" sz="1400" b="0" i="1" u="none" strike="noStrike">
+                <a:solidFill>
+                  <a:srgbClr val="2D3748"/>
                 </a:solidFill>
                 <a:effectLst/>
                 <a:uFillTx/>
@@ -7439,7 +7439,7 @@
               </a:rPr>
               <a:t>Figuur 3 · het keuzeproces in vier stappen</a:t>
             </a:r>
-            <a:endParaRPr lang="en-US" sz="1000" b="0" u="none" strike="noStrike">
+            <a:endParaRPr lang="en-US" sz="1400" b="0" u="none" strike="noStrike">
               <a:solidFill>
                 <a:srgbClr val="000000"/>
               </a:solidFill>
@@ -7532,7 +7532,7 @@
               </a:tabLst>
             </a:pPr>
             <a:r>
-              <a:rPr lang="en-US" sz="1300" b="0" i="1" u="none" strike="noStrike">
+              <a:rPr lang="en-US" sz="1600" b="0" i="1" u="none" strike="noStrike">
                 <a:solidFill>
                   <a:srgbClr val="F4B740"/>
                 </a:solidFill>
@@ -7543,7 +7543,7 @@
               </a:rPr>
               <a:t>Verstandig = opbrengst &gt; alternatieve kosten.</a:t>
             </a:r>
-            <a:endParaRPr lang="en-US" sz="1300" b="0" u="none" strike="noStrike">
+            <a:endParaRPr lang="en-US" sz="1600" b="0" u="none" strike="noStrike">
               <a:solidFill>
                 <a:srgbClr val="000000"/>
               </a:solidFill>
@@ -7593,7 +7593,7 @@
         <p:spPr>
           <a:xfrm>
             <a:off x="457200" y="274320"/>
-            <a:ext cx="8229240" cy="273960"/>
+            <a:ext cx="8229240" cy="292320"/>
           </a:xfrm>
           <a:prstGeom prst="rect">
             <a:avLst/>
@@ -7623,9 +7623,9 @@
               </a:tabLst>
             </a:pPr>
             <a:r>
-              <a:rPr lang="en-US" sz="1100" b="1" u="none" spc="400" strike="noStrike">
-                <a:solidFill>
-                  <a:srgbClr val="FF6B5B"/>
+              <a:rPr lang="en-US" sz="1400" b="1" u="none" spc="400" strike="noStrike">
+                <a:solidFill>
+                  <a:srgbClr val="D94A3A"/>
                 </a:solidFill>
                 <a:effectLst/>
                 <a:uFillTx/>
@@ -7634,7 +7634,7 @@
               </a:rPr>
               <a:t>UITGEWERKT VOORBEELD · STAP 2</a:t>
             </a:r>
-            <a:endParaRPr lang="en-US" sz="1100" b="0" u="none" strike="noStrike">
+            <a:endParaRPr lang="en-US" sz="1400" b="0" u="none" strike="noStrike">
               <a:solidFill>
                 <a:srgbClr val="000000"/>
               </a:solidFill>
@@ -7788,7 +7788,7 @@
               </a:tabLst>
             </a:pPr>
             <a:r>
-              <a:rPr lang="en-US" sz="1000" b="1" u="none" spc="201" strike="noStrike">
+              <a:rPr lang="en-US" sz="1400" b="1" u="none" spc="201" strike="noStrike">
                 <a:solidFill>
                   <a:srgbClr val="FFFFFF"/>
                 </a:solidFill>
@@ -7799,7 +7799,7 @@
               </a:rPr>
               <a:t>GEWAS</a:t>
             </a:r>
-            <a:endParaRPr lang="en-US" sz="1000" b="0" u="none" strike="noStrike">
+            <a:endParaRPr lang="en-US" sz="1400" b="0" u="none" strike="noStrike">
               <a:solidFill>
                 <a:srgbClr val="000000"/>
               </a:solidFill>
@@ -7849,7 +7849,7 @@
               </a:tabLst>
             </a:pPr>
             <a:r>
-              <a:rPr lang="en-US" sz="1000" b="1" u="none" spc="201" strike="noStrike">
+              <a:rPr lang="en-US" sz="1400" b="1" u="none" spc="201" strike="noStrike">
                 <a:solidFill>
                   <a:srgbClr val="FFFFFF"/>
                 </a:solidFill>
@@ -7860,7 +7860,7 @@
               </a:rPr>
               <a:t>€ / HECTARE</a:t>
             </a:r>
-            <a:endParaRPr lang="en-US" sz="1000" b="0" u="none" strike="noStrike">
+            <a:endParaRPr lang="en-US" sz="1400" b="0" u="none" strike="noStrike">
               <a:solidFill>
                 <a:srgbClr val="000000"/>
               </a:solidFill>
@@ -7910,7 +7910,7 @@
               </a:tabLst>
             </a:pPr>
             <a:r>
-              <a:rPr lang="en-US" sz="1000" b="1" u="none" spc="201" strike="noStrike">
+              <a:rPr lang="en-US" sz="1400" b="1" u="none" spc="201" strike="noStrike">
                 <a:solidFill>
                   <a:srgbClr val="FFFFFF"/>
                 </a:solidFill>
@@ -7921,7 +7921,7 @@
               </a:rPr>
               <a:t>TOTAAL (10 ha)</a:t>
             </a:r>
-            <a:endParaRPr lang="en-US" sz="1000" b="0" u="none" strike="noStrike">
+            <a:endParaRPr lang="en-US" sz="1400" b="0" u="none" strike="noStrike">
               <a:solidFill>
                 <a:srgbClr val="000000"/>
               </a:solidFill>
@@ -8184,7 +8184,7 @@
             <a:r>
               <a:rPr lang="en-US" sz="2200" b="1" u="none" strike="noStrike">
                 <a:solidFill>
-                  <a:srgbClr val="0FA3A3"/>
+                  <a:srgbClr val="076E6E"/>
                 </a:solidFill>
                 <a:effectLst/>
                 <a:uFillTx/>
@@ -8456,7 +8456,7 @@
             <a:r>
               <a:rPr lang="en-US" sz="2200" b="1" u="none" strike="noStrike">
                 <a:solidFill>
-                  <a:srgbClr val="C78E1F"/>
+                  <a:srgbClr val="8A5A0E"/>
                 </a:solidFill>
                 <a:effectLst/>
                 <a:uFillTx/>
@@ -8539,7 +8539,7 @@
         <p:spPr>
           <a:xfrm>
             <a:off x="457200" y="274320"/>
-            <a:ext cx="8229240" cy="273960"/>
+            <a:ext cx="8229240" cy="292320"/>
           </a:xfrm>
           <a:prstGeom prst="rect">
             <a:avLst/>
@@ -8569,9 +8569,9 @@
               </a:tabLst>
             </a:pPr>
             <a:r>
-              <a:rPr lang="en-US" sz="1100" b="1" u="none" spc="400" strike="noStrike">
-                <a:solidFill>
-                  <a:srgbClr val="FF6B5B"/>
+              <a:rPr lang="en-US" sz="1400" b="1" u="none" spc="400" strike="noStrike">
+                <a:solidFill>
+                  <a:srgbClr val="D94A3A"/>
                 </a:solidFill>
                 <a:effectLst/>
                 <a:uFillTx/>
@@ -8580,7 +8580,7 @@
               </a:rPr>
               <a:t>UITGEWERKT VOORBEELD · STAP 3</a:t>
             </a:r>
-            <a:endParaRPr lang="en-US" sz="1100" b="0" u="none" strike="noStrike">
+            <a:endParaRPr lang="en-US" sz="1400" b="0" u="none" strike="noStrike">
               <a:solidFill>
                 <a:srgbClr val="000000"/>
               </a:solidFill>
@@ -8777,7 +8777,7 @@
               </a:tabLst>
             </a:pPr>
             <a:r>
-              <a:rPr lang="en-US" sz="1600" b="0" u="none" strike="noStrike">
+              <a:rPr lang="en-US" sz="1800" b="0" u="none" strike="noStrike">
                 <a:solidFill>
                   <a:srgbClr val="FFFFFF"/>
                 </a:solidFill>
@@ -8788,7 +8788,7 @@
               </a:rPr>
               <a:t>Kiest tarwe → alternatieve kosten</a:t>
             </a:r>
-            <a:endParaRPr lang="en-US" sz="1600" b="0" u="none" strike="noStrike">
+            <a:endParaRPr lang="en-US" sz="1800" b="0" u="none" strike="noStrike">
               <a:solidFill>
                 <a:srgbClr val="000000"/>
               </a:solidFill>
@@ -8899,7 +8899,7 @@
               </a:tabLst>
             </a:pPr>
             <a:r>
-              <a:rPr lang="en-US" sz="1600" b="0" i="1" u="none" strike="noStrike">
+              <a:rPr lang="en-US" sz="1800" b="0" i="1" u="none" strike="noStrike">
                 <a:solidFill>
                   <a:srgbClr val="D4D1CA"/>
                 </a:solidFill>
@@ -8910,7 +8910,7 @@
               </a:rPr>
               <a:t>de maïsopbrengst die hij laat liggen</a:t>
             </a:r>
-            <a:endParaRPr lang="en-US" sz="1600" b="0" u="none" strike="noStrike">
+            <a:endParaRPr lang="en-US" sz="1800" b="0" u="none" strike="noStrike">
               <a:solidFill>
                 <a:srgbClr val="000000"/>
               </a:solidFill>
@@ -9014,7 +9014,7 @@
               </a:tabLst>
             </a:pPr>
             <a:r>
-              <a:rPr lang="en-US" sz="1300" b="1" u="none" spc="601" strike="noStrike">
+              <a:rPr lang="en-US" sz="1400" b="1" u="none" spc="601" strike="noStrike">
                 <a:solidFill>
                   <a:srgbClr val="FF6B5B"/>
                 </a:solidFill>
@@ -9025,7 +9025,7 @@
               </a:rPr>
               <a:t>De kern</a:t>
             </a:r>
-            <a:endParaRPr lang="en-US" sz="1300" b="0" u="none" strike="noStrike">
+            <a:endParaRPr lang="en-US" sz="1400" b="0" u="none" strike="noStrike">
               <a:solidFill>
                 <a:srgbClr val="FFFFFF"/>
               </a:solidFill>
@@ -10230,7 +10230,7 @@
         <p:spPr>
           <a:xfrm>
             <a:off x="777240" y="3840480"/>
-            <a:ext cx="7772040" cy="273960"/>
+            <a:ext cx="7772040" cy="292320"/>
           </a:xfrm>
           <a:prstGeom prst="rect">
             <a:avLst/>
@@ -10260,7 +10260,7 @@
               </a:tabLst>
             </a:pPr>
             <a:r>
-              <a:rPr lang="en-US" sz="1100" b="1" u="none" spc="300" strike="noStrike">
+              <a:rPr lang="en-US" sz="1400" b="1" u="none" spc="300" strike="noStrike">
                 <a:solidFill>
                   <a:srgbClr val="F4B740"/>
                 </a:solidFill>
@@ -10271,7 +10271,7 @@
               </a:rPr>
               <a:t>VOLGENDE PARAGRAAF  ·  §1.1.2</a:t>
             </a:r>
-            <a:endParaRPr lang="en-US" sz="1100" b="0" u="none" strike="noStrike">
+            <a:endParaRPr lang="en-US" sz="1400" b="0" u="none" strike="noStrike">
               <a:solidFill>
                 <a:srgbClr val="FFFFFF"/>
               </a:solidFill>

</xml_diff>

<commit_message>
Refresh 1.1.1 parity artifacts
Regenerate 1.1.1 student-facing materials from the platform parity fixes, record the L1.5D-B02 plan and roadmap evidence, refresh the Part A review/quality record, and preserve the lead web-PowerPoint review as the source of the follow-up.
</commit_message>
<xml_diff>
--- a/Boek 1 - Grondslagen, vraag en aanbod/1.1 Hoofdstuk Economisch denken en rekenen/1.1.1 Schaarste en economisch denken/1.1.1 Schaarste en economisch denken – presentatie.pptx
+++ b/Boek 1 - Grondslagen, vraag en aanbod/1.1 Hoofdstuk Economisch denken en rekenen/1.1.1 Schaarste en economisch denken/1.1.1 Schaarste en economisch denken – presentatie.pptx
@@ -372,7 +372,7 @@
             <a:pPr indent="0" algn="r">
               <a:buNone/>
             </a:pPr>
-            <a:fld id="{5EF2FF7F-9CA6-416B-9F24-D18A1174E12C}" type="slidenum">
+            <a:fld id="{022D8C17-E217-4B3D-8FF8-1163C8E2D8B7}" type="slidenum">
               <a:rPr lang="en-US" sz="1400" b="0" u="none" strike="noStrike">
                 <a:solidFill>
                   <a:srgbClr val="000000"/>
@@ -419,7 +419,7 @@
       </p:grpSpPr>
       <p:sp>
         <p:nvSpPr>
-          <p:cNvPr id="127" name="PlaceHolder 1"/>
+          <p:cNvPr id="128" name="PlaceHolder 1"/>
           <p:cNvSpPr>
             <a:spLocks noGrp="1"/>
           </p:cNvSpPr>
@@ -442,7 +442,7 @@
       </p:sp>
       <p:sp>
         <p:nvSpPr>
-          <p:cNvPr id="128" name="PlaceHolder 2"/>
+          <p:cNvPr id="129" name="PlaceHolder 2"/>
           <p:cNvSpPr>
             <a:spLocks noGrp="1"/>
           </p:cNvSpPr>
@@ -480,6 +480,30 @@
                 <a:uFillTx/>
                 <a:latin typeface="Arial"/>
               </a:rPr>
+              <a:t>NavTitle: Startvraag</a:t>
+            </a:r>
+            <a:endParaRPr lang="en-US" sz="2000" b="0" u="none" strike="noStrike">
+              <a:solidFill>
+                <a:srgbClr val="000000"/>
+              </a:solidFill>
+              <a:effectLst/>
+              <a:uFillTx/>
+              <a:latin typeface="Arial"/>
+            </a:endParaRPr>
+          </a:p>
+          <a:p>
+            <a:pPr indent="0" algn="l">
+              <a:buNone/>
+            </a:pPr>
+            <a:r>
+              <a:rPr lang="en-US" sz="1400" b="0" u="none" strike="noStrike">
+                <a:solidFill>
+                  <a:srgbClr val="000000"/>
+                </a:solidFill>
+                <a:effectLst/>
+                <a:uFillTx/>
+                <a:latin typeface="Arial"/>
+              </a:rPr>
               <a:t>Vraag:    Waarom kun je niet alles hebben? Laat de klas één antwoord roepen.</a:t>
             </a:r>
             <a:endParaRPr lang="en-US" sz="2000" b="0" u="none" strike="noStrike">
@@ -570,7 +594,7 @@
       </p:sp>
       <p:sp>
         <p:nvSpPr>
-          <p:cNvPr id="129" name="PlaceHolder 3"/>
+          <p:cNvPr id="130" name="PlaceHolder 3"/>
           <p:cNvSpPr>
             <a:spLocks noGrp="1"/>
           </p:cNvSpPr>
@@ -619,7 +643,7 @@
               </a:lnSpc>
               <a:buNone/>
             </a:pPr>
-            <a:fld id="{7B7B47FD-7F08-4AB1-9043-CB66140F82E2}" type="slidenum">
+            <a:fld id="{9C03FF26-C20C-4853-812B-04EC1CB24575}" type="slidenum">
               <a:rPr lang="en-US" sz="1400" b="0" u="none" strike="noStrike">
                 <a:solidFill>
                   <a:schemeClr val="dk1"/>
@@ -666,7 +690,7 @@
       </p:grpSpPr>
       <p:sp>
         <p:nvSpPr>
-          <p:cNvPr id="130" name="PlaceHolder 1"/>
+          <p:cNvPr id="131" name="PlaceHolder 1"/>
           <p:cNvSpPr>
             <a:spLocks noGrp="1"/>
           </p:cNvSpPr>
@@ -689,7 +713,7 @@
       </p:sp>
       <p:sp>
         <p:nvSpPr>
-          <p:cNvPr id="131" name="PlaceHolder 2"/>
+          <p:cNvPr id="132" name="PlaceHolder 2"/>
           <p:cNvSpPr>
             <a:spLocks noGrp="1"/>
           </p:cNvSpPr>
@@ -727,6 +751,30 @@
                 <a:uFillTx/>
                 <a:latin typeface="Arial"/>
               </a:rPr>
+              <a:t>NavTitle: Lisa moet kiezen</a:t>
+            </a:r>
+            <a:endParaRPr lang="en-US" sz="2000" b="0" u="none" strike="noStrike">
+              <a:solidFill>
+                <a:srgbClr val="000000"/>
+              </a:solidFill>
+              <a:effectLst/>
+              <a:uFillTx/>
+              <a:latin typeface="Arial"/>
+            </a:endParaRPr>
+          </a:p>
+          <a:p>
+            <a:pPr indent="0" algn="l">
+              <a:buNone/>
+            </a:pPr>
+            <a:r>
+              <a:rPr lang="en-US" sz="1400" b="0" u="none" strike="noStrike">
+                <a:solidFill>
+                  <a:srgbClr val="000000"/>
+                </a:solidFill>
+                <a:effectLst/>
+                <a:uFillTx/>
+                <a:latin typeface="Arial"/>
+              </a:rPr>
               <a:t>Vraag:    Welke zou jij kiezen, bioscoop of boek? Hand omhoog.</a:t>
             </a:r>
             <a:endParaRPr lang="en-US" sz="2000" b="0" u="none" strike="noStrike">
@@ -817,7 +865,7 @@
       </p:sp>
       <p:sp>
         <p:nvSpPr>
-          <p:cNvPr id="132" name="PlaceHolder 3"/>
+          <p:cNvPr id="133" name="PlaceHolder 3"/>
           <p:cNvSpPr>
             <a:spLocks noGrp="1"/>
           </p:cNvSpPr>
@@ -866,7 +914,7 @@
               </a:lnSpc>
               <a:buNone/>
             </a:pPr>
-            <a:fld id="{3B0993E3-08CA-4A28-9262-EAA5E2985867}" type="slidenum">
+            <a:fld id="{7214C8D0-9487-4143-825E-4AAE681DAC2A}" type="slidenum">
               <a:rPr lang="en-US" sz="1400" b="0" u="none" strike="noStrike">
                 <a:solidFill>
                   <a:schemeClr val="dk1"/>
@@ -913,7 +961,7 @@
       </p:grpSpPr>
       <p:sp>
         <p:nvSpPr>
-          <p:cNvPr id="133" name="PlaceHolder 1"/>
+          <p:cNvPr id="134" name="PlaceHolder 1"/>
           <p:cNvSpPr>
             <a:spLocks noGrp="1"/>
           </p:cNvSpPr>
@@ -936,7 +984,7 @@
       </p:sp>
       <p:sp>
         <p:nvSpPr>
-          <p:cNvPr id="134" name="PlaceHolder 2"/>
+          <p:cNvPr id="135" name="PlaceHolder 2"/>
           <p:cNvSpPr>
             <a:spLocks noGrp="1"/>
           </p:cNvSpPr>
@@ -974,6 +1022,30 @@
                 <a:uFillTx/>
                 <a:latin typeface="Arial"/>
               </a:rPr>
+              <a:t>NavTitle: Schaarste herkennen</a:t>
+            </a:r>
+            <a:endParaRPr lang="en-US" sz="2000" b="0" u="none" strike="noStrike">
+              <a:solidFill>
+                <a:srgbClr val="000000"/>
+              </a:solidFill>
+              <a:effectLst/>
+              <a:uFillTx/>
+              <a:latin typeface="Arial"/>
+            </a:endParaRPr>
+          </a:p>
+          <a:p>
+            <a:pPr indent="0" algn="l">
+              <a:buNone/>
+            </a:pPr>
+            <a:r>
+              <a:rPr lang="en-US" sz="1400" b="0" u="none" strike="noStrike">
+                <a:solidFill>
+                  <a:srgbClr val="000000"/>
+                </a:solidFill>
+                <a:effectLst/>
+                <a:uFillTx/>
+                <a:latin typeface="Arial"/>
+              </a:rPr>
               <a:t>Vraag:    Wat heb jij deze week wel gewild en niet gekregen? Waardoor?</a:t>
             </a:r>
             <a:endParaRPr lang="en-US" sz="2000" b="0" u="none" strike="noStrike">
@@ -1136,7 +1208,7 @@
       </p:sp>
       <p:sp>
         <p:nvSpPr>
-          <p:cNvPr id="135" name="PlaceHolder 3"/>
+          <p:cNvPr id="136" name="PlaceHolder 3"/>
           <p:cNvSpPr>
             <a:spLocks noGrp="1"/>
           </p:cNvSpPr>
@@ -1185,7 +1257,7 @@
               </a:lnSpc>
               <a:buNone/>
             </a:pPr>
-            <a:fld id="{2938FC43-80E8-480A-AEE9-7C7BC96597D9}" type="slidenum">
+            <a:fld id="{9E0174F8-40C6-480E-A83E-A97C188D87BC}" type="slidenum">
               <a:rPr lang="en-US" sz="1400" b="0" u="none" strike="noStrike">
                 <a:solidFill>
                   <a:schemeClr val="dk1"/>
@@ -1232,7 +1304,7 @@
       </p:grpSpPr>
       <p:sp>
         <p:nvSpPr>
-          <p:cNvPr id="136" name="PlaceHolder 1"/>
+          <p:cNvPr id="137" name="PlaceHolder 1"/>
           <p:cNvSpPr>
             <a:spLocks noGrp="1"/>
           </p:cNvSpPr>
@@ -1255,7 +1327,7 @@
       </p:sp>
       <p:sp>
         <p:nvSpPr>
-          <p:cNvPr id="137" name="PlaceHolder 2"/>
+          <p:cNvPr id="138" name="PlaceHolder 2"/>
           <p:cNvSpPr>
             <a:spLocks noGrp="1"/>
           </p:cNvSpPr>
@@ -1293,6 +1365,30 @@
                 <a:uFillTx/>
                 <a:latin typeface="Arial"/>
               </a:rPr>
+              <a:t>NavTitle: Alternatieve kosten</a:t>
+            </a:r>
+            <a:endParaRPr lang="en-US" sz="2000" b="0" u="none" strike="noStrike">
+              <a:solidFill>
+                <a:srgbClr val="000000"/>
+              </a:solidFill>
+              <a:effectLst/>
+              <a:uFillTx/>
+              <a:latin typeface="Arial"/>
+            </a:endParaRPr>
+          </a:p>
+          <a:p>
+            <a:pPr indent="0" algn="l">
+              <a:buNone/>
+            </a:pPr>
+            <a:r>
+              <a:rPr lang="en-US" sz="1400" b="0" u="none" strike="noStrike">
+                <a:solidFill>
+                  <a:srgbClr val="000000"/>
+                </a:solidFill>
+                <a:effectLst/>
+                <a:uFillTx/>
+                <a:latin typeface="Arial"/>
+              </a:rPr>
               <a:t>Vraag:    Lisa kiest de bioscoop. Wat kost haar dat — in euro's, en daarnaast?</a:t>
             </a:r>
             <a:endParaRPr lang="en-US" sz="2000" b="0" u="none" strike="noStrike">
@@ -1479,7 +1575,7 @@
       </p:sp>
       <p:sp>
         <p:nvSpPr>
-          <p:cNvPr id="138" name="PlaceHolder 3"/>
+          <p:cNvPr id="139" name="PlaceHolder 3"/>
           <p:cNvSpPr>
             <a:spLocks noGrp="1"/>
           </p:cNvSpPr>
@@ -1528,7 +1624,7 @@
               </a:lnSpc>
               <a:buNone/>
             </a:pPr>
-            <a:fld id="{46E6AAB7-6B70-47EE-B0D4-9030B95D7A9C}" type="slidenum">
+            <a:fld id="{94920D59-5C80-4999-BDE6-9BB72B5B0830}" type="slidenum">
               <a:rPr lang="en-US" sz="1400" b="0" u="none" strike="noStrike">
                 <a:solidFill>
                   <a:schemeClr val="dk1"/>
@@ -1575,7 +1671,7 @@
       </p:grpSpPr>
       <p:sp>
         <p:nvSpPr>
-          <p:cNvPr id="139" name="PlaceHolder 1"/>
+          <p:cNvPr id="140" name="PlaceHolder 1"/>
           <p:cNvSpPr>
             <a:spLocks noGrp="1"/>
           </p:cNvSpPr>
@@ -1598,7 +1694,7 @@
       </p:sp>
       <p:sp>
         <p:nvSpPr>
-          <p:cNvPr id="140" name="PlaceHolder 2"/>
+          <p:cNvPr id="141" name="PlaceHolder 2"/>
           <p:cNvSpPr>
             <a:spLocks noGrp="1"/>
           </p:cNvSpPr>
@@ -1636,6 +1732,30 @@
                 <a:uFillTx/>
                 <a:latin typeface="Arial"/>
               </a:rPr>
+              <a:t>NavTitle: Vier stappen</a:t>
+            </a:r>
+            <a:endParaRPr lang="en-US" sz="2000" b="0" u="none" strike="noStrike">
+              <a:solidFill>
+                <a:srgbClr val="000000"/>
+              </a:solidFill>
+              <a:effectLst/>
+              <a:uFillTx/>
+              <a:latin typeface="Arial"/>
+            </a:endParaRPr>
+          </a:p>
+          <a:p>
+            <a:pPr indent="0" algn="l">
+              <a:buNone/>
+            </a:pPr>
+            <a:r>
+              <a:rPr lang="en-US" sz="1400" b="0" u="none" strike="noStrike">
+                <a:solidFill>
+                  <a:srgbClr val="000000"/>
+                </a:solidFill>
+                <a:effectLst/>
+                <a:uFillTx/>
+                <a:latin typeface="Arial"/>
+              </a:rPr>
               <a:t>Vraag:    Als je voor een lastige keuze staat, waarmee begin je?</a:t>
             </a:r>
             <a:endParaRPr lang="en-US" sz="2000" b="0" u="none" strike="noStrike">
@@ -1726,7 +1846,7 @@
       </p:sp>
       <p:sp>
         <p:nvSpPr>
-          <p:cNvPr id="141" name="PlaceHolder 3"/>
+          <p:cNvPr id="142" name="PlaceHolder 3"/>
           <p:cNvSpPr>
             <a:spLocks noGrp="1"/>
           </p:cNvSpPr>
@@ -1775,7 +1895,7 @@
               </a:lnSpc>
               <a:buNone/>
             </a:pPr>
-            <a:fld id="{8A481C97-5AEA-441F-87E7-A692BD379B71}" type="slidenum">
+            <a:fld id="{2C834605-CE39-4C1F-83FF-ED79CAAB5353}" type="slidenum">
               <a:rPr lang="en-US" sz="1400" b="0" u="none" strike="noStrike">
                 <a:solidFill>
                   <a:schemeClr val="dk1"/>
@@ -1822,7 +1942,7 @@
       </p:grpSpPr>
       <p:sp>
         <p:nvSpPr>
-          <p:cNvPr id="142" name="PlaceHolder 1"/>
+          <p:cNvPr id="143" name="PlaceHolder 1"/>
           <p:cNvSpPr>
             <a:spLocks noGrp="1"/>
           </p:cNvSpPr>
@@ -1845,7 +1965,7 @@
       </p:sp>
       <p:sp>
         <p:nvSpPr>
-          <p:cNvPr id="143" name="PlaceHolder 2"/>
+          <p:cNvPr id="144" name="PlaceHolder 2"/>
           <p:cNvSpPr>
             <a:spLocks noGrp="1"/>
           </p:cNvSpPr>
@@ -1883,7 +2003,7 @@
                 <a:uFillTx/>
                 <a:latin typeface="Arial"/>
               </a:rPr>
-              <a:t>Vraag:    Een boer heeft 10 hectare. Tarwe levert €500/ha op, maïs €350/ha. Wat verdient hij per gewas?</a:t>
+              <a:t>NavTitle: Winst boer berekenen</a:t>
             </a:r>
             <a:endParaRPr lang="en-US" sz="2000" b="0" u="none" strike="noStrike">
               <a:solidFill>
@@ -1907,7 +2027,31 @@
                 <a:uFillTx/>
                 <a:latin typeface="Arial"/>
               </a:rPr>
-              <a:t>Uitleg:   Snel voorrekenen: 10 × €500 = €5.000 voor tarwe; 10 × €350 = €3.500 voor maïs. We hebben nu de opbrengst van élke optie — dat was stap 2.</a:t>
+              <a:t>Vraag:    Een boer heeft 10 hectare. Tarwe levert €500/ha op, maïs €350/ha. Wat verdient hij per gewas?</a:t>
+            </a:r>
+            <a:endParaRPr lang="en-US" sz="2000" b="0" u="none" strike="noStrike">
+              <a:solidFill>
+                <a:srgbClr val="000000"/>
+              </a:solidFill>
+              <a:effectLst/>
+              <a:uFillTx/>
+              <a:latin typeface="Arial"/>
+            </a:endParaRPr>
+          </a:p>
+          <a:p>
+            <a:pPr indent="0" algn="l">
+              <a:buNone/>
+            </a:pPr>
+            <a:r>
+              <a:rPr lang="en-US" sz="1400" b="0" u="none" strike="noStrike">
+                <a:solidFill>
+                  <a:srgbClr val="000000"/>
+                </a:solidFill>
+                <a:effectLst/>
+                <a:uFillTx/>
+                <a:latin typeface="Arial"/>
+              </a:rPr>
+              <a:t>Uitleg:   Snel voorrekenen: 10 × €500 = €5.000 voor tarwe; 10 × €350 = €3.500 voor maïs. We hebben nu de totale winst van élke optie — dat was stap 2.</a:t>
             </a:r>
             <a:endParaRPr lang="en-US" sz="2000" b="0" u="none" strike="noStrike">
               <a:solidFill>
@@ -1973,7 +2117,7 @@
       </p:sp>
       <p:sp>
         <p:nvSpPr>
-          <p:cNvPr id="144" name="PlaceHolder 3"/>
+          <p:cNvPr id="145" name="PlaceHolder 3"/>
           <p:cNvSpPr>
             <a:spLocks noGrp="1"/>
           </p:cNvSpPr>
@@ -2022,7 +2166,7 @@
               </a:lnSpc>
               <a:buNone/>
             </a:pPr>
-            <a:fld id="{529A6605-2952-464D-800D-1D9B4CD13AAB}" type="slidenum">
+            <a:fld id="{43A6DDE5-72B0-4B3D-AD12-9503EF25036F}" type="slidenum">
               <a:rPr lang="en-US" sz="1400" b="0" u="none" strike="noStrike">
                 <a:solidFill>
                   <a:schemeClr val="dk1"/>
@@ -2069,7 +2213,7 @@
       </p:grpSpPr>
       <p:sp>
         <p:nvSpPr>
-          <p:cNvPr id="145" name="PlaceHolder 1"/>
+          <p:cNvPr id="146" name="PlaceHolder 1"/>
           <p:cNvSpPr>
             <a:spLocks noGrp="1"/>
           </p:cNvSpPr>
@@ -2092,7 +2236,7 @@
       </p:sp>
       <p:sp>
         <p:nvSpPr>
-          <p:cNvPr id="146" name="PlaceHolder 2"/>
+          <p:cNvPr id="147" name="PlaceHolder 2"/>
           <p:cNvSpPr>
             <a:spLocks noGrp="1"/>
           </p:cNvSpPr>
@@ -2130,7 +2274,7 @@
                 <a:uFillTx/>
                 <a:latin typeface="Arial"/>
               </a:rPr>
-              <a:t>Vraag:    Hij kiest tarwe. Wat láát hij dan liggen?</a:t>
+              <a:t>NavTitle: Alternatieve kosten boer</a:t>
             </a:r>
             <a:endParaRPr lang="en-US" sz="2000" b="0" u="none" strike="noStrike">
               <a:solidFill>
@@ -2154,7 +2298,7 @@
                 <a:uFillTx/>
                 <a:latin typeface="Arial"/>
               </a:rPr>
-              <a:t>Uitleg:   De maïsopbrengst van €3.500 — dát zijn zijn alternatieve kosten. Niet de som van opties, niet de prijs die hij betaalt: het beste alternatief dat hij niet neemt.</a:t>
+              <a:t>Vraag:    Hij kiest tarwe. Wat láát hij dan liggen?</a:t>
             </a:r>
             <a:endParaRPr lang="en-US" sz="2000" b="0" u="none" strike="noStrike">
               <a:solidFill>
@@ -2178,7 +2322,31 @@
                 <a:uFillTx/>
                 <a:latin typeface="Arial"/>
               </a:rPr>
-              <a:t>          Netto: €5.000 − €3.500 = €1.500 voordeel. Kiezen loont dus — zolang de opbrengst de alternatieve kosten overtreft.</a:t>
+              <a:t>Uitleg:   De totale winst met maïs van €3.500 — dát zijn zijn alternatieve kosten. Niet de som van opties, niet de prijs die hij betaalt: het beste alternatief dat hij niet neemt.</a:t>
+            </a:r>
+            <a:endParaRPr lang="en-US" sz="2000" b="0" u="none" strike="noStrike">
+              <a:solidFill>
+                <a:srgbClr val="000000"/>
+              </a:solidFill>
+              <a:effectLst/>
+              <a:uFillTx/>
+              <a:latin typeface="Arial"/>
+            </a:endParaRPr>
+          </a:p>
+          <a:p>
+            <a:pPr indent="0" algn="l">
+              <a:buNone/>
+            </a:pPr>
+            <a:r>
+              <a:rPr lang="en-US" sz="1400" b="0" u="none" strike="noStrike">
+                <a:solidFill>
+                  <a:srgbClr val="000000"/>
+                </a:solidFill>
+                <a:effectLst/>
+                <a:uFillTx/>
+                <a:latin typeface="Arial"/>
+              </a:rPr>
+              <a:t>          Nettowaarde: €5.000 − €3.500 = €1.500 voordeel volgens deze opbrengstmaat.</a:t>
             </a:r>
             <a:endParaRPr lang="en-US" sz="2000" b="0" u="none" strike="noStrike">
               <a:solidFill>
@@ -2244,7 +2412,7 @@
       </p:sp>
       <p:sp>
         <p:nvSpPr>
-          <p:cNvPr id="147" name="PlaceHolder 3"/>
+          <p:cNvPr id="148" name="PlaceHolder 3"/>
           <p:cNvSpPr>
             <a:spLocks noGrp="1"/>
           </p:cNvSpPr>
@@ -2293,7 +2461,7 @@
               </a:lnSpc>
               <a:buNone/>
             </a:pPr>
-            <a:fld id="{BACF90C4-5773-46DA-A27C-B69D8966C2E6}" type="slidenum">
+            <a:fld id="{C61EB7D7-5675-4122-BC0E-FE562634B7F2}" type="slidenum">
               <a:rPr lang="en-US" sz="1400" b="0" u="none" strike="noStrike">
                 <a:solidFill>
                   <a:schemeClr val="dk1"/>
@@ -2340,7 +2508,7 @@
       </p:grpSpPr>
       <p:sp>
         <p:nvSpPr>
-          <p:cNvPr id="148" name="PlaceHolder 1"/>
+          <p:cNvPr id="149" name="PlaceHolder 1"/>
           <p:cNvSpPr>
             <a:spLocks noGrp="1"/>
           </p:cNvSpPr>
@@ -2363,7 +2531,7 @@
       </p:sp>
       <p:sp>
         <p:nvSpPr>
-          <p:cNvPr id="149" name="PlaceHolder 2"/>
+          <p:cNvPr id="150" name="PlaceHolder 2"/>
           <p:cNvSpPr>
             <a:spLocks noGrp="1"/>
           </p:cNvSpPr>
@@ -2401,6 +2569,30 @@
                 <a:uFillTx/>
                 <a:latin typeface="Arial"/>
               </a:rPr>
+              <a:t>NavTitle: Vijf kernpunten</a:t>
+            </a:r>
+            <a:endParaRPr lang="en-US" sz="2000" b="0" u="none" strike="noStrike">
+              <a:solidFill>
+                <a:srgbClr val="000000"/>
+              </a:solidFill>
+              <a:effectLst/>
+              <a:uFillTx/>
+              <a:latin typeface="Arial"/>
+            </a:endParaRPr>
+          </a:p>
+          <a:p>
+            <a:pPr indent="0" algn="l">
+              <a:buNone/>
+            </a:pPr>
+            <a:r>
+              <a:rPr lang="en-US" sz="1400" b="0" u="none" strike="noStrike">
+                <a:solidFill>
+                  <a:srgbClr val="000000"/>
+                </a:solidFill>
+                <a:effectLst/>
+                <a:uFillTx/>
+                <a:latin typeface="Arial"/>
+              </a:rPr>
               <a:t>Vraag:    Welke van de vijf punten kun je uit je hoofd aan je buurman uitleggen?</a:t>
             </a:r>
             <a:endParaRPr lang="en-US" sz="2000" b="0" u="none" strike="noStrike">
@@ -2491,7 +2683,7 @@
       </p:sp>
       <p:sp>
         <p:nvSpPr>
-          <p:cNvPr id="150" name="PlaceHolder 3"/>
+          <p:cNvPr id="151" name="PlaceHolder 3"/>
           <p:cNvSpPr>
             <a:spLocks noGrp="1"/>
           </p:cNvSpPr>
@@ -2540,7 +2732,7 @@
               </a:lnSpc>
               <a:buNone/>
             </a:pPr>
-            <a:fld id="{30144A15-205D-4C99-B457-DF9630D20145}" type="slidenum">
+            <a:fld id="{8319B111-27A4-47AD-81F9-D64D1A605C3F}" type="slidenum">
               <a:rPr lang="en-US" sz="1400" b="0" u="none" strike="noStrike">
                 <a:solidFill>
                   <a:schemeClr val="dk1"/>
@@ -2587,7 +2779,7 @@
       </p:grpSpPr>
       <p:sp>
         <p:nvSpPr>
-          <p:cNvPr id="151" name="PlaceHolder 1"/>
+          <p:cNvPr id="152" name="PlaceHolder 1"/>
           <p:cNvSpPr>
             <a:spLocks noGrp="1"/>
           </p:cNvSpPr>
@@ -2610,7 +2802,7 @@
       </p:sp>
       <p:sp>
         <p:nvSpPr>
-          <p:cNvPr id="152" name="PlaceHolder 2"/>
+          <p:cNvPr id="153" name="PlaceHolder 2"/>
           <p:cNvSpPr>
             <a:spLocks noGrp="1"/>
           </p:cNvSpPr>
@@ -2648,6 +2840,30 @@
                 <a:uFillTx/>
                 <a:latin typeface="Arial"/>
               </a:rPr>
+              <a:t>NavTitle: Brug naar §1.1.2</a:t>
+            </a:r>
+            <a:endParaRPr lang="en-US" sz="2000" b="0" u="none" strike="noStrike">
+              <a:solidFill>
+                <a:srgbClr val="000000"/>
+              </a:solidFill>
+              <a:effectLst/>
+              <a:uFillTx/>
+              <a:latin typeface="Arial"/>
+            </a:endParaRPr>
+          </a:p>
+          <a:p>
+            <a:pPr indent="0" algn="l">
+              <a:buNone/>
+            </a:pPr>
+            <a:r>
+              <a:rPr lang="en-US" sz="1400" b="0" u="none" strike="noStrike">
+                <a:solidFill>
+                  <a:srgbClr val="000000"/>
+                </a:solidFill>
+                <a:effectLst/>
+                <a:uFillTx/>
+                <a:latin typeface="Arial"/>
+              </a:rPr>
               <a:t>Vraag:    Hoe vergelijk je eigenlijk het plezier van een film met dat van een boek — of tarwe met maïs?</a:t>
             </a:r>
             <a:endParaRPr lang="en-US" sz="2000" b="0" u="none" strike="noStrike">
@@ -2738,7 +2954,7 @@
       </p:sp>
       <p:sp>
         <p:nvSpPr>
-          <p:cNvPr id="153" name="PlaceHolder 3"/>
+          <p:cNvPr id="154" name="PlaceHolder 3"/>
           <p:cNvSpPr>
             <a:spLocks noGrp="1"/>
           </p:cNvSpPr>
@@ -2787,7 +3003,7 @@
               </a:lnSpc>
               <a:buNone/>
             </a:pPr>
-            <a:fld id="{9B9E917E-42D8-42DE-9FF9-2A6E5959FFA5}" type="slidenum">
+            <a:fld id="{4B8B4511-8DAF-40C0-BC29-5FFEFC425677}" type="slidenum">
               <a:rPr lang="en-US" sz="1400" b="0" u="none" strike="noStrike">
                 <a:solidFill>
                   <a:schemeClr val="dk1"/>
@@ -4711,7 +4927,68 @@
       </p:sp>
       <p:sp>
         <p:nvSpPr>
-          <p:cNvPr id="26" name="Shape 3"/>
+          <p:cNvPr id="26" name="Text 3"/>
+          <p:cNvSpPr/>
+          <p:nvPr/>
+        </p:nvSpPr>
+        <p:spPr>
+          <a:xfrm>
+            <a:off x="457200" y="1783080"/>
+            <a:ext cx="8229240" cy="292320"/>
+          </a:xfrm>
+          <a:prstGeom prst="rect">
+            <a:avLst/>
+          </a:prstGeom>
+          <a:noFill/>
+          <a:ln w="0">
+            <a:noFill/>
+          </a:ln>
+        </p:spPr>
+        <p:style>
+          <a:lnRef idx="0"/>
+          <a:fillRef idx="0"/>
+          <a:effectRef idx="0"/>
+          <a:fontRef idx="minor"/>
+        </p:style>
+        <p:txBody>
+          <a:bodyPr lIns="90000" tIns="45000" rIns="90000" bIns="45000" anchor="ctr">
+            <a:noAutofit/>
+          </a:bodyPr>
+          <a:p>
+            <a:pPr defTabSz="914400">
+              <a:lnSpc>
+                <a:spcPct val="100000"/>
+              </a:lnSpc>
+              <a:tabLst>
+                <a:tab pos="0" algn="l"/>
+              </a:tabLst>
+            </a:pPr>
+            <a:r>
+              <a:rPr lang="en-US" sz="1400" b="1" u="none" strike="noStrike">
+                <a:solidFill>
+                  <a:srgbClr val="0B1B3D"/>
+                </a:solidFill>
+                <a:effectLst/>
+                <a:uFillTx/>
+                <a:latin typeface="Segoe UI"/>
+                <a:ea typeface="Segoe UI"/>
+              </a:rPr>
+              <a:t>Na deze les kun je: schaarste herkennen · alternatieve kosten bepalen · nettowaarde beoordelen.</a:t>
+            </a:r>
+            <a:endParaRPr lang="en-US" sz="1400" b="0" u="none" strike="noStrike">
+              <a:solidFill>
+                <a:srgbClr val="000000"/>
+              </a:solidFill>
+              <a:effectLst/>
+              <a:uFillTx/>
+              <a:latin typeface="Arial"/>
+            </a:endParaRPr>
+          </a:p>
+        </p:txBody>
+      </p:sp>
+      <p:sp>
+        <p:nvSpPr>
+          <p:cNvPr id="27" name="Shape 4"/>
           <p:cNvSpPr/>
           <p:nvPr/>
         </p:nvSpPr>
@@ -4757,7 +5034,7 @@
       </p:sp>
       <p:sp>
         <p:nvSpPr>
-          <p:cNvPr id="27" name="Shape 4"/>
+          <p:cNvPr id="28" name="Shape 5"/>
           <p:cNvSpPr/>
           <p:nvPr/>
         </p:nvSpPr>
@@ -4800,7 +5077,7 @@
       </p:sp>
       <p:sp>
         <p:nvSpPr>
-          <p:cNvPr id="28" name="Text 5"/>
+          <p:cNvPr id="29" name="Text 6"/>
           <p:cNvSpPr/>
           <p:nvPr/>
         </p:nvSpPr>
@@ -4861,7 +5138,7 @@
       </p:sp>
       <p:sp>
         <p:nvSpPr>
-          <p:cNvPr id="29" name="Text 6"/>
+          <p:cNvPr id="30" name="Text 7"/>
           <p:cNvSpPr/>
           <p:nvPr/>
         </p:nvSpPr>
@@ -4922,7 +5199,7 @@
       </p:sp>
       <p:sp>
         <p:nvSpPr>
-          <p:cNvPr id="30" name="Text 7"/>
+          <p:cNvPr id="31" name="Text 8"/>
           <p:cNvSpPr/>
           <p:nvPr/>
         </p:nvSpPr>
@@ -4983,7 +5260,7 @@
       </p:sp>
       <p:sp>
         <p:nvSpPr>
-          <p:cNvPr id="31" name="Text 8"/>
+          <p:cNvPr id="32" name="Text 9"/>
           <p:cNvSpPr/>
           <p:nvPr/>
         </p:nvSpPr>
@@ -5044,7 +5321,7 @@
       </p:sp>
       <p:sp>
         <p:nvSpPr>
-          <p:cNvPr id="32" name="Shape 9"/>
+          <p:cNvPr id="33" name="Shape 10"/>
           <p:cNvSpPr/>
           <p:nvPr/>
         </p:nvSpPr>
@@ -5090,7 +5367,7 @@
       </p:sp>
       <p:sp>
         <p:nvSpPr>
-          <p:cNvPr id="33" name="Shape 10"/>
+          <p:cNvPr id="34" name="Shape 11"/>
           <p:cNvSpPr/>
           <p:nvPr/>
         </p:nvSpPr>
@@ -5133,7 +5410,7 @@
       </p:sp>
       <p:sp>
         <p:nvSpPr>
-          <p:cNvPr id="34" name="Text 11"/>
+          <p:cNvPr id="35" name="Text 12"/>
           <p:cNvSpPr/>
           <p:nvPr/>
         </p:nvSpPr>
@@ -5194,7 +5471,7 @@
       </p:sp>
       <p:sp>
         <p:nvSpPr>
-          <p:cNvPr id="35" name="Text 12"/>
+          <p:cNvPr id="36" name="Text 13"/>
           <p:cNvSpPr/>
           <p:nvPr/>
         </p:nvSpPr>
@@ -5255,7 +5532,7 @@
       </p:sp>
       <p:sp>
         <p:nvSpPr>
-          <p:cNvPr id="36" name="Text 13"/>
+          <p:cNvPr id="37" name="Text 14"/>
           <p:cNvSpPr/>
           <p:nvPr/>
         </p:nvSpPr>
@@ -5316,7 +5593,7 @@
       </p:sp>
       <p:sp>
         <p:nvSpPr>
-          <p:cNvPr id="37" name="Text 14"/>
+          <p:cNvPr id="38" name="Text 15"/>
           <p:cNvSpPr/>
           <p:nvPr/>
         </p:nvSpPr>
@@ -5377,7 +5654,7 @@
       </p:sp>
       <p:sp>
         <p:nvSpPr>
-          <p:cNvPr id="38" name="Shape 15"/>
+          <p:cNvPr id="39" name="Shape 16"/>
           <p:cNvSpPr/>
           <p:nvPr/>
         </p:nvSpPr>
@@ -5420,7 +5697,7 @@
       </p:sp>
       <p:sp>
         <p:nvSpPr>
-          <p:cNvPr id="39" name="Text 16"/>
+          <p:cNvPr id="40" name="Text 17"/>
           <p:cNvSpPr/>
           <p:nvPr/>
         </p:nvSpPr>
@@ -5511,7 +5788,7 @@
       </p:grpSpPr>
       <p:sp>
         <p:nvSpPr>
-          <p:cNvPr id="40" name="Text 0"/>
+          <p:cNvPr id="41" name="Text 0"/>
           <p:cNvSpPr/>
           <p:nvPr/>
         </p:nvSpPr>
@@ -5572,7 +5849,7 @@
       </p:sp>
       <p:sp>
         <p:nvSpPr>
-          <p:cNvPr id="41" name="Text 1"/>
+          <p:cNvPr id="42" name="Text 1"/>
           <p:cNvSpPr/>
           <p:nvPr/>
         </p:nvSpPr>
@@ -5633,7 +5910,7 @@
       </p:sp>
       <p:sp>
         <p:nvSpPr>
-          <p:cNvPr id="42" name="Shape 2"/>
+          <p:cNvPr id="43" name="Shape 2"/>
           <p:cNvSpPr/>
           <p:nvPr/>
         </p:nvSpPr>
@@ -5676,7 +5953,7 @@
       </p:sp>
       <p:sp>
         <p:nvSpPr>
-          <p:cNvPr id="43" name="Shape 3"/>
+          <p:cNvPr id="44" name="Shape 3"/>
           <p:cNvSpPr/>
           <p:nvPr/>
         </p:nvSpPr>
@@ -5719,7 +5996,7 @@
       </p:sp>
       <p:sp>
         <p:nvSpPr>
-          <p:cNvPr id="44" name="Text 4"/>
+          <p:cNvPr id="45" name="Text 4"/>
           <p:cNvSpPr/>
           <p:nvPr/>
         </p:nvSpPr>
@@ -5780,7 +6057,7 @@
       </p:sp>
       <p:pic>
         <p:nvPicPr>
-          <p:cNvPr id="45" name="Image 0" descr="Infographic: brede behoeften-trechter (zakgeld, vrije tijd, ruimte, aandacht) loopt door een schaarste-filter naar een smal keuze-uitstroompunt — illustreert dat behoeften groter zijn dan beschikbare middelen."/>
+          <p:cNvPr id="46" name="Image 0" descr="Infographic: brede behoeften-trechter (zakgeld, vrije tijd, ruimte, aandacht) loopt door een schaarste-filter naar een smal keuze-uitstroompunt — illustreert dat behoeften groter zijn dan beschikbare middelen."/>
           <p:cNvPicPr/>
           <p:nvPr/>
         </p:nvPicPr>
@@ -5834,7 +6111,7 @@
       </p:grpSpPr>
       <p:sp>
         <p:nvSpPr>
-          <p:cNvPr id="46" name="Text 0"/>
+          <p:cNvPr id="47" name="Text 0"/>
           <p:cNvSpPr/>
           <p:nvPr/>
         </p:nvSpPr>
@@ -5895,7 +6172,7 @@
       </p:sp>
       <p:sp>
         <p:nvSpPr>
-          <p:cNvPr id="47" name="Text 1"/>
+          <p:cNvPr id="48" name="Text 1"/>
           <p:cNvSpPr/>
           <p:nvPr/>
         </p:nvSpPr>
@@ -5956,7 +6233,7 @@
       </p:sp>
       <p:sp>
         <p:nvSpPr>
-          <p:cNvPr id="48" name="Shape 2"/>
+          <p:cNvPr id="49" name="Shape 2"/>
           <p:cNvSpPr/>
           <p:nvPr/>
         </p:nvSpPr>
@@ -5999,7 +6276,7 @@
       </p:sp>
       <p:sp>
         <p:nvSpPr>
-          <p:cNvPr id="49" name="Shape 3"/>
+          <p:cNvPr id="50" name="Shape 3"/>
           <p:cNvSpPr/>
           <p:nvPr/>
         </p:nvSpPr>
@@ -6042,7 +6319,7 @@
       </p:sp>
       <p:sp>
         <p:nvSpPr>
-          <p:cNvPr id="50" name="Text 4"/>
+          <p:cNvPr id="51" name="Text 4"/>
           <p:cNvSpPr/>
           <p:nvPr/>
         </p:nvSpPr>
@@ -6103,7 +6380,7 @@
       </p:sp>
       <p:pic>
         <p:nvPicPr>
-          <p:cNvPr id="51" name="Image 0" descr="Keuzediagram met twee alternatieven naast elkaar; de gekozen optie levert de opbrengst, het beste niet-gekozen alternatief wordt aangewezen als de alternatieve kosten."/>
+          <p:cNvPr id="52" name="Image 0" descr="Keuzediagram met twee alternatieven naast elkaar; de gekozen optie levert de opbrengst, het beste niet-gekozen alternatief wordt aangewezen als de alternatieve kosten."/>
           <p:cNvPicPr/>
           <p:nvPr/>
         </p:nvPicPr>
@@ -6157,7 +6434,7 @@
       </p:grpSpPr>
       <p:sp>
         <p:nvSpPr>
-          <p:cNvPr id="52" name="Text 0"/>
+          <p:cNvPr id="53" name="Text 0"/>
           <p:cNvSpPr/>
           <p:nvPr/>
         </p:nvSpPr>
@@ -6218,7 +6495,7 @@
       </p:sp>
       <p:sp>
         <p:nvSpPr>
-          <p:cNvPr id="53" name="Text 1"/>
+          <p:cNvPr id="54" name="Text 1"/>
           <p:cNvSpPr/>
           <p:nvPr/>
         </p:nvSpPr>
@@ -6279,7 +6556,7 @@
       </p:sp>
       <p:sp>
         <p:nvSpPr>
-          <p:cNvPr id="54" name="Shape 2"/>
+          <p:cNvPr id="55" name="Shape 2"/>
           <p:cNvSpPr/>
           <p:nvPr/>
         </p:nvSpPr>
@@ -6325,7 +6602,7 @@
       </p:sp>
       <p:sp>
         <p:nvSpPr>
-          <p:cNvPr id="55" name="Shape 3"/>
+          <p:cNvPr id="56" name="Shape 3"/>
           <p:cNvSpPr/>
           <p:nvPr/>
         </p:nvSpPr>
@@ -6368,7 +6645,7 @@
       </p:sp>
       <p:sp>
         <p:nvSpPr>
-          <p:cNvPr id="56" name="Text 4"/>
+          <p:cNvPr id="57" name="Text 4"/>
           <p:cNvSpPr/>
           <p:nvPr/>
         </p:nvSpPr>
@@ -6429,7 +6706,7 @@
       </p:sp>
       <p:sp>
         <p:nvSpPr>
-          <p:cNvPr id="57" name="Text 5"/>
+          <p:cNvPr id="58" name="Text 5"/>
           <p:cNvSpPr/>
           <p:nvPr/>
         </p:nvSpPr>
@@ -6490,7 +6767,7 @@
       </p:sp>
       <p:sp>
         <p:nvSpPr>
-          <p:cNvPr id="58" name="Text 6"/>
+          <p:cNvPr id="59" name="Text 6"/>
           <p:cNvSpPr/>
           <p:nvPr/>
         </p:nvSpPr>
@@ -6551,7 +6828,7 @@
       </p:sp>
       <p:sp>
         <p:nvSpPr>
-          <p:cNvPr id="59" name="Shape 7"/>
+          <p:cNvPr id="60" name="Shape 7"/>
           <p:cNvSpPr/>
           <p:nvPr/>
         </p:nvSpPr>
@@ -6597,7 +6874,7 @@
       </p:sp>
       <p:sp>
         <p:nvSpPr>
-          <p:cNvPr id="60" name="Shape 8"/>
+          <p:cNvPr id="61" name="Shape 8"/>
           <p:cNvSpPr/>
           <p:nvPr/>
         </p:nvSpPr>
@@ -6640,7 +6917,7 @@
       </p:sp>
       <p:sp>
         <p:nvSpPr>
-          <p:cNvPr id="61" name="Text 9"/>
+          <p:cNvPr id="62" name="Text 9"/>
           <p:cNvSpPr/>
           <p:nvPr/>
         </p:nvSpPr>
@@ -6701,7 +6978,7 @@
       </p:sp>
       <p:sp>
         <p:nvSpPr>
-          <p:cNvPr id="62" name="Text 10"/>
+          <p:cNvPr id="63" name="Text 10"/>
           <p:cNvSpPr/>
           <p:nvPr/>
         </p:nvSpPr>
@@ -6762,7 +7039,7 @@
       </p:sp>
       <p:sp>
         <p:nvSpPr>
-          <p:cNvPr id="63" name="Text 11"/>
+          <p:cNvPr id="64" name="Text 11"/>
           <p:cNvSpPr/>
           <p:nvPr/>
         </p:nvSpPr>
@@ -6823,7 +7100,7 @@
       </p:sp>
       <p:sp>
         <p:nvSpPr>
-          <p:cNvPr id="64" name="Shape 12"/>
+          <p:cNvPr id="65" name="Shape 12"/>
           <p:cNvSpPr/>
           <p:nvPr/>
         </p:nvSpPr>
@@ -6869,7 +7146,7 @@
       </p:sp>
       <p:sp>
         <p:nvSpPr>
-          <p:cNvPr id="65" name="Shape 13"/>
+          <p:cNvPr id="66" name="Shape 13"/>
           <p:cNvSpPr/>
           <p:nvPr/>
         </p:nvSpPr>
@@ -6912,7 +7189,7 @@
       </p:sp>
       <p:sp>
         <p:nvSpPr>
-          <p:cNvPr id="66" name="Text 14"/>
+          <p:cNvPr id="67" name="Text 14"/>
           <p:cNvSpPr/>
           <p:nvPr/>
         </p:nvSpPr>
@@ -6973,7 +7250,7 @@
       </p:sp>
       <p:sp>
         <p:nvSpPr>
-          <p:cNvPr id="67" name="Text 15"/>
+          <p:cNvPr id="68" name="Text 15"/>
           <p:cNvSpPr/>
           <p:nvPr/>
         </p:nvSpPr>
@@ -7034,7 +7311,7 @@
       </p:sp>
       <p:sp>
         <p:nvSpPr>
-          <p:cNvPr id="68" name="Text 16"/>
+          <p:cNvPr id="69" name="Text 16"/>
           <p:cNvSpPr/>
           <p:nvPr/>
         </p:nvSpPr>
@@ -7095,7 +7372,7 @@
       </p:sp>
       <p:sp>
         <p:nvSpPr>
-          <p:cNvPr id="69" name="Shape 17"/>
+          <p:cNvPr id="70" name="Shape 17"/>
           <p:cNvSpPr/>
           <p:nvPr/>
         </p:nvSpPr>
@@ -7141,7 +7418,7 @@
       </p:sp>
       <p:sp>
         <p:nvSpPr>
-          <p:cNvPr id="70" name="Shape 18"/>
+          <p:cNvPr id="71" name="Shape 18"/>
           <p:cNvSpPr/>
           <p:nvPr/>
         </p:nvSpPr>
@@ -7184,7 +7461,7 @@
       </p:sp>
       <p:sp>
         <p:nvSpPr>
-          <p:cNvPr id="71" name="Text 19"/>
+          <p:cNvPr id="72" name="Text 19"/>
           <p:cNvSpPr/>
           <p:nvPr/>
         </p:nvSpPr>
@@ -7245,7 +7522,7 @@
       </p:sp>
       <p:sp>
         <p:nvSpPr>
-          <p:cNvPr id="72" name="Text 20"/>
+          <p:cNvPr id="73" name="Text 20"/>
           <p:cNvSpPr/>
           <p:nvPr/>
         </p:nvSpPr>
@@ -7306,7 +7583,7 @@
       </p:sp>
       <p:sp>
         <p:nvSpPr>
-          <p:cNvPr id="73" name="Text 21"/>
+          <p:cNvPr id="74" name="Text 21"/>
           <p:cNvSpPr/>
           <p:nvPr/>
         </p:nvSpPr>
@@ -7367,7 +7644,7 @@
       </p:sp>
       <p:pic>
         <p:nvPicPr>
-          <p:cNvPr id="74" name="Image 0" descr="Flowchart van de vier stappen om alternatieve kosten en nettowaarde te bepalen: (1) alternatieven benoemen, (2) opbrengst per alternatief berekenen, (3) beste niet-gekozen alternatief = alternatieve kosten, (4) nettowaarde = opbrengst gekozen min alternatieve kosten."/>
+          <p:cNvPr id="75" name="Image 0" descr="Flowchart van de vier stappen om alternatieve kosten en nettowaarde te bepalen: (1) alternatieven benoemen, (2) opbrengst per alternatief berekenen, (3) beste niet-gekozen alternatief = alternatieve kosten, (4) nettowaarde = opbrengst gekozen min alternatieve kosten."/>
           <p:cNvPicPr/>
           <p:nvPr/>
         </p:nvPicPr>
@@ -7391,7 +7668,7 @@
       </p:pic>
       <p:sp>
         <p:nvSpPr>
-          <p:cNvPr id="75" name="Text 22"/>
+          <p:cNvPr id="76" name="Text 22"/>
           <p:cNvSpPr/>
           <p:nvPr/>
         </p:nvSpPr>
@@ -7452,7 +7729,7 @@
       </p:sp>
       <p:sp>
         <p:nvSpPr>
-          <p:cNvPr id="76" name="Shape 23"/>
+          <p:cNvPr id="77" name="Shape 23"/>
           <p:cNvSpPr/>
           <p:nvPr/>
         </p:nvSpPr>
@@ -7495,7 +7772,7 @@
       </p:sp>
       <p:sp>
         <p:nvSpPr>
-          <p:cNvPr id="77" name="Text 24"/>
+          <p:cNvPr id="78" name="Text 24"/>
           <p:cNvSpPr/>
           <p:nvPr/>
         </p:nvSpPr>
@@ -7541,7 +7818,7 @@
                 <a:latin typeface="Georgia"/>
                 <a:ea typeface="Georgia"/>
               </a:rPr>
-              <a:t>Verstandig = opbrengst &gt; alternatieve kosten.</a:t>
+              <a:t>Volgens deze maat: opbrengst &gt; alternatieve kosten.</a:t>
             </a:r>
             <a:endParaRPr lang="en-US" sz="1600" b="0" u="none" strike="noStrike">
               <a:solidFill>
@@ -7586,7 +7863,7 @@
       </p:grpSpPr>
       <p:sp>
         <p:nvSpPr>
-          <p:cNvPr id="78" name="Text 0"/>
+          <p:cNvPr id="79" name="Text 0"/>
           <p:cNvSpPr/>
           <p:nvPr/>
         </p:nvSpPr>
@@ -7647,7 +7924,7 @@
       </p:sp>
       <p:sp>
         <p:nvSpPr>
-          <p:cNvPr id="79" name="Text 1"/>
+          <p:cNvPr id="80" name="Text 1"/>
           <p:cNvSpPr/>
           <p:nvPr/>
         </p:nvSpPr>
@@ -7693,7 +7970,7 @@
                 <a:latin typeface="Segoe UI"/>
                 <a:ea typeface="Segoe UI"/>
               </a:rPr>
-              <a:t>Wat levert elk gewas op?</a:t>
+              <a:t>Wat is de totale winst?</a:t>
             </a:r>
             <a:endParaRPr lang="en-US" sz="2800" b="0" u="none" strike="noStrike">
               <a:solidFill>
@@ -7708,7 +7985,7 @@
       </p:sp>
       <p:sp>
         <p:nvSpPr>
-          <p:cNvPr id="80" name="Shape 2"/>
+          <p:cNvPr id="81" name="Shape 2"/>
           <p:cNvSpPr/>
           <p:nvPr/>
         </p:nvSpPr>
@@ -7751,7 +8028,7 @@
       </p:sp>
       <p:sp>
         <p:nvSpPr>
-          <p:cNvPr id="81" name="Text 3"/>
+          <p:cNvPr id="82" name="Text 3"/>
           <p:cNvSpPr/>
           <p:nvPr/>
         </p:nvSpPr>
@@ -7812,7 +8089,7 @@
       </p:sp>
       <p:sp>
         <p:nvSpPr>
-          <p:cNvPr id="82" name="Text 4"/>
+          <p:cNvPr id="83" name="Text 4"/>
           <p:cNvSpPr/>
           <p:nvPr/>
         </p:nvSpPr>
@@ -7858,7 +8135,7 @@
                 <a:latin typeface="Segoe UI"/>
                 <a:ea typeface="Segoe UI"/>
               </a:rPr>
-              <a:t>€ / HECTARE</a:t>
+              <a:t>WINST / HA</a:t>
             </a:r>
             <a:endParaRPr lang="en-US" sz="1400" b="0" u="none" strike="noStrike">
               <a:solidFill>
@@ -7873,7 +8150,7 @@
       </p:sp>
       <p:sp>
         <p:nvSpPr>
-          <p:cNvPr id="83" name="Text 5"/>
+          <p:cNvPr id="84" name="Text 5"/>
           <p:cNvSpPr/>
           <p:nvPr/>
         </p:nvSpPr>
@@ -7934,7 +8211,7 @@
       </p:sp>
       <p:sp>
         <p:nvSpPr>
-          <p:cNvPr id="84" name="Shape 6"/>
+          <p:cNvPr id="85" name="Shape 6"/>
           <p:cNvSpPr/>
           <p:nvPr/>
         </p:nvSpPr>
@@ -7980,7 +8257,7 @@
       </p:sp>
       <p:sp>
         <p:nvSpPr>
-          <p:cNvPr id="85" name="Shape 7"/>
+          <p:cNvPr id="86" name="Shape 7"/>
           <p:cNvSpPr/>
           <p:nvPr/>
         </p:nvSpPr>
@@ -8023,7 +8300,7 @@
       </p:sp>
       <p:sp>
         <p:nvSpPr>
-          <p:cNvPr id="86" name="Text 8"/>
+          <p:cNvPr id="87" name="Text 8"/>
           <p:cNvSpPr/>
           <p:nvPr/>
         </p:nvSpPr>
@@ -8084,7 +8361,7 @@
       </p:sp>
       <p:sp>
         <p:nvSpPr>
-          <p:cNvPr id="87" name="Text 9"/>
+          <p:cNvPr id="88" name="Text 9"/>
           <p:cNvSpPr/>
           <p:nvPr/>
         </p:nvSpPr>
@@ -8145,7 +8422,7 @@
       </p:sp>
       <p:sp>
         <p:nvSpPr>
-          <p:cNvPr id="88" name="Text 10"/>
+          <p:cNvPr id="89" name="Text 10"/>
           <p:cNvSpPr/>
           <p:nvPr/>
         </p:nvSpPr>
@@ -8206,7 +8483,7 @@
       </p:sp>
       <p:sp>
         <p:nvSpPr>
-          <p:cNvPr id="89" name="Shape 11"/>
+          <p:cNvPr id="90" name="Shape 11"/>
           <p:cNvSpPr/>
           <p:nvPr/>
         </p:nvSpPr>
@@ -8252,7 +8529,7 @@
       </p:sp>
       <p:sp>
         <p:nvSpPr>
-          <p:cNvPr id="90" name="Shape 12"/>
+          <p:cNvPr id="91" name="Shape 12"/>
           <p:cNvSpPr/>
           <p:nvPr/>
         </p:nvSpPr>
@@ -8295,7 +8572,7 @@
       </p:sp>
       <p:sp>
         <p:nvSpPr>
-          <p:cNvPr id="91" name="Text 13"/>
+          <p:cNvPr id="92" name="Text 13"/>
           <p:cNvSpPr/>
           <p:nvPr/>
         </p:nvSpPr>
@@ -8356,7 +8633,7 @@
       </p:sp>
       <p:sp>
         <p:nvSpPr>
-          <p:cNvPr id="92" name="Text 14"/>
+          <p:cNvPr id="93" name="Text 14"/>
           <p:cNvSpPr/>
           <p:nvPr/>
         </p:nvSpPr>
@@ -8417,7 +8694,7 @@
       </p:sp>
       <p:sp>
         <p:nvSpPr>
-          <p:cNvPr id="93" name="Text 15"/>
+          <p:cNvPr id="94" name="Text 15"/>
           <p:cNvSpPr/>
           <p:nvPr/>
         </p:nvSpPr>
@@ -8478,7 +8755,7 @@
       </p:sp>
       <p:pic>
         <p:nvPicPr>
-          <p:cNvPr id="94" name="Image 0" descr="Uitgewerkt voorbeeld tarwe versus maïs op 10 hectare: tarwe levert €500 per hectare op (totaal €5.000), maïs €350 per hectare (totaal €3.500); de alternatieve kosten van tarwe kiezen zijn €3.500 en de nettowaarde €1.500."/>
+          <p:cNvPr id="95" name="Image 0" descr="Uitgewerkt voorbeeld tarwe versus maïs op 10 hectare: tarwe levert €500 per hectare op (totaal €5.000), maïs €350 per hectare (totaal €3.500); de alternatieve kosten van tarwe kiezen zijn €3.500 en de nettowaarde €1.500."/>
           <p:cNvPicPr/>
           <p:nvPr/>
         </p:nvPicPr>
@@ -8532,7 +8809,7 @@
       </p:grpSpPr>
       <p:sp>
         <p:nvSpPr>
-          <p:cNvPr id="95" name="Text 0"/>
+          <p:cNvPr id="96" name="Text 0"/>
           <p:cNvSpPr/>
           <p:nvPr/>
         </p:nvSpPr>
@@ -8593,7 +8870,7 @@
       </p:sp>
       <p:sp>
         <p:nvSpPr>
-          <p:cNvPr id="96" name="Text 1"/>
+          <p:cNvPr id="97" name="Text 1"/>
           <p:cNvSpPr/>
           <p:nvPr/>
         </p:nvSpPr>
@@ -8654,7 +8931,7 @@
       </p:sp>
       <p:sp>
         <p:nvSpPr>
-          <p:cNvPr id="97" name="Shape 2"/>
+          <p:cNvPr id="98" name="Shape 2"/>
           <p:cNvSpPr/>
           <p:nvPr/>
         </p:nvSpPr>
@@ -8697,7 +8974,7 @@
       </p:sp>
       <p:sp>
         <p:nvSpPr>
-          <p:cNvPr id="98" name="Shape 3"/>
+          <p:cNvPr id="99" name="Shape 3"/>
           <p:cNvSpPr/>
           <p:nvPr/>
         </p:nvSpPr>
@@ -8740,7 +9017,7 @@
       </p:sp>
       <p:sp>
         <p:nvSpPr>
-          <p:cNvPr id="99" name="Text 4"/>
+          <p:cNvPr id="100" name="Text 4"/>
           <p:cNvSpPr/>
           <p:nvPr/>
         </p:nvSpPr>
@@ -8801,7 +9078,7 @@
       </p:sp>
       <p:sp>
         <p:nvSpPr>
-          <p:cNvPr id="100" name="Text 5"/>
+          <p:cNvPr id="101" name="Text 5"/>
           <p:cNvSpPr/>
           <p:nvPr/>
         </p:nvSpPr>
@@ -8862,7 +9139,7 @@
       </p:sp>
       <p:sp>
         <p:nvSpPr>
-          <p:cNvPr id="101" name="Text 6"/>
+          <p:cNvPr id="102" name="Text 6"/>
           <p:cNvSpPr/>
           <p:nvPr/>
         </p:nvSpPr>
@@ -8908,7 +9185,7 @@
                 <a:latin typeface="Georgia"/>
                 <a:ea typeface="Georgia"/>
               </a:rPr>
-              <a:t>de maïsopbrengst die hij laat liggen</a:t>
+              <a:t>de totale winst met maïs die hij laat liggen</a:t>
             </a:r>
             <a:endParaRPr lang="en-US" sz="1800" b="0" u="none" strike="noStrike">
               <a:solidFill>
@@ -8923,7 +9200,7 @@
       </p:sp>
       <p:pic>
         <p:nvPicPr>
-          <p:cNvPr id="102" name="Image 0" descr="Uitgewerkt voorbeeld tarwe versus maïs op 10 hectare: tarwe levert €500 per hectare op (totaal €5.000), maïs €350 per hectare (totaal €3.500); de alternatieve kosten van tarwe kiezen zijn €3.500 en de nettowaarde €1.500."/>
+          <p:cNvPr id="103" name="Image 0" descr="Uitgewerkt voorbeeld tarwe versus maïs op 10 hectare: tarwe levert €500 per hectare op (totaal €5.000), maïs €350 per hectare (totaal €3.500); de alternatieve kosten van tarwe kiezen zijn €3.500 en de nettowaarde €1.500."/>
           <p:cNvPicPr/>
           <p:nvPr/>
         </p:nvPicPr>
@@ -8977,7 +9254,7 @@
       </p:grpSpPr>
       <p:sp>
         <p:nvSpPr>
-          <p:cNvPr id="103" name="Text 0"/>
+          <p:cNvPr id="104" name="Text 0"/>
           <p:cNvSpPr/>
           <p:nvPr/>
         </p:nvSpPr>
@@ -9038,7 +9315,7 @@
       </p:sp>
       <p:sp>
         <p:nvSpPr>
-          <p:cNvPr id="104" name="Text 1"/>
+          <p:cNvPr id="105" name="Text 1"/>
           <p:cNvSpPr/>
           <p:nvPr/>
         </p:nvSpPr>
@@ -9099,7 +9376,7 @@
       </p:sp>
       <p:sp>
         <p:nvSpPr>
-          <p:cNvPr id="105" name="Text 2"/>
+          <p:cNvPr id="106" name="Text 2"/>
           <p:cNvSpPr/>
           <p:nvPr/>
         </p:nvSpPr>
@@ -9160,7 +9437,7 @@
       </p:sp>
       <p:sp>
         <p:nvSpPr>
-          <p:cNvPr id="106" name="Text 3"/>
+          <p:cNvPr id="107" name="Text 3"/>
           <p:cNvSpPr/>
           <p:nvPr/>
         </p:nvSpPr>
@@ -9221,7 +9498,7 @@
       </p:sp>
       <p:sp>
         <p:nvSpPr>
-          <p:cNvPr id="107" name="Shape 4"/>
+          <p:cNvPr id="108" name="Shape 4"/>
           <p:cNvSpPr/>
           <p:nvPr/>
         </p:nvSpPr>
@@ -9264,7 +9541,7 @@
       </p:sp>
       <p:sp>
         <p:nvSpPr>
-          <p:cNvPr id="108" name="Text 5"/>
+          <p:cNvPr id="109" name="Text 5"/>
           <p:cNvSpPr/>
           <p:nvPr/>
         </p:nvSpPr>
@@ -9325,7 +9602,7 @@
       </p:sp>
       <p:sp>
         <p:nvSpPr>
-          <p:cNvPr id="109" name="Text 6"/>
+          <p:cNvPr id="110" name="Text 6"/>
           <p:cNvSpPr/>
           <p:nvPr/>
         </p:nvSpPr>
@@ -9386,7 +9663,7 @@
       </p:sp>
       <p:sp>
         <p:nvSpPr>
-          <p:cNvPr id="110" name="Shape 7"/>
+          <p:cNvPr id="111" name="Shape 7"/>
           <p:cNvSpPr/>
           <p:nvPr/>
         </p:nvSpPr>
@@ -9429,7 +9706,7 @@
       </p:sp>
       <p:sp>
         <p:nvSpPr>
-          <p:cNvPr id="111" name="Text 8"/>
+          <p:cNvPr id="112" name="Text 8"/>
           <p:cNvSpPr/>
           <p:nvPr/>
         </p:nvSpPr>
@@ -9490,7 +9767,7 @@
       </p:sp>
       <p:sp>
         <p:nvSpPr>
-          <p:cNvPr id="112" name="Text 9"/>
+          <p:cNvPr id="113" name="Text 9"/>
           <p:cNvSpPr/>
           <p:nvPr/>
         </p:nvSpPr>
@@ -9536,7 +9813,7 @@
                 <a:latin typeface="Segoe UI"/>
                 <a:ea typeface="Segoe UI"/>
               </a:rPr>
-              <a:t>Economisch denken = vier stappen: (1) alternatieven, (2) opbrengsten, (3) rangschik (= alternatieve kosten), (4) nettowaarde.</a:t>
+              <a:t>Economisch denken in vier stappen: alternatieven, opbrengsten, rangschik, nettowaarde.</a:t>
             </a:r>
             <a:endParaRPr lang="en-US" sz="1800" b="0" u="none" strike="noStrike">
               <a:solidFill>
@@ -9551,7 +9828,7 @@
       </p:sp>
       <p:sp>
         <p:nvSpPr>
-          <p:cNvPr id="113" name="Shape 10"/>
+          <p:cNvPr id="114" name="Shape 10"/>
           <p:cNvSpPr/>
           <p:nvPr/>
         </p:nvSpPr>
@@ -9594,7 +9871,7 @@
       </p:sp>
       <p:sp>
         <p:nvSpPr>
-          <p:cNvPr id="114" name="Text 11"/>
+          <p:cNvPr id="115" name="Text 11"/>
           <p:cNvSpPr/>
           <p:nvPr/>
         </p:nvSpPr>
@@ -9655,7 +9932,7 @@
       </p:sp>
       <p:sp>
         <p:nvSpPr>
-          <p:cNvPr id="115" name="Text 12"/>
+          <p:cNvPr id="116" name="Text 12"/>
           <p:cNvSpPr/>
           <p:nvPr/>
         </p:nvSpPr>
@@ -9716,7 +9993,7 @@
       </p:sp>
       <p:sp>
         <p:nvSpPr>
-          <p:cNvPr id="116" name="Shape 13"/>
+          <p:cNvPr id="117" name="Shape 13"/>
           <p:cNvSpPr/>
           <p:nvPr/>
         </p:nvSpPr>
@@ -9759,7 +10036,7 @@
       </p:sp>
       <p:sp>
         <p:nvSpPr>
-          <p:cNvPr id="117" name="Text 14"/>
+          <p:cNvPr id="118" name="Text 14"/>
           <p:cNvSpPr/>
           <p:nvPr/>
         </p:nvSpPr>
@@ -9820,7 +10097,7 @@
       </p:sp>
       <p:sp>
         <p:nvSpPr>
-          <p:cNvPr id="118" name="Text 15"/>
+          <p:cNvPr id="119" name="Text 15"/>
           <p:cNvSpPr/>
           <p:nvPr/>
         </p:nvSpPr>
@@ -9911,7 +10188,7 @@
       </p:grpSpPr>
       <p:sp>
         <p:nvSpPr>
-          <p:cNvPr id="119" name="Text 0"/>
+          <p:cNvPr id="120" name="Text 0"/>
           <p:cNvSpPr/>
           <p:nvPr/>
         </p:nvSpPr>
@@ -9972,7 +10249,7 @@
       </p:sp>
       <p:sp>
         <p:nvSpPr>
-          <p:cNvPr id="120" name="Text 1"/>
+          <p:cNvPr id="121" name="Text 1"/>
           <p:cNvSpPr/>
           <p:nvPr/>
         </p:nvSpPr>
@@ -10033,7 +10310,7 @@
       </p:sp>
       <p:sp>
         <p:nvSpPr>
-          <p:cNvPr id="121" name="Shape 2"/>
+          <p:cNvPr id="122" name="Shape 2"/>
           <p:cNvSpPr/>
           <p:nvPr/>
         </p:nvSpPr>
@@ -10076,7 +10353,7 @@
       </p:sp>
       <p:sp>
         <p:nvSpPr>
-          <p:cNvPr id="122" name="Text 3"/>
+          <p:cNvPr id="123" name="Text 3"/>
           <p:cNvSpPr/>
           <p:nvPr/>
         </p:nvSpPr>
@@ -10137,7 +10414,7 @@
       </p:sp>
       <p:sp>
         <p:nvSpPr>
-          <p:cNvPr id="123" name="Shape 4"/>
+          <p:cNvPr id="124" name="Shape 4"/>
           <p:cNvSpPr/>
           <p:nvPr/>
         </p:nvSpPr>
@@ -10180,7 +10457,7 @@
       </p:sp>
       <p:sp>
         <p:nvSpPr>
-          <p:cNvPr id="124" name="Shape 5"/>
+          <p:cNvPr id="125" name="Shape 5"/>
           <p:cNvSpPr/>
           <p:nvPr/>
         </p:nvSpPr>
@@ -10223,7 +10500,7 @@
       </p:sp>
       <p:sp>
         <p:nvSpPr>
-          <p:cNvPr id="125" name="Text 6"/>
+          <p:cNvPr id="126" name="Text 6"/>
           <p:cNvSpPr/>
           <p:nvPr/>
         </p:nvSpPr>
@@ -10284,7 +10561,7 @@
       </p:sp>
       <p:sp>
         <p:nvSpPr>
-          <p:cNvPr id="126" name="Text 7"/>
+          <p:cNvPr id="127" name="Text 7"/>
           <p:cNvSpPr/>
           <p:nvPr/>
         </p:nvSpPr>

</xml_diff>

<commit_message>
Regenerate presentation PPTX outputs
</commit_message>
<xml_diff>
--- a/Boek 1 - Grondslagen, vraag en aanbod/1.1 Hoofdstuk Economisch denken en rekenen/1.1.1 Schaarste en economisch denken/1.1.1 Schaarste en economisch denken – presentatie.pptx
+++ b/Boek 1 - Grondslagen, vraag en aanbod/1.1 Hoofdstuk Economisch denken en rekenen/1.1.1 Schaarste en economisch denken/1.1.1 Schaarste en economisch denken – presentatie.pptx
@@ -374,7 +374,7 @@
             <a:pPr indent="0" algn="r">
               <a:buNone/>
             </a:pPr>
-            <a:fld id="{76F8B84C-A548-4F10-9D38-64F11FDDC94A}" type="slidenum">
+            <a:fld id="{1C046D76-6527-4277-A579-F3DEA8CA8657}" type="slidenum">
               <a:rPr lang="en-US" sz="1400" b="0" u="none" strike="noStrike">
                 <a:solidFill>
                   <a:srgbClr val="000000"/>
@@ -521,17 +521,6 @@
             <a:pPr indent="0" algn="l">
               <a:buNone/>
             </a:pPr>
-            <a:r>
-              <a:rPr lang="en-US" sz="1400" b="0" u="none" strike="noStrike">
-                <a:solidFill>
-                  <a:srgbClr val="000000"/>
-                </a:solidFill>
-                <a:effectLst/>
-                <a:uFillTx/>
-                <a:latin typeface="Arial"/>
-              </a:rPr>
-              <a:t>Rol: route_contract</a:t>
-            </a:r>
             <a:endParaRPr lang="en-US" sz="2000" b="0" u="none" strike="noStrike">
               <a:solidFill>
                 <a:srgbClr val="000000"/>
@@ -554,7 +543,7 @@
                 <a:uFillTx/>
                 <a:latin typeface="Arial"/>
               </a:rPr>
-              <a:t>Layout: routeContract</a:t>
+              <a:t>Vraag:</a:t>
             </a:r>
             <a:endParaRPr lang="en-US" sz="2000" b="0" u="none" strike="noStrike">
               <a:solidFill>
@@ -569,6 +558,17 @@
             <a:pPr indent="0" algn="l">
               <a:buNone/>
             </a:pPr>
+            <a:r>
+              <a:rPr lang="en-US" sz="1400" b="0" u="none" strike="noStrike">
+                <a:solidFill>
+                  <a:srgbClr val="000000"/>
+                </a:solidFill>
+                <a:effectLst/>
+                <a:uFillTx/>
+                <a:latin typeface="Arial"/>
+              </a:rPr>
+              <a:t>Route: eerst Lisa, daarna het begrip, daarna de boer.</a:t>
+            </a:r>
             <a:endParaRPr lang="en-US" sz="2000" b="0" u="none" strike="noStrike">
               <a:solidFill>
                 <a:srgbClr val="000000"/>
@@ -582,17 +582,6 @@
             <a:pPr indent="0" algn="l">
               <a:buNone/>
             </a:pPr>
-            <a:r>
-              <a:rPr lang="en-US" sz="1400" b="0" u="none" strike="noStrike">
-                <a:solidFill>
-                  <a:srgbClr val="000000"/>
-                </a:solidFill>
-                <a:effectLst/>
-                <a:uFillTx/>
-                <a:latin typeface="Arial"/>
-              </a:rPr>
-              <a:t>Kernzin:</a:t>
-            </a:r>
             <a:endParaRPr lang="en-US" sz="2000" b="0" u="none" strike="noStrike">
               <a:solidFill>
                 <a:srgbClr val="000000"/>
@@ -615,7 +604,7 @@
                 <a:uFillTx/>
                 <a:latin typeface="Arial"/>
               </a:rPr>
-              <a:t>Aan het einde kun je een keuzeprobleem herkennen, de alternatieve kosten aanwijzen en een keuze in vier stappen beoordelen.</a:t>
+              <a:t>Uitleg:</a:t>
             </a:r>
             <a:endParaRPr lang="en-US" sz="2000" b="0" u="none" strike="noStrike">
               <a:solidFill>
@@ -630,6 +619,17 @@
             <a:pPr indent="0" algn="l">
               <a:buNone/>
             </a:pPr>
+            <a:r>
+              <a:rPr lang="en-US" sz="1400" b="0" u="none" strike="noStrike">
+                <a:solidFill>
+                  <a:srgbClr val="000000"/>
+                </a:solidFill>
+                <a:effectLst/>
+                <a:uFillTx/>
+                <a:latin typeface="Arial"/>
+              </a:rPr>
+              <a:t>- Aan het einde kun je een keuzeprobleem herkennen, de alternatieve kosten aanwijzen en een keuze in vier stappen beoordelen.</a:t>
+            </a:r>
             <a:endParaRPr lang="en-US" sz="2000" b="0" u="none" strike="noStrike">
               <a:solidFill>
                 <a:srgbClr val="000000"/>
@@ -652,7 +652,7 @@
                 <a:uFillTx/>
                 <a:latin typeface="Arial"/>
               </a:rPr>
-              <a:t>Studentuitleg:</a:t>
+              <a:t>- Deze les gaat over één centrale vraag: wat kost een keuze echt? Niet alleen in euro's, maar vooral in wat je niet meer kunt doen nadat je gekozen hebt.</a:t>
             </a:r>
             <a:endParaRPr lang="en-US" sz="2000" b="0" u="none" strike="noStrike">
               <a:solidFill>
@@ -676,7 +676,7 @@
                 <a:uFillTx/>
                 <a:latin typeface="Arial"/>
               </a:rPr>
-              <a:t>- Deze les gaat over één centrale vraag: wat kost een keuze echt? Niet alleen in euro's, maar vooral in wat je niet meer kunt doen nadat je gekozen hebt.</a:t>
+              <a:t>- Laat leerlingen de route in eigen woorden voorspellen: van Lisa naar begrip naar boer.</a:t>
             </a:r>
             <a:endParaRPr lang="en-US" sz="2000" b="0" u="none" strike="noStrike">
               <a:solidFill>
@@ -691,17 +691,6 @@
             <a:pPr indent="0" algn="l">
               <a:buNone/>
             </a:pPr>
-            <a:r>
-              <a:rPr lang="en-US" sz="1400" b="0" u="none" strike="noStrike">
-                <a:solidFill>
-                  <a:srgbClr val="000000"/>
-                </a:solidFill>
-                <a:effectLst/>
-                <a:uFillTx/>
-                <a:latin typeface="Arial"/>
-              </a:rPr>
-              <a:t>- Je leert drie dingen. Eerst herken je schaarste: mensen willen meer dan de middelen toelaten. Daarna leer je alternatieve kosten: de opbrengst van het beste alternatief dat je niet kiest. Ten slotte gebruik je een vaste procedure om een keuze netjes te beoordelen.</a:t>
-            </a:r>
             <a:endParaRPr lang="en-US" sz="2000" b="0" u="none" strike="noStrike">
               <a:solidFill>
                 <a:srgbClr val="000000"/>
@@ -724,7 +713,7 @@
                 <a:uFillTx/>
                 <a:latin typeface="Arial"/>
               </a:rPr>
-              <a:t>- Wat je straks moet kunnen: bij een voorbeeld aanwijzen: het schaarse middel, de alternatieven, het gekozen alternatief, het beste niet-gekozen alternatief en de nettowaarde.</a:t>
+              <a:t>Pitfall:</a:t>
             </a:r>
             <a:endParaRPr lang="en-US" sz="2000" b="0" u="none" strike="noStrike">
               <a:solidFill>
@@ -739,6 +728,17 @@
             <a:pPr indent="0" algn="l">
               <a:buNone/>
             </a:pPr>
+            <a:r>
+              <a:rPr lang="en-US" sz="1400" b="0" u="none" strike="noStrike">
+                <a:solidFill>
+                  <a:srgbClr val="000000"/>
+                </a:solidFill>
+                <a:effectLst/>
+                <a:uFillTx/>
+                <a:latin typeface="Arial"/>
+              </a:rPr>
+              <a:t>Geen specifieke valkuil.</a:t>
+            </a:r>
             <a:endParaRPr lang="en-US" sz="2000" b="0" u="none" strike="noStrike">
               <a:solidFill>
                 <a:srgbClr val="000000"/>
@@ -752,17 +752,6 @@
             <a:pPr indent="0" algn="l">
               <a:buNone/>
             </a:pPr>
-            <a:r>
-              <a:rPr lang="en-US" sz="1400" b="0" u="none" strike="noStrike">
-                <a:solidFill>
-                  <a:srgbClr val="000000"/>
-                </a:solidFill>
-                <a:effectLst/>
-                <a:uFillTx/>
-                <a:latin typeface="Arial"/>
-              </a:rPr>
-              <a:t>Docentcue:</a:t>
-            </a:r>
             <a:endParaRPr lang="en-US" sz="2000" b="0" u="none" strike="noStrike">
               <a:solidFill>
                 <a:srgbClr val="000000"/>
@@ -785,166 +774,7 @@
                 <a:uFillTx/>
                 <a:latin typeface="Arial"/>
               </a:rPr>
-              <a:t>- Laat leerlingen de route in eigen woorden voorspellen: van Lisa naar begrip naar boer.</a:t>
-            </a:r>
-            <a:endParaRPr lang="en-US" sz="2000" b="0" u="none" strike="noStrike">
-              <a:solidFill>
-                <a:srgbClr val="000000"/>
-              </a:solidFill>
-              <a:effectLst/>
-              <a:uFillTx/>
-              <a:latin typeface="Arial"/>
-            </a:endParaRPr>
-          </a:p>
-          <a:p>
-            <a:pPr indent="0" algn="l">
-              <a:buNone/>
-            </a:pPr>
-            <a:endParaRPr lang="en-US" sz="2000" b="0" u="none" strike="noStrike">
-              <a:solidFill>
-                <a:srgbClr val="000000"/>
-              </a:solidFill>
-              <a:effectLst/>
-              <a:uFillTx/>
-              <a:latin typeface="Arial"/>
-            </a:endParaRPr>
-          </a:p>
-          <a:p>
-            <a:pPr indent="0" algn="l">
-              <a:buNone/>
-            </a:pPr>
-            <a:r>
-              <a:rPr lang="en-US" sz="1400" b="0" u="none" strike="noStrike">
-                <a:solidFill>
-                  <a:srgbClr val="000000"/>
-                </a:solidFill>
-                <a:effectLst/>
-                <a:uFillTx/>
-                <a:latin typeface="Arial"/>
-              </a:rPr>
               <a:t>Overgang:</a:t>
-            </a:r>
-            <a:endParaRPr lang="en-US" sz="2000" b="0" u="none" strike="noStrike">
-              <a:solidFill>
-                <a:srgbClr val="000000"/>
-              </a:solidFill>
-              <a:effectLst/>
-              <a:uFillTx/>
-              <a:latin typeface="Arial"/>
-            </a:endParaRPr>
-          </a:p>
-          <a:p>
-            <a:pPr indent="0" algn="l">
-              <a:buNone/>
-            </a:pPr>
-            <a:r>
-              <a:rPr lang="en-US" sz="1400" b="0" u="none" strike="noStrike">
-                <a:solidFill>
-                  <a:srgbClr val="000000"/>
-                </a:solidFill>
-                <a:effectLst/>
-                <a:uFillTx/>
-                <a:latin typeface="Arial"/>
-              </a:rPr>
-              <a:t>We starten met Lisa, omdat haar keuze klein genoeg is om het patroon scherp te zien.</a:t>
-            </a:r>
-            <a:endParaRPr lang="en-US" sz="2000" b="0" u="none" strike="noStrike">
-              <a:solidFill>
-                <a:srgbClr val="000000"/>
-              </a:solidFill>
-              <a:effectLst/>
-              <a:uFillTx/>
-              <a:latin typeface="Arial"/>
-            </a:endParaRPr>
-          </a:p>
-          <a:p>
-            <a:pPr indent="0" algn="l">
-              <a:buNone/>
-            </a:pPr>
-            <a:endParaRPr lang="en-US" sz="2000" b="0" u="none" strike="noStrike">
-              <a:solidFill>
-                <a:srgbClr val="000000"/>
-              </a:solidFill>
-              <a:effectLst/>
-              <a:uFillTx/>
-              <a:latin typeface="Arial"/>
-            </a:endParaRPr>
-          </a:p>
-          <a:p>
-            <a:pPr indent="0" algn="l">
-              <a:buNone/>
-            </a:pPr>
-            <a:r>
-              <a:rPr lang="en-US" sz="1400" b="0" u="none" strike="noStrike">
-                <a:solidFill>
-                  <a:srgbClr val="000000"/>
-                </a:solidFill>
-                <a:effectLst/>
-                <a:uFillTx/>
-                <a:latin typeface="Arial"/>
-              </a:rPr>
-              <a:t>Visual:</a:t>
-            </a:r>
-            <a:endParaRPr lang="en-US" sz="2000" b="0" u="none" strike="noStrike">
-              <a:solidFill>
-                <a:srgbClr val="000000"/>
-              </a:solidFill>
-              <a:effectLst/>
-              <a:uFillTx/>
-              <a:latin typeface="Arial"/>
-            </a:endParaRPr>
-          </a:p>
-          <a:p>
-            <a:pPr indent="0" algn="l">
-              <a:buNone/>
-            </a:pPr>
-            <a:r>
-              <a:rPr lang="en-US" sz="1400" b="0" u="none" strike="noStrike">
-                <a:solidFill>
-                  <a:srgbClr val="000000"/>
-                </a:solidFill>
-                <a:effectLst/>
-                <a:uFillTx/>
-                <a:latin typeface="Arial"/>
-              </a:rPr>
-              <a:t>Drie routekaarten zetten de lesvolgorde neer: voorbeeld, begrip, toepassing.</a:t>
-            </a:r>
-            <a:endParaRPr lang="en-US" sz="2000" b="0" u="none" strike="noStrike">
-              <a:solidFill>
-                <a:srgbClr val="000000"/>
-              </a:solidFill>
-              <a:effectLst/>
-              <a:uFillTx/>
-              <a:latin typeface="Arial"/>
-            </a:endParaRPr>
-          </a:p>
-          <a:p>
-            <a:pPr indent="0" algn="l">
-              <a:buNone/>
-            </a:pPr>
-            <a:endParaRPr lang="en-US" sz="2000" b="0" u="none" strike="noStrike">
-              <a:solidFill>
-                <a:srgbClr val="000000"/>
-              </a:solidFill>
-              <a:effectLst/>
-              <a:uFillTx/>
-              <a:latin typeface="Arial"/>
-            </a:endParaRPr>
-          </a:p>
-          <a:p>
-            <a:pPr indent="0" algn="l">
-              <a:buNone/>
-            </a:pPr>
-            <a:r>
-              <a:rPr lang="en-US" sz="1400" b="0" u="none" strike="noStrike">
-                <a:solidFill>
-                  <a:srgbClr val="000000"/>
-                </a:solidFill>
-                <a:effectLst/>
-                <a:uFillTx/>
-                <a:latin typeface="Arial"/>
-              </a:rPr>
-              <a:t>Actie op de dia:</a:t>
             </a:r>
             <a:endParaRPr lang="en-US" sz="2000" b="0" u="none" strike="noStrike">
               <a:solidFill>
@@ -971,7 +801,7 @@
                 <a:uFillTx/>
                 <a:latin typeface="Arial"/>
               </a:rPr>
-              <a:t>Route: eerst Lisa, daarna het begrip, daarna de boer.</a:t>
+              <a:t>We starten met Lisa, omdat haar keuze klein genoeg is om het patroon scherp te zien.</a:t>
             </a:r>
             <a:endParaRPr lang="en-US" sz="2000" b="0" u="none" strike="noStrike">
               <a:solidFill>
@@ -1035,7 +865,7 @@
               </a:lnSpc>
               <a:buNone/>
             </a:pPr>
-            <a:fld id="{C14B2AB8-CCBE-42DA-A3B5-93EE9301A69F}" type="slidenum">
+            <a:fld id="{D2F98409-F010-47D6-8191-17EE5CD1E6B6}" type="slidenum">
               <a:rPr lang="en-US" sz="1400" b="0" u="none" strike="noStrike">
                 <a:solidFill>
                   <a:schemeClr val="dk1"/>
@@ -1182,17 +1012,6 @@
             <a:pPr indent="0" algn="l">
               <a:buNone/>
             </a:pPr>
-            <a:r>
-              <a:rPr lang="en-US" sz="1400" b="0" u="none" strike="noStrike">
-                <a:solidFill>
-                  <a:srgbClr val="000000"/>
-                </a:solidFill>
-                <a:effectLst/>
-                <a:uFillTx/>
-                <a:latin typeface="Arial"/>
-              </a:rPr>
-              <a:t>Rol: retrieval_check</a:t>
-            </a:r>
             <a:endParaRPr lang="en-US" sz="2000" b="0" u="none" strike="noStrike">
               <a:solidFill>
                 <a:srgbClr val="000000"/>
@@ -1215,7 +1034,7 @@
                 <a:uFillTx/>
                 <a:latin typeface="Arial"/>
               </a:rPr>
-              <a:t>Layout: retrievalCheck</a:t>
+              <a:t>Vraag:</a:t>
             </a:r>
             <a:endParaRPr lang="en-US" sz="2000" b="0" u="none" strike="noStrike">
               <a:solidFill>
@@ -1230,6 +1049,17 @@
             <a:pPr indent="0" algn="l">
               <a:buNone/>
             </a:pPr>
+            <a:r>
+              <a:rPr lang="en-US" sz="1400" b="0" u="none" strike="noStrike">
+                <a:solidFill>
+                  <a:srgbClr val="000000"/>
+                </a:solidFill>
+                <a:effectLst/>
+                <a:uFillTx/>
+                <a:latin typeface="Arial"/>
+              </a:rPr>
+              <a:t>Beantwoord eerst zelf, controleer daarna.</a:t>
+            </a:r>
             <a:endParaRPr lang="en-US" sz="2000" b="0" u="none" strike="noStrike">
               <a:solidFill>
                 <a:srgbClr val="000000"/>
@@ -1243,17 +1073,6 @@
             <a:pPr indent="0" algn="l">
               <a:buNone/>
             </a:pPr>
-            <a:r>
-              <a:rPr lang="en-US" sz="1400" b="0" u="none" strike="noStrike">
-                <a:solidFill>
-                  <a:srgbClr val="000000"/>
-                </a:solidFill>
-                <a:effectLst/>
-                <a:uFillTx/>
-                <a:latin typeface="Arial"/>
-              </a:rPr>
-              <a:t>Kernzin:</a:t>
-            </a:r>
             <a:endParaRPr lang="en-US" sz="2000" b="0" u="none" strike="noStrike">
               <a:solidFill>
                 <a:srgbClr val="000000"/>
@@ -1276,7 +1095,7 @@
                 <a:uFillTx/>
                 <a:latin typeface="Arial"/>
               </a:rPr>
-              <a:t>Je begrijpt het pas echt als je het patroon zelf kunt invullen.</a:t>
+              <a:t>Uitleg:</a:t>
             </a:r>
             <a:endParaRPr lang="en-US" sz="2000" b="0" u="none" strike="noStrike">
               <a:solidFill>
@@ -1291,6 +1110,17 @@
             <a:pPr indent="0" algn="l">
               <a:buNone/>
             </a:pPr>
+            <a:r>
+              <a:rPr lang="en-US" sz="1400" b="0" u="none" strike="noStrike">
+                <a:solidFill>
+                  <a:srgbClr val="000000"/>
+                </a:solidFill>
+                <a:effectLst/>
+                <a:uFillTx/>
+                <a:latin typeface="Arial"/>
+              </a:rPr>
+              <a:t>- Je begrijpt het pas echt als je het patroon zelf kunt invullen.</a:t>
+            </a:r>
             <a:endParaRPr lang="en-US" sz="2000" b="0" u="none" strike="noStrike">
               <a:solidFill>
                 <a:srgbClr val="000000"/>
@@ -1313,7 +1143,7 @@
                 <a:uFillTx/>
                 <a:latin typeface="Arial"/>
               </a:rPr>
-              <a:t>Studentuitleg:</a:t>
+              <a:t>- Laat leerlingen eerst individueel invullen en open daarna de antwoorden per kaart.</a:t>
             </a:r>
             <a:endParaRPr lang="en-US" sz="2000" b="0" u="none" strike="noStrike">
               <a:solidFill>
@@ -1328,17 +1158,6 @@
             <a:pPr indent="0" algn="l">
               <a:buNone/>
             </a:pPr>
-            <a:r>
-              <a:rPr lang="en-US" sz="1400" b="0" u="none" strike="noStrike">
-                <a:solidFill>
-                  <a:srgbClr val="000000"/>
-                </a:solidFill>
-                <a:effectLst/>
-                <a:uFillTx/>
-                <a:latin typeface="Arial"/>
-              </a:rPr>
-              <a:t>- Deze check gebruikt precies dezelfde volgorde als de uitleg: eerst het schaarse middel, daarna het beste niet-gekozen alternatief, daarna de alternatieve kosten.</a:t>
-            </a:r>
             <a:endParaRPr lang="en-US" sz="2000" b="0" u="none" strike="noStrike">
               <a:solidFill>
                 <a:srgbClr val="000000"/>
@@ -1361,7 +1180,7 @@
                 <a:uFillTx/>
                 <a:latin typeface="Arial"/>
               </a:rPr>
-              <a:t>- Probeer de antwoorden eerst zonder terugkijken. Daarna controleer je of je het begrip of alleen het voorbeeld hebt onthouden.</a:t>
+              <a:t>Pitfall:</a:t>
             </a:r>
             <a:endParaRPr lang="en-US" sz="2000" b="0" u="none" strike="noStrike">
               <a:solidFill>
@@ -1385,7 +1204,7 @@
                 <a:uFillTx/>
                 <a:latin typeface="Arial"/>
               </a:rPr>
-              <a:t>- Als je bij vraag 2 de prijs noemt, ga terug naar de definitie: alternatieve kosten zijn de waarde van wat je opgeeft.</a:t>
+              <a:t>Geen specifieke valkuil.</a:t>
             </a:r>
             <a:endParaRPr lang="en-US" sz="2000" b="0" u="none" strike="noStrike">
               <a:solidFill>
@@ -1422,7 +1241,7 @@
                 <a:uFillTx/>
                 <a:latin typeface="Arial"/>
               </a:rPr>
-              <a:t>Docentcue:</a:t>
+              <a:t>Antwoord:</a:t>
             </a:r>
             <a:endParaRPr lang="en-US" sz="2000" b="0" u="none" strike="noStrike">
               <a:solidFill>
@@ -1446,7 +1265,7 @@
                 <a:uFillTx/>
                 <a:latin typeface="Arial"/>
               </a:rPr>
-              <a:t>- Laat leerlingen eerst individueel invullen en open daarna de antwoorden per kaart.</a:t>
+              <a:t>- 1. Lisa’s €20.</a:t>
             </a:r>
             <a:endParaRPr lang="en-US" sz="2000" b="0" u="none" strike="noStrike">
               <a:solidFill>
@@ -1461,6 +1280,17 @@
             <a:pPr indent="0" algn="l">
               <a:buNone/>
             </a:pPr>
+            <a:r>
+              <a:rPr lang="en-US" sz="1400" b="0" u="none" strike="noStrike">
+                <a:solidFill>
+                  <a:srgbClr val="000000"/>
+                </a:solidFill>
+                <a:effectLst/>
+                <a:uFillTx/>
+                <a:latin typeface="Arial"/>
+              </a:rPr>
+              <a:t>- 2. Het boek lezen, met de waarde die dat voor haar heeft.</a:t>
+            </a:r>
             <a:endParaRPr lang="en-US" sz="2000" b="0" u="none" strike="noStrike">
               <a:solidFill>
                 <a:srgbClr val="000000"/>
@@ -1483,7 +1313,7 @@
                 <a:uFillTx/>
                 <a:latin typeface="Arial"/>
               </a:rPr>
-              <a:t>Overgang:</a:t>
+              <a:t>- 3. De opbrengst van maïs: €3.500.</a:t>
             </a:r>
             <a:endParaRPr lang="en-US" sz="2000" b="0" u="none" strike="noStrike">
               <a:solidFill>
@@ -1498,17 +1328,6 @@
             <a:pPr indent="0" algn="l">
               <a:buNone/>
             </a:pPr>
-            <a:r>
-              <a:rPr lang="en-US" sz="1400" b="0" u="none" strike="noStrike">
-                <a:solidFill>
-                  <a:srgbClr val="000000"/>
-                </a:solidFill>
-                <a:effectLst/>
-                <a:uFillTx/>
-                <a:latin typeface="Arial"/>
-              </a:rPr>
-              <a:t>We sluiten af met de kernzinnen die de volgende opgave dragen.</a:t>
-            </a:r>
             <a:endParaRPr lang="en-US" sz="2000" b="0" u="none" strike="noStrike">
               <a:solidFill>
                 <a:srgbClr val="000000"/>
@@ -1522,19 +1341,6 @@
             <a:pPr indent="0" algn="l">
               <a:buNone/>
             </a:pPr>
-            <a:endParaRPr lang="en-US" sz="2000" b="0" u="none" strike="noStrike">
-              <a:solidFill>
-                <a:srgbClr val="000000"/>
-              </a:solidFill>
-              <a:effectLst/>
-              <a:uFillTx/>
-              <a:latin typeface="Arial"/>
-            </a:endParaRPr>
-          </a:p>
-          <a:p>
-            <a:pPr indent="0" algn="l">
-              <a:buNone/>
-            </a:pPr>
             <a:r>
               <a:rPr lang="en-US" sz="1400" b="0" u="none" strike="noStrike">
                 <a:solidFill>
@@ -1544,7 +1350,7 @@
                 <a:uFillTx/>
                 <a:latin typeface="Arial"/>
               </a:rPr>
-              <a:t>Actie op de dia:</a:t>
+              <a:t>Overgang:</a:t>
             </a:r>
             <a:endParaRPr lang="en-US" sz="2000" b="0" u="none" strike="noStrike">
               <a:solidFill>
@@ -1571,7 +1377,7 @@
                 <a:uFillTx/>
                 <a:latin typeface="Arial"/>
               </a:rPr>
-              <a:t>Beantwoord eerst zelf, controleer daarna.</a:t>
+              <a:t>We sluiten af met de kernzinnen die de volgende opgave dragen.</a:t>
             </a:r>
             <a:endParaRPr lang="en-US" sz="2000" b="0" u="none" strike="noStrike">
               <a:solidFill>
@@ -1635,7 +1441,7 @@
               </a:lnSpc>
               <a:buNone/>
             </a:pPr>
-            <a:fld id="{86359418-4C80-41D6-9DEA-687619DD0D27}" type="slidenum">
+            <a:fld id="{12D1ACBB-9B4E-4323-856A-1560CECE6887}" type="slidenum">
               <a:rPr lang="en-US" sz="1400" b="0" u="none" strike="noStrike">
                 <a:solidFill>
                   <a:schemeClr val="dk1"/>
@@ -1782,17 +1588,6 @@
             <a:pPr indent="0" algn="l">
               <a:buNone/>
             </a:pPr>
-            <a:r>
-              <a:rPr lang="en-US" sz="1400" b="0" u="none" strike="noStrike">
-                <a:solidFill>
-                  <a:srgbClr val="000000"/>
-                </a:solidFill>
-                <a:effectLst/>
-                <a:uFillTx/>
-                <a:latin typeface="Arial"/>
-              </a:rPr>
-              <a:t>Rol: summary_bridge</a:t>
-            </a:r>
             <a:endParaRPr lang="en-US" sz="2000" b="0" u="none" strike="noStrike">
               <a:solidFill>
                 <a:srgbClr val="000000"/>
@@ -1815,7 +1610,7 @@
                 <a:uFillTx/>
                 <a:latin typeface="Arial"/>
               </a:rPr>
-              <a:t>Layout: summaryBridge</a:t>
+              <a:t>Vraag:</a:t>
             </a:r>
             <a:endParaRPr lang="en-US" sz="2000" b="0" u="none" strike="noStrike">
               <a:solidFill>
@@ -1830,6 +1625,17 @@
             <a:pPr indent="0" algn="l">
               <a:buNone/>
             </a:pPr>
+            <a:r>
+              <a:rPr lang="en-US" sz="1400" b="0" u="none" strike="noStrike">
+                <a:solidFill>
+                  <a:srgbClr val="000000"/>
+                </a:solidFill>
+                <a:effectLst/>
+                <a:uFillTx/>
+                <a:latin typeface="Arial"/>
+              </a:rPr>
+              <a:t>Gebruik deze samenvatting als brug naar de volgende opgave.</a:t>
+            </a:r>
             <a:endParaRPr lang="en-US" sz="2000" b="0" u="none" strike="noStrike">
               <a:solidFill>
                 <a:srgbClr val="000000"/>
@@ -1843,17 +1649,6 @@
             <a:pPr indent="0" algn="l">
               <a:buNone/>
             </a:pPr>
-            <a:r>
-              <a:rPr lang="en-US" sz="1400" b="0" u="none" strike="noStrike">
-                <a:solidFill>
-                  <a:srgbClr val="000000"/>
-                </a:solidFill>
-                <a:effectLst/>
-                <a:uFillTx/>
-                <a:latin typeface="Arial"/>
-              </a:rPr>
-              <a:t>Kernzin:</a:t>
-            </a:r>
             <a:endParaRPr lang="en-US" sz="2000" b="0" u="none" strike="noStrike">
               <a:solidFill>
                 <a:srgbClr val="000000"/>
@@ -1876,7 +1671,7 @@
                 <a:uFillTx/>
                 <a:latin typeface="Arial"/>
               </a:rPr>
-              <a:t>Met deze vijf zinnen vat je de basis van §1.1.1 samen.</a:t>
+              <a:t>Uitleg:</a:t>
             </a:r>
             <a:endParaRPr lang="en-US" sz="2000" b="0" u="none" strike="noStrike">
               <a:solidFill>
@@ -1891,6 +1686,17 @@
             <a:pPr indent="0" algn="l">
               <a:buNone/>
             </a:pPr>
+            <a:r>
+              <a:rPr lang="en-US" sz="1400" b="0" u="none" strike="noStrike">
+                <a:solidFill>
+                  <a:srgbClr val="000000"/>
+                </a:solidFill>
+                <a:effectLst/>
+                <a:uFillTx/>
+                <a:latin typeface="Arial"/>
+              </a:rPr>
+              <a:t>- Met deze vijf zinnen vat je de basis van §1.1.1 samen.</a:t>
+            </a:r>
             <a:endParaRPr lang="en-US" sz="2000" b="0" u="none" strike="noStrike">
               <a:solidFill>
                 <a:srgbClr val="000000"/>
@@ -1913,7 +1719,7 @@
                 <a:uFillTx/>
                 <a:latin typeface="Arial"/>
               </a:rPr>
-              <a:t>Studentuitleg:</a:t>
+              <a:t>- Schaarste ontstaat wanneer behoeften groter zijn dan middelen.</a:t>
             </a:r>
             <a:endParaRPr lang="en-US" sz="2000" b="0" u="none" strike="noStrike">
               <a:solidFill>
@@ -1937,7 +1743,7 @@
                 <a:uFillTx/>
                 <a:latin typeface="Arial"/>
               </a:rPr>
-              <a:t>- Schaarste ontstaat wanneer behoeften groter zijn dan middelen.</a:t>
+              <a:t>- Kiezen betekent dat je minstens één alternatief niet kiest.</a:t>
             </a:r>
             <a:endParaRPr lang="en-US" sz="2000" b="0" u="none" strike="noStrike">
               <a:solidFill>
@@ -1961,7 +1767,7 @@
                 <a:uFillTx/>
                 <a:latin typeface="Arial"/>
               </a:rPr>
-              <a:t>- Kiezen betekent dat je minstens één alternatief niet kiest.</a:t>
+              <a:t>- Laat één leerling elke zin koppelen aan een dia of voorbeeld uit de les.</a:t>
             </a:r>
             <a:endParaRPr lang="en-US" sz="2000" b="0" u="none" strike="noStrike">
               <a:solidFill>
@@ -1976,17 +1782,6 @@
             <a:pPr indent="0" algn="l">
               <a:buNone/>
             </a:pPr>
-            <a:r>
-              <a:rPr lang="en-US" sz="1400" b="0" u="none" strike="noStrike">
-                <a:solidFill>
-                  <a:srgbClr val="000000"/>
-                </a:solidFill>
-                <a:effectLst/>
-                <a:uFillTx/>
-                <a:latin typeface="Arial"/>
-              </a:rPr>
-              <a:t>- Alternatieve kosten zijn de waarde van het beste niet-gekozen alternatief.</a:t>
-            </a:r>
             <a:endParaRPr lang="en-US" sz="2000" b="0" u="none" strike="noStrike">
               <a:solidFill>
                 <a:srgbClr val="000000"/>
@@ -2009,7 +1804,7 @@
                 <a:uFillTx/>
                 <a:latin typeface="Arial"/>
               </a:rPr>
-              <a:t>- Bij berekeningen vergelijk je eerst de alternatieven en trek je daarna pas een conclusie.</a:t>
+              <a:t>Pitfall:</a:t>
             </a:r>
             <a:endParaRPr lang="en-US" sz="2000" b="0" u="none" strike="noStrike">
               <a:solidFill>
@@ -2033,7 +1828,7 @@
                 <a:uFillTx/>
                 <a:latin typeface="Arial"/>
               </a:rPr>
-              <a:t>- De kernvraag blijft: wat geef je op doordat je dit kiest?</a:t>
+              <a:t>Geen specifieke valkuil.</a:t>
             </a:r>
             <a:endParaRPr lang="en-US" sz="2000" b="0" u="none" strike="noStrike">
               <a:solidFill>
@@ -2070,129 +1865,7 @@
                 <a:uFillTx/>
                 <a:latin typeface="Arial"/>
               </a:rPr>
-              <a:t>Docentcue:</a:t>
-            </a:r>
-            <a:endParaRPr lang="en-US" sz="2000" b="0" u="none" strike="noStrike">
-              <a:solidFill>
-                <a:srgbClr val="000000"/>
-              </a:solidFill>
-              <a:effectLst/>
-              <a:uFillTx/>
-              <a:latin typeface="Arial"/>
-            </a:endParaRPr>
-          </a:p>
-          <a:p>
-            <a:pPr indent="0" algn="l">
-              <a:buNone/>
-            </a:pPr>
-            <a:r>
-              <a:rPr lang="en-US" sz="1400" b="0" u="none" strike="noStrike">
-                <a:solidFill>
-                  <a:srgbClr val="000000"/>
-                </a:solidFill>
-                <a:effectLst/>
-                <a:uFillTx/>
-                <a:latin typeface="Arial"/>
-              </a:rPr>
-              <a:t>- Laat één leerling elke zin koppelen aan een dia of voorbeeld uit de les.</a:t>
-            </a:r>
-            <a:endParaRPr lang="en-US" sz="2000" b="0" u="none" strike="noStrike">
-              <a:solidFill>
-                <a:srgbClr val="000000"/>
-              </a:solidFill>
-              <a:effectLst/>
-              <a:uFillTx/>
-              <a:latin typeface="Arial"/>
-            </a:endParaRPr>
-          </a:p>
-          <a:p>
-            <a:pPr indent="0" algn="l">
-              <a:buNone/>
-            </a:pPr>
-            <a:endParaRPr lang="en-US" sz="2000" b="0" u="none" strike="noStrike">
-              <a:solidFill>
-                <a:srgbClr val="000000"/>
-              </a:solidFill>
-              <a:effectLst/>
-              <a:uFillTx/>
-              <a:latin typeface="Arial"/>
-            </a:endParaRPr>
-          </a:p>
-          <a:p>
-            <a:pPr indent="0" algn="l">
-              <a:buNone/>
-            </a:pPr>
-            <a:r>
-              <a:rPr lang="en-US" sz="1400" b="0" u="none" strike="noStrike">
-                <a:solidFill>
-                  <a:srgbClr val="000000"/>
-                </a:solidFill>
-                <a:effectLst/>
-                <a:uFillTx/>
-                <a:latin typeface="Arial"/>
-              </a:rPr>
               <a:t>Overgang:</a:t>
-            </a:r>
-            <a:endParaRPr lang="en-US" sz="2000" b="0" u="none" strike="noStrike">
-              <a:solidFill>
-                <a:srgbClr val="000000"/>
-              </a:solidFill>
-              <a:effectLst/>
-              <a:uFillTx/>
-              <a:latin typeface="Arial"/>
-            </a:endParaRPr>
-          </a:p>
-          <a:p>
-            <a:pPr indent="0" algn="l">
-              <a:buNone/>
-            </a:pPr>
-            <a:r>
-              <a:rPr lang="en-US" sz="1400" b="0" u="none" strike="noStrike">
-                <a:solidFill>
-                  <a:srgbClr val="000000"/>
-                </a:solidFill>
-                <a:effectLst/>
-                <a:uFillTx/>
-                <a:latin typeface="Arial"/>
-              </a:rPr>
-              <a:t>Gebruik deze samenvatting als brug naar zelfstandige verwerking.</a:t>
-            </a:r>
-            <a:endParaRPr lang="en-US" sz="2000" b="0" u="none" strike="noStrike">
-              <a:solidFill>
-                <a:srgbClr val="000000"/>
-              </a:solidFill>
-              <a:effectLst/>
-              <a:uFillTx/>
-              <a:latin typeface="Arial"/>
-            </a:endParaRPr>
-          </a:p>
-          <a:p>
-            <a:pPr indent="0" algn="l">
-              <a:buNone/>
-            </a:pPr>
-            <a:endParaRPr lang="en-US" sz="2000" b="0" u="none" strike="noStrike">
-              <a:solidFill>
-                <a:srgbClr val="000000"/>
-              </a:solidFill>
-              <a:effectLst/>
-              <a:uFillTx/>
-              <a:latin typeface="Arial"/>
-            </a:endParaRPr>
-          </a:p>
-          <a:p>
-            <a:pPr indent="0" algn="l">
-              <a:buNone/>
-            </a:pPr>
-            <a:r>
-              <a:rPr lang="en-US" sz="1400" b="0" u="none" strike="noStrike">
-                <a:solidFill>
-                  <a:srgbClr val="000000"/>
-                </a:solidFill>
-                <a:effectLst/>
-                <a:uFillTx/>
-                <a:latin typeface="Arial"/>
-              </a:rPr>
-              <a:t>Actie op de dia:</a:t>
             </a:r>
             <a:endParaRPr lang="en-US" sz="2000" b="0" u="none" strike="noStrike">
               <a:solidFill>
@@ -2219,7 +1892,7 @@
                 <a:uFillTx/>
                 <a:latin typeface="Arial"/>
               </a:rPr>
-              <a:t>Gebruik deze samenvatting als brug naar de volgende opgave.</a:t>
+              <a:t>Gebruik deze samenvatting als brug naar zelfstandige verwerking.</a:t>
             </a:r>
             <a:endParaRPr lang="en-US" sz="2000" b="0" u="none" strike="noStrike">
               <a:solidFill>
@@ -2283,7 +1956,7 @@
               </a:lnSpc>
               <a:buNone/>
             </a:pPr>
-            <a:fld id="{EE6F6CF2-9F51-4CE7-9146-E95A0221B45A}" type="slidenum">
+            <a:fld id="{C804F74C-0343-4E1D-93E1-6197A63AA20E}" type="slidenum">
               <a:rPr lang="en-US" sz="1400" b="0" u="none" strike="noStrike">
                 <a:solidFill>
                   <a:schemeClr val="dk1"/>
@@ -2430,17 +2103,6 @@
             <a:pPr indent="0" algn="l">
               <a:buNone/>
             </a:pPr>
-            <a:r>
-              <a:rPr lang="en-US" sz="1400" b="0" u="none" strike="noStrike">
-                <a:solidFill>
-                  <a:srgbClr val="000000"/>
-                </a:solidFill>
-                <a:effectLst/>
-                <a:uFillTx/>
-                <a:latin typeface="Arial"/>
-              </a:rPr>
-              <a:t>Rol: narrative_anchor</a:t>
-            </a:r>
             <a:endParaRPr lang="en-US" sz="2000" b="0" u="none" strike="noStrike">
               <a:solidFill>
                 <a:srgbClr val="000000"/>
@@ -2463,7 +2125,7 @@
                 <a:uFillTx/>
                 <a:latin typeface="Arial"/>
               </a:rPr>
-              <a:t>Layout: narrativeAnchor</a:t>
+              <a:t>Vraag:</a:t>
             </a:r>
             <a:endParaRPr lang="en-US" sz="2000" b="0" u="none" strike="noStrike">
               <a:solidFill>
@@ -2478,6 +2140,17 @@
             <a:pPr indent="0" algn="l">
               <a:buNone/>
             </a:pPr>
+            <a:r>
+              <a:rPr lang="en-US" sz="1400" b="0" u="none" strike="noStrike">
+                <a:solidFill>
+                  <a:srgbClr val="000000"/>
+                </a:solidFill>
+                <a:effectLst/>
+                <a:uFillTx/>
+                <a:latin typeface="Arial"/>
+              </a:rPr>
+              <a:t>Luistervraag: welke twee alternatieven strijden om hetzelfde geld?</a:t>
+            </a:r>
             <a:endParaRPr lang="en-US" sz="2000" b="0" u="none" strike="noStrike">
               <a:solidFill>
                 <a:srgbClr val="000000"/>
@@ -2491,17 +2164,6 @@
             <a:pPr indent="0" algn="l">
               <a:buNone/>
             </a:pPr>
-            <a:r>
-              <a:rPr lang="en-US" sz="1400" b="0" u="none" strike="noStrike">
-                <a:solidFill>
-                  <a:srgbClr val="000000"/>
-                </a:solidFill>
-                <a:effectLst/>
-                <a:uFillTx/>
-                <a:latin typeface="Arial"/>
-              </a:rPr>
-              <a:t>Kernzin:</a:t>
-            </a:r>
             <a:endParaRPr lang="en-US" sz="2000" b="0" u="none" strike="noStrike">
               <a:solidFill>
                 <a:srgbClr val="000000"/>
@@ -2524,7 +2186,7 @@
                 <a:uFillTx/>
                 <a:latin typeface="Arial"/>
               </a:rPr>
-              <a:t>Het probleem is niet dat ze niets kan kopen. Het probleem is dat ze niet alles tegelijk kan kiezen.</a:t>
+              <a:t>Uitleg:</a:t>
             </a:r>
             <a:endParaRPr lang="en-US" sz="2000" b="0" u="none" strike="noStrike">
               <a:solidFill>
@@ -2539,6 +2201,17 @@
             <a:pPr indent="0" algn="l">
               <a:buNone/>
             </a:pPr>
+            <a:r>
+              <a:rPr lang="en-US" sz="1400" b="0" u="none" strike="noStrike">
+                <a:solidFill>
+                  <a:srgbClr val="000000"/>
+                </a:solidFill>
+                <a:effectLst/>
+                <a:uFillTx/>
+                <a:latin typeface="Arial"/>
+              </a:rPr>
+              <a:t>- Het probleem is niet dat ze niets kan kopen. Het probleem is dat ze niet alles tegelijk kan kiezen.</a:t>
+            </a:r>
             <a:endParaRPr lang="en-US" sz="2000" b="0" u="none" strike="noStrike">
               <a:solidFill>
                 <a:srgbClr val="000000"/>
@@ -2561,7 +2234,7 @@
                 <a:uFillTx/>
                 <a:latin typeface="Arial"/>
               </a:rPr>
-              <a:t>Studentuitleg:</a:t>
+              <a:t>- Lisa heeft een beperkt budget van €20. Ze wil naar de bioscoop voor €12 en ook een boek kopen van €15. Samen kost dat €27.</a:t>
             </a:r>
             <a:endParaRPr lang="en-US" sz="2000" b="0" u="none" strike="noStrike">
               <a:solidFill>
@@ -2585,7 +2258,7 @@
                 <a:uFillTx/>
                 <a:latin typeface="Arial"/>
               </a:rPr>
-              <a:t>- Lisa heeft een beperkt budget van €20. Ze wil naar de bioscoop voor €12 en ook een boek kopen van €15. Samen kost dat €27.</a:t>
+              <a:t>- Laat eerst het tekort uitrekenen en vraag daarna welke opties om hetzelfde geld concurreren.</a:t>
             </a:r>
             <a:endParaRPr lang="en-US" sz="2000" b="0" u="none" strike="noStrike">
               <a:solidFill>
@@ -2600,17 +2273,6 @@
             <a:pPr indent="0" algn="l">
               <a:buNone/>
             </a:pPr>
-            <a:r>
-              <a:rPr lang="en-US" sz="1400" b="0" u="none" strike="noStrike">
-                <a:solidFill>
-                  <a:srgbClr val="000000"/>
-                </a:solidFill>
-                <a:effectLst/>
-                <a:uFillTx/>
-                <a:latin typeface="Arial"/>
-              </a:rPr>
-              <a:t>- Omdat haar geld beperkt is, moet ze kiezen. De bioscoop en het boek strijden om hetzelfde middel: haar budget.</a:t>
-            </a:r>
             <a:endParaRPr lang="en-US" sz="2000" b="0" u="none" strike="noStrike">
               <a:solidFill>
                 <a:srgbClr val="000000"/>
@@ -2633,7 +2295,7 @@
                 <a:uFillTx/>
                 <a:latin typeface="Arial"/>
               </a:rPr>
-              <a:t>- Dit voorbeeld gebruiken we steeds opnieuw, zodat het begrip niet los blijft hangen.</a:t>
+              <a:t>Pitfall:</a:t>
             </a:r>
             <a:endParaRPr lang="en-US" sz="2000" b="0" u="none" strike="noStrike">
               <a:solidFill>
@@ -2648,6 +2310,17 @@
             <a:pPr indent="0" algn="l">
               <a:buNone/>
             </a:pPr>
+            <a:r>
+              <a:rPr lang="en-US" sz="1400" b="0" u="none" strike="noStrike">
+                <a:solidFill>
+                  <a:srgbClr val="000000"/>
+                </a:solidFill>
+                <a:effectLst/>
+                <a:uFillTx/>
+                <a:latin typeface="Arial"/>
+              </a:rPr>
+              <a:t>Geen specifieke valkuil.</a:t>
+            </a:r>
             <a:endParaRPr lang="en-US" sz="2000" b="0" u="none" strike="noStrike">
               <a:solidFill>
                 <a:srgbClr val="000000"/>
@@ -2661,17 +2334,6 @@
             <a:pPr indent="0" algn="l">
               <a:buNone/>
             </a:pPr>
-            <a:r>
-              <a:rPr lang="en-US" sz="1400" b="0" u="none" strike="noStrike">
-                <a:solidFill>
-                  <a:srgbClr val="000000"/>
-                </a:solidFill>
-                <a:effectLst/>
-                <a:uFillTx/>
-                <a:latin typeface="Arial"/>
-              </a:rPr>
-              <a:t>Docentcue:</a:t>
-            </a:r>
             <a:endParaRPr lang="en-US" sz="2000" b="0" u="none" strike="noStrike">
               <a:solidFill>
                 <a:srgbClr val="000000"/>
@@ -2694,166 +2356,7 @@
                 <a:uFillTx/>
                 <a:latin typeface="Arial"/>
               </a:rPr>
-              <a:t>- Laat eerst het tekort uitrekenen en vraag daarna welke opties om hetzelfde geld concurreren.</a:t>
-            </a:r>
-            <a:endParaRPr lang="en-US" sz="2000" b="0" u="none" strike="noStrike">
-              <a:solidFill>
-                <a:srgbClr val="000000"/>
-              </a:solidFill>
-              <a:effectLst/>
-              <a:uFillTx/>
-              <a:latin typeface="Arial"/>
-            </a:endParaRPr>
-          </a:p>
-          <a:p>
-            <a:pPr indent="0" algn="l">
-              <a:buNone/>
-            </a:pPr>
-            <a:endParaRPr lang="en-US" sz="2000" b="0" u="none" strike="noStrike">
-              <a:solidFill>
-                <a:srgbClr val="000000"/>
-              </a:solidFill>
-              <a:effectLst/>
-              <a:uFillTx/>
-              <a:latin typeface="Arial"/>
-            </a:endParaRPr>
-          </a:p>
-          <a:p>
-            <a:pPr indent="0" algn="l">
-              <a:buNone/>
-            </a:pPr>
-            <a:r>
-              <a:rPr lang="en-US" sz="1400" b="0" u="none" strike="noStrike">
-                <a:solidFill>
-                  <a:srgbClr val="000000"/>
-                </a:solidFill>
-                <a:effectLst/>
-                <a:uFillTx/>
-                <a:latin typeface="Arial"/>
-              </a:rPr>
               <a:t>Overgang:</a:t>
-            </a:r>
-            <a:endParaRPr lang="en-US" sz="2000" b="0" u="none" strike="noStrike">
-              <a:solidFill>
-                <a:srgbClr val="000000"/>
-              </a:solidFill>
-              <a:effectLst/>
-              <a:uFillTx/>
-              <a:latin typeface="Arial"/>
-            </a:endParaRPr>
-          </a:p>
-          <a:p>
-            <a:pPr indent="0" algn="l">
-              <a:buNone/>
-            </a:pPr>
-            <a:r>
-              <a:rPr lang="en-US" sz="1400" b="0" u="none" strike="noStrike">
-                <a:solidFill>
-                  <a:srgbClr val="000000"/>
-                </a:solidFill>
-                <a:effectLst/>
-                <a:uFillTx/>
-                <a:latin typeface="Arial"/>
-              </a:rPr>
-              <a:t>Van Lisa gaan we naar het begrip dat onder dit keuzeprobleem ligt: schaarste.</a:t>
-            </a:r>
-            <a:endParaRPr lang="en-US" sz="2000" b="0" u="none" strike="noStrike">
-              <a:solidFill>
-                <a:srgbClr val="000000"/>
-              </a:solidFill>
-              <a:effectLst/>
-              <a:uFillTx/>
-              <a:latin typeface="Arial"/>
-            </a:endParaRPr>
-          </a:p>
-          <a:p>
-            <a:pPr indent="0" algn="l">
-              <a:buNone/>
-            </a:pPr>
-            <a:endParaRPr lang="en-US" sz="2000" b="0" u="none" strike="noStrike">
-              <a:solidFill>
-                <a:srgbClr val="000000"/>
-              </a:solidFill>
-              <a:effectLst/>
-              <a:uFillTx/>
-              <a:latin typeface="Arial"/>
-            </a:endParaRPr>
-          </a:p>
-          <a:p>
-            <a:pPr indent="0" algn="l">
-              <a:buNone/>
-            </a:pPr>
-            <a:r>
-              <a:rPr lang="en-US" sz="1400" b="0" u="none" strike="noStrike">
-                <a:solidFill>
-                  <a:srgbClr val="000000"/>
-                </a:solidFill>
-                <a:effectLst/>
-                <a:uFillTx/>
-                <a:latin typeface="Arial"/>
-              </a:rPr>
-              <a:t>Visual:</a:t>
-            </a:r>
-            <a:endParaRPr lang="en-US" sz="2000" b="0" u="none" strike="noStrike">
-              <a:solidFill>
-                <a:srgbClr val="000000"/>
-              </a:solidFill>
-              <a:effectLst/>
-              <a:uFillTx/>
-              <a:latin typeface="Arial"/>
-            </a:endParaRPr>
-          </a:p>
-          <a:p>
-            <a:pPr indent="0" algn="l">
-              <a:buNone/>
-            </a:pPr>
-            <a:r>
-              <a:rPr lang="en-US" sz="1400" b="0" u="none" strike="noStrike">
-                <a:solidFill>
-                  <a:srgbClr val="000000"/>
-                </a:solidFill>
-                <a:effectLst/>
-                <a:uFillTx/>
-                <a:latin typeface="Arial"/>
-              </a:rPr>
-              <a:t>Een budgetspanning en twee optiekaarten maken zichtbaar dat beide opties om hetzelfde geld strijden.</a:t>
-            </a:r>
-            <a:endParaRPr lang="en-US" sz="2000" b="0" u="none" strike="noStrike">
-              <a:solidFill>
-                <a:srgbClr val="000000"/>
-              </a:solidFill>
-              <a:effectLst/>
-              <a:uFillTx/>
-              <a:latin typeface="Arial"/>
-            </a:endParaRPr>
-          </a:p>
-          <a:p>
-            <a:pPr indent="0" algn="l">
-              <a:buNone/>
-            </a:pPr>
-            <a:endParaRPr lang="en-US" sz="2000" b="0" u="none" strike="noStrike">
-              <a:solidFill>
-                <a:srgbClr val="000000"/>
-              </a:solidFill>
-              <a:effectLst/>
-              <a:uFillTx/>
-              <a:latin typeface="Arial"/>
-            </a:endParaRPr>
-          </a:p>
-          <a:p>
-            <a:pPr indent="0" algn="l">
-              <a:buNone/>
-            </a:pPr>
-            <a:r>
-              <a:rPr lang="en-US" sz="1400" b="0" u="none" strike="noStrike">
-                <a:solidFill>
-                  <a:srgbClr val="000000"/>
-                </a:solidFill>
-                <a:effectLst/>
-                <a:uFillTx/>
-                <a:latin typeface="Arial"/>
-              </a:rPr>
-              <a:t>Actie op de dia:</a:t>
             </a:r>
             <a:endParaRPr lang="en-US" sz="2000" b="0" u="none" strike="noStrike">
               <a:solidFill>
@@ -2880,7 +2383,7 @@
                 <a:uFillTx/>
                 <a:latin typeface="Arial"/>
               </a:rPr>
-              <a:t>Luistervraag: welke twee alternatieven strijden om hetzelfde geld?</a:t>
+              <a:t>Van Lisa gaan we naar het begrip dat onder dit keuzeprobleem ligt: schaarste.</a:t>
             </a:r>
             <a:endParaRPr lang="en-US" sz="2000" b="0" u="none" strike="noStrike">
               <a:solidFill>
@@ -2944,7 +2447,7 @@
               </a:lnSpc>
               <a:buNone/>
             </a:pPr>
-            <a:fld id="{D9E39B42-499E-475C-9596-E19677C78B4B}" type="slidenum">
+            <a:fld id="{216FE983-39BB-4B60-8915-F1CD1A61550A}" type="slidenum">
               <a:rPr lang="en-US" sz="1400" b="0" u="none" strike="noStrike">
                 <a:solidFill>
                   <a:schemeClr val="dk1"/>
@@ -3091,17 +2594,6 @@
             <a:pPr indent="0" algn="l">
               <a:buNone/>
             </a:pPr>
-            <a:r>
-              <a:rPr lang="en-US" sz="1400" b="0" u="none" strike="noStrike">
-                <a:solidFill>
-                  <a:srgbClr val="000000"/>
-                </a:solidFill>
-                <a:effectLst/>
-                <a:uFillTx/>
-                <a:latin typeface="Arial"/>
-              </a:rPr>
-              <a:t>Rol: concept_model_development</a:t>
-            </a:r>
             <a:endParaRPr lang="en-US" sz="2000" b="0" u="none" strike="noStrike">
               <a:solidFill>
                 <a:srgbClr val="000000"/>
@@ -3124,7 +2616,7 @@
                 <a:uFillTx/>
                 <a:latin typeface="Arial"/>
               </a:rPr>
-              <a:t>Layout: conceptModel</a:t>
+              <a:t>Vraag:</a:t>
             </a:r>
             <a:endParaRPr lang="en-US" sz="2000" b="0" u="none" strike="noStrike">
               <a:solidFill>
@@ -3139,6 +2631,17 @@
             <a:pPr indent="0" algn="l">
               <a:buNone/>
             </a:pPr>
+            <a:r>
+              <a:rPr lang="en-US" sz="1400" b="0" u="none" strike="noStrike">
+                <a:solidFill>
+                  <a:srgbClr val="000000"/>
+                </a:solidFill>
+                <a:effectLst/>
+                <a:uFillTx/>
+                <a:latin typeface="Arial"/>
+              </a:rPr>
+              <a:t>Check: waar in Lisa’s voorbeeld ontstaat de schaarste?</a:t>
+            </a:r>
             <a:endParaRPr lang="en-US" sz="2000" b="0" u="none" strike="noStrike">
               <a:solidFill>
                 <a:srgbClr val="000000"/>
@@ -3152,17 +2655,6 @@
             <a:pPr indent="0" algn="l">
               <a:buNone/>
             </a:pPr>
-            <a:r>
-              <a:rPr lang="en-US" sz="1400" b="0" u="none" strike="noStrike">
-                <a:solidFill>
-                  <a:srgbClr val="000000"/>
-                </a:solidFill>
-                <a:effectLst/>
-                <a:uFillTx/>
-                <a:latin typeface="Arial"/>
-              </a:rPr>
-              <a:t>Kernzin:</a:t>
-            </a:r>
             <a:endParaRPr lang="en-US" sz="2000" b="0" u="none" strike="noStrike">
               <a:solidFill>
                 <a:srgbClr val="000000"/>
@@ -3185,7 +2677,7 @@
                 <a:uFillTx/>
                 <a:latin typeface="Arial"/>
               </a:rPr>
-              <a:t>Schaarste is een verhouding, geen ander woord voor “zeldzaam”.</a:t>
+              <a:t>Uitleg:</a:t>
             </a:r>
             <a:endParaRPr lang="en-US" sz="2000" b="0" u="none" strike="noStrike">
               <a:solidFill>
@@ -3200,6 +2692,17 @@
             <a:pPr indent="0" algn="l">
               <a:buNone/>
             </a:pPr>
+            <a:r>
+              <a:rPr lang="en-US" sz="1400" b="0" u="none" strike="noStrike">
+                <a:solidFill>
+                  <a:srgbClr val="000000"/>
+                </a:solidFill>
+                <a:effectLst/>
+                <a:uFillTx/>
+                <a:latin typeface="Arial"/>
+              </a:rPr>
+              <a:t>- Schaarste is een verhouding, geen ander woord voor “zeldzaam”.</a:t>
+            </a:r>
             <a:endParaRPr lang="en-US" sz="2000" b="0" u="none" strike="noStrike">
               <a:solidFill>
                 <a:srgbClr val="000000"/>
@@ -3222,7 +2725,7 @@
                 <a:uFillTx/>
                 <a:latin typeface="Arial"/>
               </a:rPr>
-              <a:t>Studentuitleg:</a:t>
+              <a:t>- Schaarste ontstaat wanneer behoeften groter zijn dan de beschikbare middelen. Het gaat dus om de verhouding tussen wat iemand wil en wat iemand heeft.</a:t>
             </a:r>
             <a:endParaRPr lang="en-US" sz="2000" b="0" u="none" strike="noStrike">
               <a:solidFill>
@@ -3246,7 +2749,7 @@
                 <a:uFillTx/>
                 <a:latin typeface="Arial"/>
               </a:rPr>
-              <a:t>- Schaarste ontstaat wanneer behoeften groter zijn dan de beschikbare middelen. Het gaat dus om de verhouding tussen wat iemand wil en wat iemand heeft.</a:t>
+              <a:t>- Corrigeer direct de valkuil dat schaarste hetzelfde zou zijn als zeldzaamheid.</a:t>
             </a:r>
             <a:endParaRPr lang="en-US" sz="2000" b="0" u="none" strike="noStrike">
               <a:solidFill>
@@ -3261,17 +2764,6 @@
             <a:pPr indent="0" algn="l">
               <a:buNone/>
             </a:pPr>
-            <a:r>
-              <a:rPr lang="en-US" sz="1400" b="0" u="none" strike="noStrike">
-                <a:solidFill>
-                  <a:srgbClr val="000000"/>
-                </a:solidFill>
-                <a:effectLst/>
-                <a:uFillTx/>
-                <a:latin typeface="Arial"/>
-              </a:rPr>
-              <a:t>- Bij Lisa is het middel haar €20. Haar behoeften kosten samen €27. Daardoor kan ze niet alles kiezen.</a:t>
-            </a:r>
             <a:endParaRPr lang="en-US" sz="2000" b="0" u="none" strike="noStrike">
               <a:solidFill>
                 <a:srgbClr val="000000"/>
@@ -3294,7 +2786,7 @@
                 <a:uFillTx/>
                 <a:latin typeface="Arial"/>
               </a:rPr>
-              <a:t>- Een belangrijke valkuil: schaarste betekent niet automatisch dat iets zeldzaam is. Water kan in Nederland goedkoop zijn, maar toch schaars worden als er meer vraag is dan beschikbaar water.</a:t>
+              <a:t>Pitfall:</a:t>
             </a:r>
             <a:endParaRPr lang="en-US" sz="2000" b="0" u="none" strike="noStrike">
               <a:solidFill>
@@ -3309,6 +2801,17 @@
             <a:pPr indent="0" algn="l">
               <a:buNone/>
             </a:pPr>
+            <a:r>
+              <a:rPr lang="en-US" sz="1400" b="0" u="none" strike="noStrike">
+                <a:solidFill>
+                  <a:srgbClr val="000000"/>
+                </a:solidFill>
+                <a:effectLst/>
+                <a:uFillTx/>
+                <a:latin typeface="Arial"/>
+              </a:rPr>
+              <a:t>- Schaarste is niet hetzelfde als zeldzaamheid; het is een verhouding tussen behoeften en middelen.</a:t>
+            </a:r>
             <a:endParaRPr lang="en-US" sz="2000" b="0" u="none" strike="noStrike">
               <a:solidFill>
                 <a:srgbClr val="000000"/>
@@ -3322,17 +2825,6 @@
             <a:pPr indent="0" algn="l">
               <a:buNone/>
             </a:pPr>
-            <a:r>
-              <a:rPr lang="en-US" sz="1400" b="0" u="none" strike="noStrike">
-                <a:solidFill>
-                  <a:srgbClr val="000000"/>
-                </a:solidFill>
-                <a:effectLst/>
-                <a:uFillTx/>
-                <a:latin typeface="Arial"/>
-              </a:rPr>
-              <a:t>Misconceptie-watch:</a:t>
-            </a:r>
             <a:endParaRPr lang="en-US" sz="2000" b="0" u="none" strike="noStrike">
               <a:solidFill>
                 <a:srgbClr val="000000"/>
@@ -3355,227 +2847,7 @@
                 <a:uFillTx/>
                 <a:latin typeface="Arial"/>
               </a:rPr>
-              <a:t>- Schaarste is niet hetzelfde als zeldzaamheid; het is een verhouding tussen behoeften en middelen.</a:t>
-            </a:r>
-            <a:endParaRPr lang="en-US" sz="2000" b="0" u="none" strike="noStrike">
-              <a:solidFill>
-                <a:srgbClr val="000000"/>
-              </a:solidFill>
-              <a:effectLst/>
-              <a:uFillTx/>
-              <a:latin typeface="Arial"/>
-            </a:endParaRPr>
-          </a:p>
-          <a:p>
-            <a:pPr indent="0" algn="l">
-              <a:buNone/>
-            </a:pPr>
-            <a:endParaRPr lang="en-US" sz="2000" b="0" u="none" strike="noStrike">
-              <a:solidFill>
-                <a:srgbClr val="000000"/>
-              </a:solidFill>
-              <a:effectLst/>
-              <a:uFillTx/>
-              <a:latin typeface="Arial"/>
-            </a:endParaRPr>
-          </a:p>
-          <a:p>
-            <a:pPr indent="0" algn="l">
-              <a:buNone/>
-            </a:pPr>
-            <a:r>
-              <a:rPr lang="en-US" sz="1400" b="0" u="none" strike="noStrike">
-                <a:solidFill>
-                  <a:srgbClr val="000000"/>
-                </a:solidFill>
-                <a:effectLst/>
-                <a:uFillTx/>
-                <a:latin typeface="Arial"/>
-              </a:rPr>
-              <a:t>Docentcue:</a:t>
-            </a:r>
-            <a:endParaRPr lang="en-US" sz="2000" b="0" u="none" strike="noStrike">
-              <a:solidFill>
-                <a:srgbClr val="000000"/>
-              </a:solidFill>
-              <a:effectLst/>
-              <a:uFillTx/>
-              <a:latin typeface="Arial"/>
-            </a:endParaRPr>
-          </a:p>
-          <a:p>
-            <a:pPr indent="0" algn="l">
-              <a:buNone/>
-            </a:pPr>
-            <a:r>
-              <a:rPr lang="en-US" sz="1400" b="0" u="none" strike="noStrike">
-                <a:solidFill>
-                  <a:srgbClr val="000000"/>
-                </a:solidFill>
-                <a:effectLst/>
-                <a:uFillTx/>
-                <a:latin typeface="Arial"/>
-              </a:rPr>
-              <a:t>- Corrigeer direct de valkuil dat schaarste hetzelfde zou zijn als zeldzaamheid.</a:t>
-            </a:r>
-            <a:endParaRPr lang="en-US" sz="2000" b="0" u="none" strike="noStrike">
-              <a:solidFill>
-                <a:srgbClr val="000000"/>
-              </a:solidFill>
-              <a:effectLst/>
-              <a:uFillTx/>
-              <a:latin typeface="Arial"/>
-            </a:endParaRPr>
-          </a:p>
-          <a:p>
-            <a:pPr indent="0" algn="l">
-              <a:buNone/>
-            </a:pPr>
-            <a:endParaRPr lang="en-US" sz="2000" b="0" u="none" strike="noStrike">
-              <a:solidFill>
-                <a:srgbClr val="000000"/>
-              </a:solidFill>
-              <a:effectLst/>
-              <a:uFillTx/>
-              <a:latin typeface="Arial"/>
-            </a:endParaRPr>
-          </a:p>
-          <a:p>
-            <a:pPr indent="0" algn="l">
-              <a:buNone/>
-            </a:pPr>
-            <a:r>
-              <a:rPr lang="en-US" sz="1400" b="0" u="none" strike="noStrike">
-                <a:solidFill>
-                  <a:srgbClr val="000000"/>
-                </a:solidFill>
-                <a:effectLst/>
-                <a:uFillTx/>
-                <a:latin typeface="Arial"/>
-              </a:rPr>
               <a:t>Overgang:</a:t>
-            </a:r>
-            <a:endParaRPr lang="en-US" sz="2000" b="0" u="none" strike="noStrike">
-              <a:solidFill>
-                <a:srgbClr val="000000"/>
-              </a:solidFill>
-              <a:effectLst/>
-              <a:uFillTx/>
-              <a:latin typeface="Arial"/>
-            </a:endParaRPr>
-          </a:p>
-          <a:p>
-            <a:pPr indent="0" algn="l">
-              <a:buNone/>
-            </a:pPr>
-            <a:r>
-              <a:rPr lang="en-US" sz="1400" b="0" u="none" strike="noStrike">
-                <a:solidFill>
-                  <a:srgbClr val="000000"/>
-                </a:solidFill>
-                <a:effectLst/>
-                <a:uFillTx/>
-                <a:latin typeface="Arial"/>
-              </a:rPr>
-              <a:t>Nu we schaarste kunnen herkennen, testen we of hetzelfde patroon ook buiten Lisa werkt.</a:t>
-            </a:r>
-            <a:endParaRPr lang="en-US" sz="2000" b="0" u="none" strike="noStrike">
-              <a:solidFill>
-                <a:srgbClr val="000000"/>
-              </a:solidFill>
-              <a:effectLst/>
-              <a:uFillTx/>
-              <a:latin typeface="Arial"/>
-            </a:endParaRPr>
-          </a:p>
-          <a:p>
-            <a:pPr indent="0" algn="l">
-              <a:buNone/>
-            </a:pPr>
-            <a:endParaRPr lang="en-US" sz="2000" b="0" u="none" strike="noStrike">
-              <a:solidFill>
-                <a:srgbClr val="000000"/>
-              </a:solidFill>
-              <a:effectLst/>
-              <a:uFillTx/>
-              <a:latin typeface="Arial"/>
-            </a:endParaRPr>
-          </a:p>
-          <a:p>
-            <a:pPr indent="0" algn="l">
-              <a:buNone/>
-            </a:pPr>
-            <a:r>
-              <a:rPr lang="en-US" sz="1400" b="0" u="none" strike="noStrike">
-                <a:solidFill>
-                  <a:srgbClr val="000000"/>
-                </a:solidFill>
-                <a:effectLst/>
-                <a:uFillTx/>
-                <a:latin typeface="Arial"/>
-              </a:rPr>
-              <a:t>Visual:</a:t>
-            </a:r>
-            <a:endParaRPr lang="en-US" sz="2000" b="0" u="none" strike="noStrike">
-              <a:solidFill>
-                <a:srgbClr val="000000"/>
-              </a:solidFill>
-              <a:effectLst/>
-              <a:uFillTx/>
-              <a:latin typeface="Arial"/>
-            </a:endParaRPr>
-          </a:p>
-          <a:p>
-            <a:pPr indent="0" algn="l">
-              <a:buNone/>
-            </a:pPr>
-            <a:r>
-              <a:rPr lang="en-US" sz="1400" b="0" u="none" strike="noStrike">
-                <a:solidFill>
-                  <a:srgbClr val="000000"/>
-                </a:solidFill>
-                <a:effectLst/>
-                <a:uFillTx/>
-                <a:latin typeface="Arial"/>
-              </a:rPr>
-              <a:t>Een verhoudingsdiagram laat zien dat schaarste ontstaat uit behoeften groter dan middelen.</a:t>
-            </a:r>
-            <a:endParaRPr lang="en-US" sz="2000" b="0" u="none" strike="noStrike">
-              <a:solidFill>
-                <a:srgbClr val="000000"/>
-              </a:solidFill>
-              <a:effectLst/>
-              <a:uFillTx/>
-              <a:latin typeface="Arial"/>
-            </a:endParaRPr>
-          </a:p>
-          <a:p>
-            <a:pPr indent="0" algn="l">
-              <a:buNone/>
-            </a:pPr>
-            <a:endParaRPr lang="en-US" sz="2000" b="0" u="none" strike="noStrike">
-              <a:solidFill>
-                <a:srgbClr val="000000"/>
-              </a:solidFill>
-              <a:effectLst/>
-              <a:uFillTx/>
-              <a:latin typeface="Arial"/>
-            </a:endParaRPr>
-          </a:p>
-          <a:p>
-            <a:pPr indent="0" algn="l">
-              <a:buNone/>
-            </a:pPr>
-            <a:r>
-              <a:rPr lang="en-US" sz="1400" b="0" u="none" strike="noStrike">
-                <a:solidFill>
-                  <a:srgbClr val="000000"/>
-                </a:solidFill>
-                <a:effectLst/>
-                <a:uFillTx/>
-                <a:latin typeface="Arial"/>
-              </a:rPr>
-              <a:t>Actie op de dia:</a:t>
             </a:r>
             <a:endParaRPr lang="en-US" sz="2000" b="0" u="none" strike="noStrike">
               <a:solidFill>
@@ -3602,7 +2874,7 @@
                 <a:uFillTx/>
                 <a:latin typeface="Arial"/>
               </a:rPr>
-              <a:t>Check: waar in Lisa’s voorbeeld ontstaat de schaarste?</a:t>
+              <a:t>Nu we schaarste kunnen herkennen, testen we of hetzelfde patroon ook buiten Lisa werkt.</a:t>
             </a:r>
             <a:endParaRPr lang="en-US" sz="2000" b="0" u="none" strike="noStrike">
               <a:solidFill>
@@ -3666,7 +2938,7 @@
               </a:lnSpc>
               <a:buNone/>
             </a:pPr>
-            <a:fld id="{A44294DB-EDCA-4780-BA01-F3C6CEE68D15}" type="slidenum">
+            <a:fld id="{0826CB84-D3D8-4AEA-8D9F-EB9CA9F6936E}" type="slidenum">
               <a:rPr lang="en-US" sz="1400" b="0" u="none" strike="noStrike">
                 <a:solidFill>
                   <a:schemeClr val="dk1"/>
@@ -3813,17 +3085,6 @@
             <a:pPr indent="0" algn="l">
               <a:buNone/>
             </a:pPr>
-            <a:r>
-              <a:rPr lang="en-US" sz="1400" b="0" u="none" strike="noStrike">
-                <a:solidFill>
-                  <a:srgbClr val="000000"/>
-                </a:solidFill>
-                <a:effectLst/>
-                <a:uFillTx/>
-                <a:latin typeface="Arial"/>
-              </a:rPr>
-              <a:t>Rol: transfer_slide</a:t>
-            </a:r>
             <a:endParaRPr lang="en-US" sz="2000" b="0" u="none" strike="noStrike">
               <a:solidFill>
                 <a:srgbClr val="000000"/>
@@ -3846,7 +3107,7 @@
                 <a:uFillTx/>
                 <a:latin typeface="Arial"/>
               </a:rPr>
-              <a:t>Layout: transferCards</a:t>
+              <a:t>Vraag:</a:t>
             </a:r>
             <a:endParaRPr lang="en-US" sz="2000" b="0" u="none" strike="noStrike">
               <a:solidFill>
@@ -3861,6 +3122,17 @@
             <a:pPr indent="0" algn="l">
               <a:buNone/>
             </a:pPr>
+            <a:r>
+              <a:rPr lang="en-US" sz="1400" b="0" u="none" strike="noStrike">
+                <a:solidFill>
+                  <a:srgbClr val="000000"/>
+                </a:solidFill>
+                <a:effectLst/>
+                <a:uFillTx/>
+                <a:latin typeface="Arial"/>
+              </a:rPr>
+              <a:t>Vergelijk Lisa met een producent en een overheid.</a:t>
+            </a:r>
             <a:endParaRPr lang="en-US" sz="2000" b="0" u="none" strike="noStrike">
               <a:solidFill>
                 <a:srgbClr val="000000"/>
@@ -3874,17 +3146,6 @@
             <a:pPr indent="0" algn="l">
               <a:buNone/>
             </a:pPr>
-            <a:r>
-              <a:rPr lang="en-US" sz="1400" b="0" u="none" strike="noStrike">
-                <a:solidFill>
-                  <a:srgbClr val="000000"/>
-                </a:solidFill>
-                <a:effectLst/>
-                <a:uFillTx/>
-                <a:latin typeface="Arial"/>
-              </a:rPr>
-              <a:t>Kernzin:</a:t>
-            </a:r>
             <a:endParaRPr lang="en-US" sz="2000" b="0" u="none" strike="noStrike">
               <a:solidFill>
                 <a:srgbClr val="000000"/>
@@ -3907,7 +3168,7 @@
                 <a:uFillTx/>
                 <a:latin typeface="Arial"/>
               </a:rPr>
-              <a:t>Vraag steeds: wie kiest, welk middel is beperkt, en welke alternatieven strijden om dat middel?</a:t>
+              <a:t>Uitleg:</a:t>
             </a:r>
             <a:endParaRPr lang="en-US" sz="2000" b="0" u="none" strike="noStrike">
               <a:solidFill>
@@ -3922,6 +3183,17 @@
             <a:pPr indent="0" algn="l">
               <a:buNone/>
             </a:pPr>
+            <a:r>
+              <a:rPr lang="en-US" sz="1400" b="0" u="none" strike="noStrike">
+                <a:solidFill>
+                  <a:srgbClr val="000000"/>
+                </a:solidFill>
+                <a:effectLst/>
+                <a:uFillTx/>
+                <a:latin typeface="Arial"/>
+              </a:rPr>
+              <a:t>- Vraag steeds: wie kiest, welk middel is beperkt, en welke alternatieven strijden om dat middel?</a:t>
+            </a:r>
             <a:endParaRPr lang="en-US" sz="2000" b="0" u="none" strike="noStrike">
               <a:solidFill>
                 <a:srgbClr val="000000"/>
@@ -3944,7 +3216,7 @@
                 <a:uFillTx/>
                 <a:latin typeface="Arial"/>
               </a:rPr>
-              <a:t>Studentuitleg:</a:t>
+              <a:t>- De context verandert, maar de structuur blijft hetzelfde. Je zoekt steeds naar drie dingen: de kiezer, het beperkte middel en de alternatieven.</a:t>
             </a:r>
             <a:endParaRPr lang="en-US" sz="2000" b="0" u="none" strike="noStrike">
               <a:solidFill>
@@ -3968,7 +3240,7 @@
                 <a:uFillTx/>
                 <a:latin typeface="Arial"/>
               </a:rPr>
-              <a:t>- De context verandert, maar de structuur blijft hetzelfde. Je zoekt steeds naar drie dingen: de kiezer, het beperkte middel en de alternatieven.</a:t>
+              <a:t>- Vraag bij elke kaart hardop: wie kiest, welk middel is beperkt, welke alternatieven botsen?</a:t>
             </a:r>
             <a:endParaRPr lang="en-US" sz="2000" b="0" u="none" strike="noStrike">
               <a:solidFill>
@@ -3983,17 +3255,6 @@
             <a:pPr indent="0" algn="l">
               <a:buNone/>
             </a:pPr>
-            <a:r>
-              <a:rPr lang="en-US" sz="1400" b="0" u="none" strike="noStrike">
-                <a:solidFill>
-                  <a:srgbClr val="000000"/>
-                </a:solidFill>
-                <a:effectLst/>
-                <a:uFillTx/>
-                <a:latin typeface="Arial"/>
-              </a:rPr>
-              <a:t>- Bij een scholier kan het beperkte middel geld of tijd zijn. Bij een producent kan het land, machines of personeel zijn. Bij de overheid kan het belastinggeld of ruimte zijn.</a:t>
-            </a:r>
             <a:endParaRPr lang="en-US" sz="2000" b="0" u="none" strike="noStrike">
               <a:solidFill>
                 <a:srgbClr val="000000"/>
@@ -4016,7 +3277,7 @@
                 <a:uFillTx/>
                 <a:latin typeface="Arial"/>
               </a:rPr>
-              <a:t>- Als je die drie onderdelen vindt, kun je schaarste ook in nieuwe voorbeelden herkennen.</a:t>
+              <a:t>Pitfall:</a:t>
             </a:r>
             <a:endParaRPr lang="en-US" sz="2000" b="0" u="none" strike="noStrike">
               <a:solidFill>
@@ -4031,6 +3292,17 @@
             <a:pPr indent="0" algn="l">
               <a:buNone/>
             </a:pPr>
+            <a:r>
+              <a:rPr lang="en-US" sz="1400" b="0" u="none" strike="noStrike">
+                <a:solidFill>
+                  <a:srgbClr val="000000"/>
+                </a:solidFill>
+                <a:effectLst/>
+                <a:uFillTx/>
+                <a:latin typeface="Arial"/>
+              </a:rPr>
+              <a:t>Geen specifieke valkuil.</a:t>
+            </a:r>
             <a:endParaRPr lang="en-US" sz="2000" b="0" u="none" strike="noStrike">
               <a:solidFill>
                 <a:srgbClr val="000000"/>
@@ -4044,17 +3316,6 @@
             <a:pPr indent="0" algn="l">
               <a:buNone/>
             </a:pPr>
-            <a:r>
-              <a:rPr lang="en-US" sz="1400" b="0" u="none" strike="noStrike">
-                <a:solidFill>
-                  <a:srgbClr val="000000"/>
-                </a:solidFill>
-                <a:effectLst/>
-                <a:uFillTx/>
-                <a:latin typeface="Arial"/>
-              </a:rPr>
-              <a:t>Docentcue:</a:t>
-            </a:r>
             <a:endParaRPr lang="en-US" sz="2000" b="0" u="none" strike="noStrike">
               <a:solidFill>
                 <a:srgbClr val="000000"/>
@@ -4077,166 +3338,7 @@
                 <a:uFillTx/>
                 <a:latin typeface="Arial"/>
               </a:rPr>
-              <a:t>- Vraag bij elke kaart hardop: wie kiest, welk middel is beperkt, welke alternatieven botsen?</a:t>
-            </a:r>
-            <a:endParaRPr lang="en-US" sz="2000" b="0" u="none" strike="noStrike">
-              <a:solidFill>
-                <a:srgbClr val="000000"/>
-              </a:solidFill>
-              <a:effectLst/>
-              <a:uFillTx/>
-              <a:latin typeface="Arial"/>
-            </a:endParaRPr>
-          </a:p>
-          <a:p>
-            <a:pPr indent="0" algn="l">
-              <a:buNone/>
-            </a:pPr>
-            <a:endParaRPr lang="en-US" sz="2000" b="0" u="none" strike="noStrike">
-              <a:solidFill>
-                <a:srgbClr val="000000"/>
-              </a:solidFill>
-              <a:effectLst/>
-              <a:uFillTx/>
-              <a:latin typeface="Arial"/>
-            </a:endParaRPr>
-          </a:p>
-          <a:p>
-            <a:pPr indent="0" algn="l">
-              <a:buNone/>
-            </a:pPr>
-            <a:r>
-              <a:rPr lang="en-US" sz="1400" b="0" u="none" strike="noStrike">
-                <a:solidFill>
-                  <a:srgbClr val="000000"/>
-                </a:solidFill>
-                <a:effectLst/>
-                <a:uFillTx/>
-                <a:latin typeface="Arial"/>
-              </a:rPr>
               <a:t>Overgang:</a:t>
-            </a:r>
-            <a:endParaRPr lang="en-US" sz="2000" b="0" u="none" strike="noStrike">
-              <a:solidFill>
-                <a:srgbClr val="000000"/>
-              </a:solidFill>
-              <a:effectLst/>
-              <a:uFillTx/>
-              <a:latin typeface="Arial"/>
-            </a:endParaRPr>
-          </a:p>
-          <a:p>
-            <a:pPr indent="0" algn="l">
-              <a:buNone/>
-            </a:pPr>
-            <a:r>
-              <a:rPr lang="en-US" sz="1400" b="0" u="none" strike="noStrike">
-                <a:solidFill>
-                  <a:srgbClr val="000000"/>
-                </a:solidFill>
-                <a:effectLst/>
-                <a:uFillTx/>
-                <a:latin typeface="Arial"/>
-              </a:rPr>
-              <a:t>Daarna voegen we het tweede kernbegrip toe: alternatieve kosten.</a:t>
-            </a:r>
-            <a:endParaRPr lang="en-US" sz="2000" b="0" u="none" strike="noStrike">
-              <a:solidFill>
-                <a:srgbClr val="000000"/>
-              </a:solidFill>
-              <a:effectLst/>
-              <a:uFillTx/>
-              <a:latin typeface="Arial"/>
-            </a:endParaRPr>
-          </a:p>
-          <a:p>
-            <a:pPr indent="0" algn="l">
-              <a:buNone/>
-            </a:pPr>
-            <a:endParaRPr lang="en-US" sz="2000" b="0" u="none" strike="noStrike">
-              <a:solidFill>
-                <a:srgbClr val="000000"/>
-              </a:solidFill>
-              <a:effectLst/>
-              <a:uFillTx/>
-              <a:latin typeface="Arial"/>
-            </a:endParaRPr>
-          </a:p>
-          <a:p>
-            <a:pPr indent="0" algn="l">
-              <a:buNone/>
-            </a:pPr>
-            <a:r>
-              <a:rPr lang="en-US" sz="1400" b="0" u="none" strike="noStrike">
-                <a:solidFill>
-                  <a:srgbClr val="000000"/>
-                </a:solidFill>
-                <a:effectLst/>
-                <a:uFillTx/>
-                <a:latin typeface="Arial"/>
-              </a:rPr>
-              <a:t>Visual:</a:t>
-            </a:r>
-            <a:endParaRPr lang="en-US" sz="2000" b="0" u="none" strike="noStrike">
-              <a:solidFill>
-                <a:srgbClr val="000000"/>
-              </a:solidFill>
-              <a:effectLst/>
-              <a:uFillTx/>
-              <a:latin typeface="Arial"/>
-            </a:endParaRPr>
-          </a:p>
-          <a:p>
-            <a:pPr indent="0" algn="l">
-              <a:buNone/>
-            </a:pPr>
-            <a:r>
-              <a:rPr lang="en-US" sz="1400" b="0" u="none" strike="noStrike">
-                <a:solidFill>
-                  <a:srgbClr val="000000"/>
-                </a:solidFill>
-                <a:effectLst/>
-                <a:uFillTx/>
-                <a:latin typeface="Arial"/>
-              </a:rPr>
-              <a:t>Drie transferkaarten houden dezelfde vragen vast in andere contexten.</a:t>
-            </a:r>
-            <a:endParaRPr lang="en-US" sz="2000" b="0" u="none" strike="noStrike">
-              <a:solidFill>
-                <a:srgbClr val="000000"/>
-              </a:solidFill>
-              <a:effectLst/>
-              <a:uFillTx/>
-              <a:latin typeface="Arial"/>
-            </a:endParaRPr>
-          </a:p>
-          <a:p>
-            <a:pPr indent="0" algn="l">
-              <a:buNone/>
-            </a:pPr>
-            <a:endParaRPr lang="en-US" sz="2000" b="0" u="none" strike="noStrike">
-              <a:solidFill>
-                <a:srgbClr val="000000"/>
-              </a:solidFill>
-              <a:effectLst/>
-              <a:uFillTx/>
-              <a:latin typeface="Arial"/>
-            </a:endParaRPr>
-          </a:p>
-          <a:p>
-            <a:pPr indent="0" algn="l">
-              <a:buNone/>
-            </a:pPr>
-            <a:r>
-              <a:rPr lang="en-US" sz="1400" b="0" u="none" strike="noStrike">
-                <a:solidFill>
-                  <a:srgbClr val="000000"/>
-                </a:solidFill>
-                <a:effectLst/>
-                <a:uFillTx/>
-                <a:latin typeface="Arial"/>
-              </a:rPr>
-              <a:t>Actie op de dia:</a:t>
             </a:r>
             <a:endParaRPr lang="en-US" sz="2000" b="0" u="none" strike="noStrike">
               <a:solidFill>
@@ -4263,7 +3365,7 @@
                 <a:uFillTx/>
                 <a:latin typeface="Arial"/>
               </a:rPr>
-              <a:t>Vergelijk Lisa met een producent en een overheid.</a:t>
+              <a:t>Daarna voegen we het tweede kernbegrip toe: alternatieve kosten.</a:t>
             </a:r>
             <a:endParaRPr lang="en-US" sz="2000" b="0" u="none" strike="noStrike">
               <a:solidFill>
@@ -4327,7 +3429,7 @@
               </a:lnSpc>
               <a:buNone/>
             </a:pPr>
-            <a:fld id="{C314CA57-573A-497A-AAB6-7059812D19BE}" type="slidenum">
+            <a:fld id="{DCC1B2EF-74A2-4FE7-9FC6-8A4A6E5CA0C1}" type="slidenum">
               <a:rPr lang="en-US" sz="1400" b="0" u="none" strike="noStrike">
                 <a:solidFill>
                   <a:schemeClr val="dk1"/>
@@ -4474,17 +3576,6 @@
             <a:pPr indent="0" algn="l">
               <a:buNone/>
             </a:pPr>
-            <a:r>
-              <a:rPr lang="en-US" sz="1400" b="0" u="none" strike="noStrike">
-                <a:solidFill>
-                  <a:srgbClr val="000000"/>
-                </a:solidFill>
-                <a:effectLst/>
-                <a:uFillTx/>
-                <a:latin typeface="Arial"/>
-              </a:rPr>
-              <a:t>Rol: concept_model_development</a:t>
-            </a:r>
             <a:endParaRPr lang="en-US" sz="2000" b="0" u="none" strike="noStrike">
               <a:solidFill>
                 <a:srgbClr val="000000"/>
@@ -4507,7 +3598,7 @@
                 <a:uFillTx/>
                 <a:latin typeface="Arial"/>
               </a:rPr>
-              <a:t>Layout: conceptModel</a:t>
+              <a:t>Vraag:</a:t>
             </a:r>
             <a:endParaRPr lang="en-US" sz="2000" b="0" u="none" strike="noStrike">
               <a:solidFill>
@@ -4522,6 +3613,17 @@
             <a:pPr indent="0" algn="l">
               <a:buNone/>
             </a:pPr>
+            <a:r>
+              <a:rPr lang="en-US" sz="1400" b="0" u="none" strike="noStrike">
+                <a:solidFill>
+                  <a:srgbClr val="000000"/>
+                </a:solidFill>
+                <a:effectLst/>
+                <a:uFillTx/>
+                <a:latin typeface="Arial"/>
+              </a:rPr>
+              <a:t>Lisa kiest bioscoop. Wat is dan haar beste niet-gekozen alternatief?</a:t>
+            </a:r>
             <a:endParaRPr lang="en-US" sz="2000" b="0" u="none" strike="noStrike">
               <a:solidFill>
                 <a:srgbClr val="000000"/>
@@ -4535,17 +3637,6 @@
             <a:pPr indent="0" algn="l">
               <a:buNone/>
             </a:pPr>
-            <a:r>
-              <a:rPr lang="en-US" sz="1400" b="0" u="none" strike="noStrike">
-                <a:solidFill>
-                  <a:srgbClr val="000000"/>
-                </a:solidFill>
-                <a:effectLst/>
-                <a:uFillTx/>
-                <a:latin typeface="Arial"/>
-              </a:rPr>
-              <a:t>Kernzin:</a:t>
-            </a:r>
             <a:endParaRPr lang="en-US" sz="2000" b="0" u="none" strike="noStrike">
               <a:solidFill>
                 <a:srgbClr val="000000"/>
@@ -4568,7 +3659,7 @@
                 <a:uFillTx/>
                 <a:latin typeface="Arial"/>
               </a:rPr>
-              <a:t>Bij Lisa is dat niet simpelweg de betaalde prijs, maar de waarde van het alternatief dat ze niet kiest.</a:t>
+              <a:t>Uitleg:</a:t>
             </a:r>
             <a:endParaRPr lang="en-US" sz="2000" b="0" u="none" strike="noStrike">
               <a:solidFill>
@@ -4583,6 +3674,17 @@
             <a:pPr indent="0" algn="l">
               <a:buNone/>
             </a:pPr>
+            <a:r>
+              <a:rPr lang="en-US" sz="1400" b="0" u="none" strike="noStrike">
+                <a:solidFill>
+                  <a:srgbClr val="000000"/>
+                </a:solidFill>
+                <a:effectLst/>
+                <a:uFillTx/>
+                <a:latin typeface="Arial"/>
+              </a:rPr>
+              <a:t>- Bij Lisa is dat niet simpelweg de betaalde prijs, maar de waarde van het alternatief dat ze niet kiest.</a:t>
+            </a:r>
             <a:endParaRPr lang="en-US" sz="2000" b="0" u="none" strike="noStrike">
               <a:solidFill>
                 <a:srgbClr val="000000"/>
@@ -4605,7 +3707,7 @@
                 <a:uFillTx/>
                 <a:latin typeface="Arial"/>
               </a:rPr>
-              <a:t>Studentuitleg:</a:t>
+              <a:t>- Als Lisa naar de bioscoop gaat, betaalt ze €12. Maar alternatieve kosten gaan niet over de prijs die ze betaalt.</a:t>
             </a:r>
             <a:endParaRPr lang="en-US" sz="2000" b="0" u="none" strike="noStrike">
               <a:solidFill>
@@ -4629,7 +3731,7 @@
                 <a:uFillTx/>
                 <a:latin typeface="Arial"/>
               </a:rPr>
-              <a:t>- Als Lisa naar de bioscoop gaat, betaalt ze €12. Maar alternatieve kosten gaan niet over de prijs die ze betaalt.</a:t>
+              <a:t>- Laat leerlingen eerst de prijs noemen en daarna expliciet uitleggen waarom dat nog niet de alternatieve kosten zijn.</a:t>
             </a:r>
             <a:endParaRPr lang="en-US" sz="2000" b="0" u="none" strike="noStrike">
               <a:solidFill>
@@ -4644,17 +3746,6 @@
             <a:pPr indent="0" algn="l">
               <a:buNone/>
             </a:pPr>
-            <a:r>
-              <a:rPr lang="en-US" sz="1400" b="0" u="none" strike="noStrike">
-                <a:solidFill>
-                  <a:srgbClr val="000000"/>
-                </a:solidFill>
-                <a:effectLst/>
-                <a:uFillTx/>
-                <a:latin typeface="Arial"/>
-              </a:rPr>
-              <a:t>- Alternatieve kosten zijn de waarde van het beste alternatief dat ze niet kiest. In dit voorbeeld is dat het boek lezen, met de waarde die dat voor haar had.</a:t>
-            </a:r>
             <a:endParaRPr lang="en-US" sz="2000" b="0" u="none" strike="noStrike">
               <a:solidFill>
                 <a:srgbClr val="000000"/>
@@ -4677,7 +3768,7 @@
                 <a:uFillTx/>
                 <a:latin typeface="Arial"/>
               </a:rPr>
-              <a:t>- De definitie is dus: de opbrengst of waarde van het beste niet-gekozen alternatief.</a:t>
+              <a:t>Pitfall:</a:t>
             </a:r>
             <a:endParaRPr lang="en-US" sz="2000" b="0" u="none" strike="noStrike">
               <a:solidFill>
@@ -4692,6 +3783,17 @@
             <a:pPr indent="0" algn="l">
               <a:buNone/>
             </a:pPr>
+            <a:r>
+              <a:rPr lang="en-US" sz="1400" b="0" u="none" strike="noStrike">
+                <a:solidFill>
+                  <a:srgbClr val="000000"/>
+                </a:solidFill>
+                <a:effectLst/>
+                <a:uFillTx/>
+                <a:latin typeface="Arial"/>
+              </a:rPr>
+              <a:t>Geen specifieke valkuil.</a:t>
+            </a:r>
             <a:endParaRPr lang="en-US" sz="2000" b="0" u="none" strike="noStrike">
               <a:solidFill>
                 <a:srgbClr val="000000"/>
@@ -4705,17 +3807,6 @@
             <a:pPr indent="0" algn="l">
               <a:buNone/>
             </a:pPr>
-            <a:r>
-              <a:rPr lang="en-US" sz="1400" b="0" u="none" strike="noStrike">
-                <a:solidFill>
-                  <a:srgbClr val="000000"/>
-                </a:solidFill>
-                <a:effectLst/>
-                <a:uFillTx/>
-                <a:latin typeface="Arial"/>
-              </a:rPr>
-              <a:t>Docentcue:</a:t>
-            </a:r>
             <a:endParaRPr lang="en-US" sz="2000" b="0" u="none" strike="noStrike">
               <a:solidFill>
                 <a:srgbClr val="000000"/>
@@ -4738,166 +3829,7 @@
                 <a:uFillTx/>
                 <a:latin typeface="Arial"/>
               </a:rPr>
-              <a:t>- Laat leerlingen eerst de prijs noemen en daarna expliciet uitleggen waarom dat nog niet de alternatieve kosten zijn.</a:t>
-            </a:r>
-            <a:endParaRPr lang="en-US" sz="2000" b="0" u="none" strike="noStrike">
-              <a:solidFill>
-                <a:srgbClr val="000000"/>
-              </a:solidFill>
-              <a:effectLst/>
-              <a:uFillTx/>
-              <a:latin typeface="Arial"/>
-            </a:endParaRPr>
-          </a:p>
-          <a:p>
-            <a:pPr indent="0" algn="l">
-              <a:buNone/>
-            </a:pPr>
-            <a:endParaRPr lang="en-US" sz="2000" b="0" u="none" strike="noStrike">
-              <a:solidFill>
-                <a:srgbClr val="000000"/>
-              </a:solidFill>
-              <a:effectLst/>
-              <a:uFillTx/>
-              <a:latin typeface="Arial"/>
-            </a:endParaRPr>
-          </a:p>
-          <a:p>
-            <a:pPr indent="0" algn="l">
-              <a:buNone/>
-            </a:pPr>
-            <a:r>
-              <a:rPr lang="en-US" sz="1400" b="0" u="none" strike="noStrike">
-                <a:solidFill>
-                  <a:srgbClr val="000000"/>
-                </a:solidFill>
-                <a:effectLst/>
-                <a:uFillTx/>
-                <a:latin typeface="Arial"/>
-              </a:rPr>
               <a:t>Overgang:</a:t>
-            </a:r>
-            <a:endParaRPr lang="en-US" sz="2000" b="0" u="none" strike="noStrike">
-              <a:solidFill>
-                <a:srgbClr val="000000"/>
-              </a:solidFill>
-              <a:effectLst/>
-              <a:uFillTx/>
-              <a:latin typeface="Arial"/>
-            </a:endParaRPr>
-          </a:p>
-          <a:p>
-            <a:pPr indent="0" algn="l">
-              <a:buNone/>
-            </a:pPr>
-            <a:r>
-              <a:rPr lang="en-US" sz="1400" b="0" u="none" strike="noStrike">
-                <a:solidFill>
-                  <a:srgbClr val="000000"/>
-                </a:solidFill>
-                <a:effectLst/>
-                <a:uFillTx/>
-                <a:latin typeface="Arial"/>
-              </a:rPr>
-              <a:t>Voordat we gaan rekenen, halen we twee hardnekkige verwarringen weg.</a:t>
-            </a:r>
-            <a:endParaRPr lang="en-US" sz="2000" b="0" u="none" strike="noStrike">
-              <a:solidFill>
-                <a:srgbClr val="000000"/>
-              </a:solidFill>
-              <a:effectLst/>
-              <a:uFillTx/>
-              <a:latin typeface="Arial"/>
-            </a:endParaRPr>
-          </a:p>
-          <a:p>
-            <a:pPr indent="0" algn="l">
-              <a:buNone/>
-            </a:pPr>
-            <a:endParaRPr lang="en-US" sz="2000" b="0" u="none" strike="noStrike">
-              <a:solidFill>
-                <a:srgbClr val="000000"/>
-              </a:solidFill>
-              <a:effectLst/>
-              <a:uFillTx/>
-              <a:latin typeface="Arial"/>
-            </a:endParaRPr>
-          </a:p>
-          <a:p>
-            <a:pPr indent="0" algn="l">
-              <a:buNone/>
-            </a:pPr>
-            <a:r>
-              <a:rPr lang="en-US" sz="1400" b="0" u="none" strike="noStrike">
-                <a:solidFill>
-                  <a:srgbClr val="000000"/>
-                </a:solidFill>
-                <a:effectLst/>
-                <a:uFillTx/>
-                <a:latin typeface="Arial"/>
-              </a:rPr>
-              <a:t>Visual:</a:t>
-            </a:r>
-            <a:endParaRPr lang="en-US" sz="2000" b="0" u="none" strike="noStrike">
-              <a:solidFill>
-                <a:srgbClr val="000000"/>
-              </a:solidFill>
-              <a:effectLst/>
-              <a:uFillTx/>
-              <a:latin typeface="Arial"/>
-            </a:endParaRPr>
-          </a:p>
-          <a:p>
-            <a:pPr indent="0" algn="l">
-              <a:buNone/>
-            </a:pPr>
-            <a:r>
-              <a:rPr lang="en-US" sz="1400" b="0" u="none" strike="noStrike">
-                <a:solidFill>
-                  <a:srgbClr val="000000"/>
-                </a:solidFill>
-                <a:effectLst/>
-                <a:uFillTx/>
-                <a:latin typeface="Arial"/>
-              </a:rPr>
-              <a:t>Een gekozen/niet-gekozen-relatie maakt de definitie van alternatieve kosten visueel.</a:t>
-            </a:r>
-            <a:endParaRPr lang="en-US" sz="2000" b="0" u="none" strike="noStrike">
-              <a:solidFill>
-                <a:srgbClr val="000000"/>
-              </a:solidFill>
-              <a:effectLst/>
-              <a:uFillTx/>
-              <a:latin typeface="Arial"/>
-            </a:endParaRPr>
-          </a:p>
-          <a:p>
-            <a:pPr indent="0" algn="l">
-              <a:buNone/>
-            </a:pPr>
-            <a:endParaRPr lang="en-US" sz="2000" b="0" u="none" strike="noStrike">
-              <a:solidFill>
-                <a:srgbClr val="000000"/>
-              </a:solidFill>
-              <a:effectLst/>
-              <a:uFillTx/>
-              <a:latin typeface="Arial"/>
-            </a:endParaRPr>
-          </a:p>
-          <a:p>
-            <a:pPr indent="0" algn="l">
-              <a:buNone/>
-            </a:pPr>
-            <a:r>
-              <a:rPr lang="en-US" sz="1400" b="0" u="none" strike="noStrike">
-                <a:solidFill>
-                  <a:srgbClr val="000000"/>
-                </a:solidFill>
-                <a:effectLst/>
-                <a:uFillTx/>
-                <a:latin typeface="Arial"/>
-              </a:rPr>
-              <a:t>Actie op de dia:</a:t>
             </a:r>
             <a:endParaRPr lang="en-US" sz="2000" b="0" u="none" strike="noStrike">
               <a:solidFill>
@@ -4924,7 +3856,7 @@
                 <a:uFillTx/>
                 <a:latin typeface="Arial"/>
               </a:rPr>
-              <a:t>Lisa kiest bioscoop. Wat is dan haar beste niet-gekozen alternatief?</a:t>
+              <a:t>Voordat we gaan rekenen, halen we twee hardnekkige verwarringen weg.</a:t>
             </a:r>
             <a:endParaRPr lang="en-US" sz="2000" b="0" u="none" strike="noStrike">
               <a:solidFill>
@@ -4988,7 +3920,7 @@
               </a:lnSpc>
               <a:buNone/>
             </a:pPr>
-            <a:fld id="{6438D905-552E-4663-9259-DE11BEA7C918}" type="slidenum">
+            <a:fld id="{9B4EB52E-E7E3-4F2A-BE65-07F70FAAB0B3}" type="slidenum">
               <a:rPr lang="en-US" sz="1400" b="0" u="none" strike="noStrike">
                 <a:solidFill>
                   <a:schemeClr val="dk1"/>
@@ -5135,17 +4067,6 @@
             <a:pPr indent="0" algn="l">
               <a:buNone/>
             </a:pPr>
-            <a:r>
-              <a:rPr lang="en-US" sz="1400" b="0" u="none" strike="noStrike">
-                <a:solidFill>
-                  <a:srgbClr val="000000"/>
-                </a:solidFill>
-                <a:effectLst/>
-                <a:uFillTx/>
-                <a:latin typeface="Arial"/>
-              </a:rPr>
-              <a:t>Rol: misconception_slide</a:t>
-            </a:r>
             <a:endParaRPr lang="en-US" sz="2000" b="0" u="none" strike="noStrike">
               <a:solidFill>
                 <a:srgbClr val="000000"/>
@@ -5168,7 +4089,7 @@
                 <a:uFillTx/>
                 <a:latin typeface="Arial"/>
               </a:rPr>
-              <a:t>Layout: misconceptionCards</a:t>
+              <a:t>Vraag:</a:t>
             </a:r>
             <a:endParaRPr lang="en-US" sz="2000" b="0" u="none" strike="noStrike">
               <a:solidFill>
@@ -5183,6 +4104,17 @@
             <a:pPr indent="0" algn="l">
               <a:buNone/>
             </a:pPr>
+            <a:r>
+              <a:rPr lang="en-US" sz="1400" b="0" u="none" strike="noStrike">
+                <a:solidFill>
+                  <a:srgbClr val="000000"/>
+                </a:solidFill>
+                <a:effectLst/>
+                <a:uFillTx/>
+                <a:latin typeface="Arial"/>
+              </a:rPr>
+              <a:t>Noem bij elk voorbeeld eerst: gekozen alternatief en beste niet-gekozen alternatief.</a:t>
+            </a:r>
             <a:endParaRPr lang="en-US" sz="2000" b="0" u="none" strike="noStrike">
               <a:solidFill>
                 <a:srgbClr val="000000"/>
@@ -5196,17 +4128,6 @@
             <a:pPr indent="0" algn="l">
               <a:buNone/>
             </a:pPr>
-            <a:r>
-              <a:rPr lang="en-US" sz="1400" b="0" u="none" strike="noStrike">
-                <a:solidFill>
-                  <a:srgbClr val="000000"/>
-                </a:solidFill>
-                <a:effectLst/>
-                <a:uFillTx/>
-                <a:latin typeface="Arial"/>
-              </a:rPr>
-              <a:t>Kernzin:</a:t>
-            </a:r>
             <a:endParaRPr lang="en-US" sz="2000" b="0" u="none" strike="noStrike">
               <a:solidFill>
                 <a:srgbClr val="000000"/>
@@ -5229,7 +4150,7 @@
                 <a:uFillTx/>
                 <a:latin typeface="Arial"/>
               </a:rPr>
-              <a:t>Deze twee fouten zorgen later voor verkeerde berekeningen.</a:t>
+              <a:t>Uitleg:</a:t>
             </a:r>
             <a:endParaRPr lang="en-US" sz="2000" b="0" u="none" strike="noStrike">
               <a:solidFill>
@@ -5244,6 +4165,17 @@
             <a:pPr indent="0" algn="l">
               <a:buNone/>
             </a:pPr>
+            <a:r>
+              <a:rPr lang="en-US" sz="1400" b="0" u="none" strike="noStrike">
+                <a:solidFill>
+                  <a:srgbClr val="000000"/>
+                </a:solidFill>
+                <a:effectLst/>
+                <a:uFillTx/>
+                <a:latin typeface="Arial"/>
+              </a:rPr>
+              <a:t>- Deze twee fouten zorgen later voor verkeerde berekeningen.</a:t>
+            </a:r>
             <a:endParaRPr lang="en-US" sz="2000" b="0" u="none" strike="noStrike">
               <a:solidFill>
                 <a:srgbClr val="000000"/>
@@ -5266,7 +4198,7 @@
                 <a:uFillTx/>
                 <a:latin typeface="Arial"/>
               </a:rPr>
-              <a:t>Studentuitleg:</a:t>
+              <a:t>- Fout één: alternatieve kosten gelijkstellen aan de prijs. De prijs is wat je betaalt; alternatieve kosten zijn wat je opgeeft.</a:t>
             </a:r>
             <a:endParaRPr lang="en-US" sz="2000" b="0" u="none" strike="noStrike">
               <a:solidFill>
@@ -5290,7 +4222,7 @@
                 <a:uFillTx/>
                 <a:latin typeface="Arial"/>
               </a:rPr>
-              <a:t>- Fout één: alternatieve kosten gelijkstellen aan de prijs. De prijs is wat je betaalt; alternatieve kosten zijn wat je opgeeft.</a:t>
+              <a:t>- Gebruik de twee foutkaarten als klassikale diagnose voordat leerlingen zelf rekenen.</a:t>
             </a:r>
             <a:endParaRPr lang="en-US" sz="2000" b="0" u="none" strike="noStrike">
               <a:solidFill>
@@ -5305,17 +4237,6 @@
             <a:pPr indent="0" algn="l">
               <a:buNone/>
             </a:pPr>
-            <a:r>
-              <a:rPr lang="en-US" sz="1400" b="0" u="none" strike="noStrike">
-                <a:solidFill>
-                  <a:srgbClr val="000000"/>
-                </a:solidFill>
-                <a:effectLst/>
-                <a:uFillTx/>
-                <a:latin typeface="Arial"/>
-              </a:rPr>
-              <a:t>- Fout twee: alle gemiste opties bij elkaar optellen. Je telt niet alles op wat je niet doet. Je kiest alleen het beste alternatief dat je laat liggen.</a:t>
-            </a:r>
             <a:endParaRPr lang="en-US" sz="2000" b="0" u="none" strike="noStrike">
               <a:solidFill>
                 <a:srgbClr val="000000"/>
@@ -5338,7 +4259,7 @@
                 <a:uFillTx/>
                 <a:latin typeface="Arial"/>
               </a:rPr>
-              <a:t>- De controlevraag blijft: wat is gekozen, wat is het beste niet-gekozen alternatief, en welke waarde had dat alternatief?</a:t>
+              <a:t>Pitfall:</a:t>
             </a:r>
             <a:endParaRPr lang="en-US" sz="2000" b="0" u="none" strike="noStrike">
               <a:solidFill>
@@ -5353,6 +4274,17 @@
             <a:pPr indent="0" algn="l">
               <a:buNone/>
             </a:pPr>
+            <a:r>
+              <a:rPr lang="en-US" sz="1400" b="0" u="none" strike="noStrike">
+                <a:solidFill>
+                  <a:srgbClr val="000000"/>
+                </a:solidFill>
+                <a:effectLst/>
+                <a:uFillTx/>
+                <a:latin typeface="Arial"/>
+              </a:rPr>
+              <a:t>- Alternatieve kosten zijn niet de prijs.</a:t>
+            </a:r>
             <a:endParaRPr lang="en-US" sz="2000" b="0" u="none" strike="noStrike">
               <a:solidFill>
                 <a:srgbClr val="000000"/>
@@ -5375,7 +4307,7 @@
                 <a:uFillTx/>
                 <a:latin typeface="Arial"/>
               </a:rPr>
-              <a:t>Misconceptie-watch:</a:t>
+              <a:t>- Alternatieve kosten zijn niet de som van alle gemiste opties.</a:t>
             </a:r>
             <a:endParaRPr lang="en-US" sz="2000" b="0" u="none" strike="noStrike">
               <a:solidFill>
@@ -5390,17 +4322,6 @@
             <a:pPr indent="0" algn="l">
               <a:buNone/>
             </a:pPr>
-            <a:r>
-              <a:rPr lang="en-US" sz="1400" b="0" u="none" strike="noStrike">
-                <a:solidFill>
-                  <a:srgbClr val="000000"/>
-                </a:solidFill>
-                <a:effectLst/>
-                <a:uFillTx/>
-                <a:latin typeface="Arial"/>
-              </a:rPr>
-              <a:t>- Alternatieve kosten zijn niet de prijs.</a:t>
-            </a:r>
             <a:endParaRPr lang="en-US" sz="2000" b="0" u="none" strike="noStrike">
               <a:solidFill>
                 <a:srgbClr val="000000"/>
@@ -5423,227 +4344,7 @@
                 <a:uFillTx/>
                 <a:latin typeface="Arial"/>
               </a:rPr>
-              <a:t>- Alternatieve kosten zijn niet de som van alle gemiste opties.</a:t>
-            </a:r>
-            <a:endParaRPr lang="en-US" sz="2000" b="0" u="none" strike="noStrike">
-              <a:solidFill>
-                <a:srgbClr val="000000"/>
-              </a:solidFill>
-              <a:effectLst/>
-              <a:uFillTx/>
-              <a:latin typeface="Arial"/>
-            </a:endParaRPr>
-          </a:p>
-          <a:p>
-            <a:pPr indent="0" algn="l">
-              <a:buNone/>
-            </a:pPr>
-            <a:endParaRPr lang="en-US" sz="2000" b="0" u="none" strike="noStrike">
-              <a:solidFill>
-                <a:srgbClr val="000000"/>
-              </a:solidFill>
-              <a:effectLst/>
-              <a:uFillTx/>
-              <a:latin typeface="Arial"/>
-            </a:endParaRPr>
-          </a:p>
-          <a:p>
-            <a:pPr indent="0" algn="l">
-              <a:buNone/>
-            </a:pPr>
-            <a:r>
-              <a:rPr lang="en-US" sz="1400" b="0" u="none" strike="noStrike">
-                <a:solidFill>
-                  <a:srgbClr val="000000"/>
-                </a:solidFill>
-                <a:effectLst/>
-                <a:uFillTx/>
-                <a:latin typeface="Arial"/>
-              </a:rPr>
-              <a:t>Docentcue:</a:t>
-            </a:r>
-            <a:endParaRPr lang="en-US" sz="2000" b="0" u="none" strike="noStrike">
-              <a:solidFill>
-                <a:srgbClr val="000000"/>
-              </a:solidFill>
-              <a:effectLst/>
-              <a:uFillTx/>
-              <a:latin typeface="Arial"/>
-            </a:endParaRPr>
-          </a:p>
-          <a:p>
-            <a:pPr indent="0" algn="l">
-              <a:buNone/>
-            </a:pPr>
-            <a:r>
-              <a:rPr lang="en-US" sz="1400" b="0" u="none" strike="noStrike">
-                <a:solidFill>
-                  <a:srgbClr val="000000"/>
-                </a:solidFill>
-                <a:effectLst/>
-                <a:uFillTx/>
-                <a:latin typeface="Arial"/>
-              </a:rPr>
-              <a:t>- Gebruik de twee foutkaarten als klassikale diagnose voordat leerlingen zelf rekenen.</a:t>
-            </a:r>
-            <a:endParaRPr lang="en-US" sz="2000" b="0" u="none" strike="noStrike">
-              <a:solidFill>
-                <a:srgbClr val="000000"/>
-              </a:solidFill>
-              <a:effectLst/>
-              <a:uFillTx/>
-              <a:latin typeface="Arial"/>
-            </a:endParaRPr>
-          </a:p>
-          <a:p>
-            <a:pPr indent="0" algn="l">
-              <a:buNone/>
-            </a:pPr>
-            <a:endParaRPr lang="en-US" sz="2000" b="0" u="none" strike="noStrike">
-              <a:solidFill>
-                <a:srgbClr val="000000"/>
-              </a:solidFill>
-              <a:effectLst/>
-              <a:uFillTx/>
-              <a:latin typeface="Arial"/>
-            </a:endParaRPr>
-          </a:p>
-          <a:p>
-            <a:pPr indent="0" algn="l">
-              <a:buNone/>
-            </a:pPr>
-            <a:r>
-              <a:rPr lang="en-US" sz="1400" b="0" u="none" strike="noStrike">
-                <a:solidFill>
-                  <a:srgbClr val="000000"/>
-                </a:solidFill>
-                <a:effectLst/>
-                <a:uFillTx/>
-                <a:latin typeface="Arial"/>
-              </a:rPr>
               <a:t>Overgang:</a:t>
-            </a:r>
-            <a:endParaRPr lang="en-US" sz="2000" b="0" u="none" strike="noStrike">
-              <a:solidFill>
-                <a:srgbClr val="000000"/>
-              </a:solidFill>
-              <a:effectLst/>
-              <a:uFillTx/>
-              <a:latin typeface="Arial"/>
-            </a:endParaRPr>
-          </a:p>
-          <a:p>
-            <a:pPr indent="0" algn="l">
-              <a:buNone/>
-            </a:pPr>
-            <a:r>
-              <a:rPr lang="en-US" sz="1400" b="0" u="none" strike="noStrike">
-                <a:solidFill>
-                  <a:srgbClr val="000000"/>
-                </a:solidFill>
-                <a:effectLst/>
-                <a:uFillTx/>
-                <a:latin typeface="Arial"/>
-              </a:rPr>
-              <a:t>Met die valkuilen helder kunnen we de vaste vierstappenroute gebruiken.</a:t>
-            </a:r>
-            <a:endParaRPr lang="en-US" sz="2000" b="0" u="none" strike="noStrike">
-              <a:solidFill>
-                <a:srgbClr val="000000"/>
-              </a:solidFill>
-              <a:effectLst/>
-              <a:uFillTx/>
-              <a:latin typeface="Arial"/>
-            </a:endParaRPr>
-          </a:p>
-          <a:p>
-            <a:pPr indent="0" algn="l">
-              <a:buNone/>
-            </a:pPr>
-            <a:endParaRPr lang="en-US" sz="2000" b="0" u="none" strike="noStrike">
-              <a:solidFill>
-                <a:srgbClr val="000000"/>
-              </a:solidFill>
-              <a:effectLst/>
-              <a:uFillTx/>
-              <a:latin typeface="Arial"/>
-            </a:endParaRPr>
-          </a:p>
-          <a:p>
-            <a:pPr indent="0" algn="l">
-              <a:buNone/>
-            </a:pPr>
-            <a:r>
-              <a:rPr lang="en-US" sz="1400" b="0" u="none" strike="noStrike">
-                <a:solidFill>
-                  <a:srgbClr val="000000"/>
-                </a:solidFill>
-                <a:effectLst/>
-                <a:uFillTx/>
-                <a:latin typeface="Arial"/>
-              </a:rPr>
-              <a:t>Visual:</a:t>
-            </a:r>
-            <a:endParaRPr lang="en-US" sz="2000" b="0" u="none" strike="noStrike">
-              <a:solidFill>
-                <a:srgbClr val="000000"/>
-              </a:solidFill>
-              <a:effectLst/>
-              <a:uFillTx/>
-              <a:latin typeface="Arial"/>
-            </a:endParaRPr>
-          </a:p>
-          <a:p>
-            <a:pPr indent="0" algn="l">
-              <a:buNone/>
-            </a:pPr>
-            <a:r>
-              <a:rPr lang="en-US" sz="1400" b="0" u="none" strike="noStrike">
-                <a:solidFill>
-                  <a:srgbClr val="000000"/>
-                </a:solidFill>
-                <a:effectLst/>
-                <a:uFillTx/>
-                <a:latin typeface="Arial"/>
-              </a:rPr>
-              <a:t>Twee foutkaarten zetten verwarring naast de correcte controlevraag.</a:t>
-            </a:r>
-            <a:endParaRPr lang="en-US" sz="2000" b="0" u="none" strike="noStrike">
-              <a:solidFill>
-                <a:srgbClr val="000000"/>
-              </a:solidFill>
-              <a:effectLst/>
-              <a:uFillTx/>
-              <a:latin typeface="Arial"/>
-            </a:endParaRPr>
-          </a:p>
-          <a:p>
-            <a:pPr indent="0" algn="l">
-              <a:buNone/>
-            </a:pPr>
-            <a:endParaRPr lang="en-US" sz="2000" b="0" u="none" strike="noStrike">
-              <a:solidFill>
-                <a:srgbClr val="000000"/>
-              </a:solidFill>
-              <a:effectLst/>
-              <a:uFillTx/>
-              <a:latin typeface="Arial"/>
-            </a:endParaRPr>
-          </a:p>
-          <a:p>
-            <a:pPr indent="0" algn="l">
-              <a:buNone/>
-            </a:pPr>
-            <a:r>
-              <a:rPr lang="en-US" sz="1400" b="0" u="none" strike="noStrike">
-                <a:solidFill>
-                  <a:srgbClr val="000000"/>
-                </a:solidFill>
-                <a:effectLst/>
-                <a:uFillTx/>
-                <a:latin typeface="Arial"/>
-              </a:rPr>
-              <a:t>Actie op de dia:</a:t>
             </a:r>
             <a:endParaRPr lang="en-US" sz="2000" b="0" u="none" strike="noStrike">
               <a:solidFill>
@@ -5670,7 +4371,7 @@
                 <a:uFillTx/>
                 <a:latin typeface="Arial"/>
               </a:rPr>
-              <a:t>Noem bij elk voorbeeld eerst: gekozen alternatief en beste niet-gekozen alternatief.</a:t>
+              <a:t>Met die valkuilen helder kunnen we de vaste vierstappenroute gebruiken.</a:t>
             </a:r>
             <a:endParaRPr lang="en-US" sz="2000" b="0" u="none" strike="noStrike">
               <a:solidFill>
@@ -5734,7 +4435,7 @@
               </a:lnSpc>
               <a:buNone/>
             </a:pPr>
-            <a:fld id="{E7B1AA35-0FDE-4AEF-81BA-EF6DBAC89AEA}" type="slidenum">
+            <a:fld id="{36AC1059-11E1-4FC4-81F0-2C3318265564}" type="slidenum">
               <a:rPr lang="en-US" sz="1400" b="0" u="none" strike="noStrike">
                 <a:solidFill>
                   <a:schemeClr val="dk1"/>
@@ -5881,17 +4582,6 @@
             <a:pPr indent="0" algn="l">
               <a:buNone/>
             </a:pPr>
-            <a:r>
-              <a:rPr lang="en-US" sz="1400" b="0" u="none" strike="noStrike">
-                <a:solidFill>
-                  <a:srgbClr val="000000"/>
-                </a:solidFill>
-                <a:effectLst/>
-                <a:uFillTx/>
-                <a:latin typeface="Arial"/>
-              </a:rPr>
-              <a:t>Rol: procedure_route</a:t>
-            </a:r>
             <a:endParaRPr lang="en-US" sz="2000" b="0" u="none" strike="noStrike">
               <a:solidFill>
                 <a:srgbClr val="000000"/>
@@ -5914,7 +4604,7 @@
                 <a:uFillTx/>
                 <a:latin typeface="Arial"/>
               </a:rPr>
-              <a:t>Layout: procedureRoute</a:t>
+              <a:t>Vraag:</a:t>
             </a:r>
             <a:endParaRPr lang="en-US" sz="2000" b="0" u="none" strike="noStrike">
               <a:solidFill>
@@ -5929,6 +4619,17 @@
             <a:pPr indent="0" algn="l">
               <a:buNone/>
             </a:pPr>
+            <a:r>
+              <a:rPr lang="en-US" sz="1400" b="0" u="none" strike="noStrike">
+                <a:solidFill>
+                  <a:srgbClr val="000000"/>
+                </a:solidFill>
+                <a:effectLst/>
+                <a:uFillTx/>
+                <a:latin typeface="Arial"/>
+              </a:rPr>
+              <a:t>Gebruik straks dezelfde volgorde bij de boer.</a:t>
+            </a:r>
             <a:endParaRPr lang="en-US" sz="2000" b="0" u="none" strike="noStrike">
               <a:solidFill>
                 <a:srgbClr val="000000"/>
@@ -5942,17 +4643,6 @@
             <a:pPr indent="0" algn="l">
               <a:buNone/>
             </a:pPr>
-            <a:r>
-              <a:rPr lang="en-US" sz="1400" b="0" u="none" strike="noStrike">
-                <a:solidFill>
-                  <a:srgbClr val="000000"/>
-                </a:solidFill>
-                <a:effectLst/>
-                <a:uFillTx/>
-                <a:latin typeface="Arial"/>
-              </a:rPr>
-              <a:t>Kernzin:</a:t>
-            </a:r>
             <a:endParaRPr lang="en-US" sz="2000" b="0" u="none" strike="noStrike">
               <a:solidFill>
                 <a:srgbClr val="000000"/>
@@ -5975,7 +4665,7 @@
                 <a:uFillTx/>
                 <a:latin typeface="Arial"/>
               </a:rPr>
-              <a:t>De procedure voorkomt dat je te snel “hoogste bedrag = beste keuze” roept.</a:t>
+              <a:t>Uitleg:</a:t>
             </a:r>
             <a:endParaRPr lang="en-US" sz="2000" b="0" u="none" strike="noStrike">
               <a:solidFill>
@@ -5990,6 +4680,17 @@
             <a:pPr indent="0" algn="l">
               <a:buNone/>
             </a:pPr>
+            <a:r>
+              <a:rPr lang="en-US" sz="1400" b="0" u="none" strike="noStrike">
+                <a:solidFill>
+                  <a:srgbClr val="000000"/>
+                </a:solidFill>
+                <a:effectLst/>
+                <a:uFillTx/>
+                <a:latin typeface="Arial"/>
+              </a:rPr>
+              <a:t>- De procedure voorkomt dat je te snel “hoogste bedrag = beste keuze” roept.</a:t>
+            </a:r>
             <a:endParaRPr lang="en-US" sz="2000" b="0" u="none" strike="noStrike">
               <a:solidFill>
                 <a:srgbClr val="000000"/>
@@ -6012,7 +4713,7 @@
                 <a:uFillTx/>
                 <a:latin typeface="Arial"/>
               </a:rPr>
-              <a:t>Studentuitleg:</a:t>
+              <a:t>- Bij Lisa is het voorbeeld klein. In economische vragen worden keuzes vaak groter, met opbrengsten, kosten en meerdere alternatieven.</a:t>
             </a:r>
             <a:endParaRPr lang="en-US" sz="2000" b="0" u="none" strike="noStrike">
               <a:solidFill>
@@ -6036,7 +4737,7 @@
                 <a:uFillTx/>
                 <a:latin typeface="Arial"/>
               </a:rPr>
-              <a:t>- Bij Lisa is het voorbeeld klein. In economische vragen worden keuzes vaak groter, met opbrengsten, kosten en meerdere alternatieven.</a:t>
+              <a:t>- Laat de volgorde nazeggen: middel, opbrengsten, alternatieve kosten, conclusie.</a:t>
             </a:r>
             <a:endParaRPr lang="en-US" sz="2000" b="0" u="none" strike="noStrike">
               <a:solidFill>
@@ -6051,17 +4752,6 @@
             <a:pPr indent="0" algn="l">
               <a:buNone/>
             </a:pPr>
-            <a:r>
-              <a:rPr lang="en-US" sz="1400" b="0" u="none" strike="noStrike">
-                <a:solidFill>
-                  <a:srgbClr val="000000"/>
-                </a:solidFill>
-                <a:effectLst/>
-                <a:uFillTx/>
-                <a:latin typeface="Arial"/>
-              </a:rPr>
-              <a:t>- Daarom werk je in vier stappen: bepaal het schaarse middel, bereken de opbrengst per alternatief, bepaal de alternatieve kosten en trek daarna pas de conclusie.</a:t>
-            </a:r>
             <a:endParaRPr lang="en-US" sz="2000" b="0" u="none" strike="noStrike">
               <a:solidFill>
                 <a:srgbClr val="000000"/>
@@ -6084,7 +4774,7 @@
                 <a:uFillTx/>
                 <a:latin typeface="Arial"/>
               </a:rPr>
-              <a:t>- De volgorde is belangrijk. Eerst rekenen en vergelijken, daarna pas beoordelen.</a:t>
+              <a:t>Pitfall:</a:t>
             </a:r>
             <a:endParaRPr lang="en-US" sz="2000" b="0" u="none" strike="noStrike">
               <a:solidFill>
@@ -6099,6 +4789,17 @@
             <a:pPr indent="0" algn="l">
               <a:buNone/>
             </a:pPr>
+            <a:r>
+              <a:rPr lang="en-US" sz="1400" b="0" u="none" strike="noStrike">
+                <a:solidFill>
+                  <a:srgbClr val="000000"/>
+                </a:solidFill>
+                <a:effectLst/>
+                <a:uFillTx/>
+                <a:latin typeface="Arial"/>
+              </a:rPr>
+              <a:t>Geen specifieke valkuil.</a:t>
+            </a:r>
             <a:endParaRPr lang="en-US" sz="2000" b="0" u="none" strike="noStrike">
               <a:solidFill>
                 <a:srgbClr val="000000"/>
@@ -6112,17 +4813,6 @@
             <a:pPr indent="0" algn="l">
               <a:buNone/>
             </a:pPr>
-            <a:r>
-              <a:rPr lang="en-US" sz="1400" b="0" u="none" strike="noStrike">
-                <a:solidFill>
-                  <a:srgbClr val="000000"/>
-                </a:solidFill>
-                <a:effectLst/>
-                <a:uFillTx/>
-                <a:latin typeface="Arial"/>
-              </a:rPr>
-              <a:t>Docentcue:</a:t>
-            </a:r>
             <a:endParaRPr lang="en-US" sz="2000" b="0" u="none" strike="noStrike">
               <a:solidFill>
                 <a:srgbClr val="000000"/>
@@ -6145,166 +4835,7 @@
                 <a:uFillTx/>
                 <a:latin typeface="Arial"/>
               </a:rPr>
-              <a:t>- Laat de volgorde nazeggen: middel, opbrengsten, alternatieve kosten, conclusie.</a:t>
-            </a:r>
-            <a:endParaRPr lang="en-US" sz="2000" b="0" u="none" strike="noStrike">
-              <a:solidFill>
-                <a:srgbClr val="000000"/>
-              </a:solidFill>
-              <a:effectLst/>
-              <a:uFillTx/>
-              <a:latin typeface="Arial"/>
-            </a:endParaRPr>
-          </a:p>
-          <a:p>
-            <a:pPr indent="0" algn="l">
-              <a:buNone/>
-            </a:pPr>
-            <a:endParaRPr lang="en-US" sz="2000" b="0" u="none" strike="noStrike">
-              <a:solidFill>
-                <a:srgbClr val="000000"/>
-              </a:solidFill>
-              <a:effectLst/>
-              <a:uFillTx/>
-              <a:latin typeface="Arial"/>
-            </a:endParaRPr>
-          </a:p>
-          <a:p>
-            <a:pPr indent="0" algn="l">
-              <a:buNone/>
-            </a:pPr>
-            <a:r>
-              <a:rPr lang="en-US" sz="1400" b="0" u="none" strike="noStrike">
-                <a:solidFill>
-                  <a:srgbClr val="000000"/>
-                </a:solidFill>
-                <a:effectLst/>
-                <a:uFillTx/>
-                <a:latin typeface="Arial"/>
-              </a:rPr>
               <a:t>Overgang:</a:t>
-            </a:r>
-            <a:endParaRPr lang="en-US" sz="2000" b="0" u="none" strike="noStrike">
-              <a:solidFill>
-                <a:srgbClr val="000000"/>
-              </a:solidFill>
-              <a:effectLst/>
-              <a:uFillTx/>
-              <a:latin typeface="Arial"/>
-            </a:endParaRPr>
-          </a:p>
-          <a:p>
-            <a:pPr indent="0" algn="l">
-              <a:buNone/>
-            </a:pPr>
-            <a:r>
-              <a:rPr lang="en-US" sz="1400" b="0" u="none" strike="noStrike">
-                <a:solidFill>
-                  <a:srgbClr val="000000"/>
-                </a:solidFill>
-                <a:effectLst/>
-                <a:uFillTx/>
-                <a:latin typeface="Arial"/>
-              </a:rPr>
-              <a:t>De route passen we nu toe op de boer met 10 hectare land.</a:t>
-            </a:r>
-            <a:endParaRPr lang="en-US" sz="2000" b="0" u="none" strike="noStrike">
-              <a:solidFill>
-                <a:srgbClr val="000000"/>
-              </a:solidFill>
-              <a:effectLst/>
-              <a:uFillTx/>
-              <a:latin typeface="Arial"/>
-            </a:endParaRPr>
-          </a:p>
-          <a:p>
-            <a:pPr indent="0" algn="l">
-              <a:buNone/>
-            </a:pPr>
-            <a:endParaRPr lang="en-US" sz="2000" b="0" u="none" strike="noStrike">
-              <a:solidFill>
-                <a:srgbClr val="000000"/>
-              </a:solidFill>
-              <a:effectLst/>
-              <a:uFillTx/>
-              <a:latin typeface="Arial"/>
-            </a:endParaRPr>
-          </a:p>
-          <a:p>
-            <a:pPr indent="0" algn="l">
-              <a:buNone/>
-            </a:pPr>
-            <a:r>
-              <a:rPr lang="en-US" sz="1400" b="0" u="none" strike="noStrike">
-                <a:solidFill>
-                  <a:srgbClr val="000000"/>
-                </a:solidFill>
-                <a:effectLst/>
-                <a:uFillTx/>
-                <a:latin typeface="Arial"/>
-              </a:rPr>
-              <a:t>Visual:</a:t>
-            </a:r>
-            <a:endParaRPr lang="en-US" sz="2000" b="0" u="none" strike="noStrike">
-              <a:solidFill>
-                <a:srgbClr val="000000"/>
-              </a:solidFill>
-              <a:effectLst/>
-              <a:uFillTx/>
-              <a:latin typeface="Arial"/>
-            </a:endParaRPr>
-          </a:p>
-          <a:p>
-            <a:pPr indent="0" algn="l">
-              <a:buNone/>
-            </a:pPr>
-            <a:r>
-              <a:rPr lang="en-US" sz="1400" b="0" u="none" strike="noStrike">
-                <a:solidFill>
-                  <a:srgbClr val="000000"/>
-                </a:solidFill>
-                <a:effectLst/>
-                <a:uFillTx/>
-                <a:latin typeface="Arial"/>
-              </a:rPr>
-              <a:t>Een vierstappenroute voorkomt dat leerlingen meteen naar de hoogste opbrengst springen.</a:t>
-            </a:r>
-            <a:endParaRPr lang="en-US" sz="2000" b="0" u="none" strike="noStrike">
-              <a:solidFill>
-                <a:srgbClr val="000000"/>
-              </a:solidFill>
-              <a:effectLst/>
-              <a:uFillTx/>
-              <a:latin typeface="Arial"/>
-            </a:endParaRPr>
-          </a:p>
-          <a:p>
-            <a:pPr indent="0" algn="l">
-              <a:buNone/>
-            </a:pPr>
-            <a:endParaRPr lang="en-US" sz="2000" b="0" u="none" strike="noStrike">
-              <a:solidFill>
-                <a:srgbClr val="000000"/>
-              </a:solidFill>
-              <a:effectLst/>
-              <a:uFillTx/>
-              <a:latin typeface="Arial"/>
-            </a:endParaRPr>
-          </a:p>
-          <a:p>
-            <a:pPr indent="0" algn="l">
-              <a:buNone/>
-            </a:pPr>
-            <a:r>
-              <a:rPr lang="en-US" sz="1400" b="0" u="none" strike="noStrike">
-                <a:solidFill>
-                  <a:srgbClr val="000000"/>
-                </a:solidFill>
-                <a:effectLst/>
-                <a:uFillTx/>
-                <a:latin typeface="Arial"/>
-              </a:rPr>
-              <a:t>Actie op de dia:</a:t>
             </a:r>
             <a:endParaRPr lang="en-US" sz="2000" b="0" u="none" strike="noStrike">
               <a:solidFill>
@@ -6331,7 +4862,7 @@
                 <a:uFillTx/>
                 <a:latin typeface="Arial"/>
               </a:rPr>
-              <a:t>Gebruik straks dezelfde volgorde bij de boer.</a:t>
+              <a:t>De route passen we nu toe op de boer met 10 hectare land.</a:t>
             </a:r>
             <a:endParaRPr lang="en-US" sz="2000" b="0" u="none" strike="noStrike">
               <a:solidFill>
@@ -6395,7 +4926,7 @@
               </a:lnSpc>
               <a:buNone/>
             </a:pPr>
-            <a:fld id="{43E9ED11-901A-4A75-8301-9473678E45DA}" type="slidenum">
+            <a:fld id="{A33CC4B8-20CD-428B-96FA-3B4E32FEE9C4}" type="slidenum">
               <a:rPr lang="en-US" sz="1400" b="0" u="none" strike="noStrike">
                 <a:solidFill>
                   <a:schemeClr val="dk1"/>
@@ -6542,17 +5073,6 @@
             <a:pPr indent="0" algn="l">
               <a:buNone/>
             </a:pPr>
-            <a:r>
-              <a:rPr lang="en-US" sz="1400" b="0" u="none" strike="noStrike">
-                <a:solidFill>
-                  <a:srgbClr val="000000"/>
-                </a:solidFill>
-                <a:effectLst/>
-                <a:uFillTx/>
-                <a:latin typeface="Arial"/>
-              </a:rPr>
-              <a:t>Rol: worked_example_calculation</a:t>
-            </a:r>
             <a:endParaRPr lang="en-US" sz="2000" b="0" u="none" strike="noStrike">
               <a:solidFill>
                 <a:srgbClr val="000000"/>
@@ -6575,7 +5095,7 @@
                 <a:uFillTx/>
                 <a:latin typeface="Arial"/>
               </a:rPr>
-              <a:t>Layout: workedCalculation</a:t>
+              <a:t>Vraag:</a:t>
             </a:r>
             <a:endParaRPr lang="en-US" sz="2000" b="0" u="none" strike="noStrike">
               <a:solidFill>
@@ -6590,6 +5110,17 @@
             <a:pPr indent="0" algn="l">
               <a:buNone/>
             </a:pPr>
+            <a:r>
+              <a:rPr lang="en-US" sz="1400" b="0" u="none" strike="noStrike">
+                <a:solidFill>
+                  <a:srgbClr val="000000"/>
+                </a:solidFill>
+                <a:effectLst/>
+                <a:uFillTx/>
+                <a:latin typeface="Arial"/>
+              </a:rPr>
+              <a:t>Vraag: wat levert elk gewas op als alle 10 hectare daarvoor worden gebruikt?</a:t>
+            </a:r>
             <a:endParaRPr lang="en-US" sz="2000" b="0" u="none" strike="noStrike">
               <a:solidFill>
                 <a:srgbClr val="000000"/>
@@ -6603,17 +5134,6 @@
             <a:pPr indent="0" algn="l">
               <a:buNone/>
             </a:pPr>
-            <a:r>
-              <a:rPr lang="en-US" sz="1400" b="0" u="none" strike="noStrike">
-                <a:solidFill>
-                  <a:srgbClr val="000000"/>
-                </a:solidFill>
-                <a:effectLst/>
-                <a:uFillTx/>
-                <a:latin typeface="Arial"/>
-              </a:rPr>
-              <a:t>Kernzin:</a:t>
-            </a:r>
             <a:endParaRPr lang="en-US" sz="2000" b="0" u="none" strike="noStrike">
               <a:solidFill>
                 <a:srgbClr val="000000"/>
@@ -6636,7 +5156,7 @@
                 <a:uFillTx/>
                 <a:latin typeface="Arial"/>
               </a:rPr>
-              <a:t>Het schaarse middel is 10 hectare land; tarwe en maïs gebruiken hetzelfde land.</a:t>
+              <a:t>Uitleg:</a:t>
             </a:r>
             <a:endParaRPr lang="en-US" sz="2000" b="0" u="none" strike="noStrike">
               <a:solidFill>
@@ -6651,6 +5171,17 @@
             <a:pPr indent="0" algn="l">
               <a:buNone/>
             </a:pPr>
+            <a:r>
+              <a:rPr lang="en-US" sz="1400" b="0" u="none" strike="noStrike">
+                <a:solidFill>
+                  <a:srgbClr val="000000"/>
+                </a:solidFill>
+                <a:effectLst/>
+                <a:uFillTx/>
+                <a:latin typeface="Arial"/>
+              </a:rPr>
+              <a:t>- Het schaarse middel is 10 hectare land; tarwe en maïs gebruiken hetzelfde land.</a:t>
+            </a:r>
             <a:endParaRPr lang="en-US" sz="2000" b="0" u="none" strike="noStrike">
               <a:solidFill>
                 <a:srgbClr val="000000"/>
@@ -6673,7 +5204,7 @@
                 <a:uFillTx/>
                 <a:latin typeface="Arial"/>
               </a:rPr>
-              <a:t>Studentuitleg:</a:t>
+              <a:t>- Een boer heeft 10 hectare land. Hij kan tarwe verbouwen of maïs verbouwen, maar hetzelfde stuk land kan niet tegelijk voor beide worden gebruikt.</a:t>
             </a:r>
             <a:endParaRPr lang="en-US" sz="2000" b="0" u="none" strike="noStrike">
               <a:solidFill>
@@ -6697,7 +5228,7 @@
                 <a:uFillTx/>
                 <a:latin typeface="Arial"/>
               </a:rPr>
-              <a:t>- Een boer heeft 10 hectare land. Hij kan tarwe verbouwen of maïs verbouwen, maar hetzelfde stuk land kan niet tegelijk voor beide worden gebruikt.</a:t>
+              <a:t>- Stop na de tabel en laat leerlingen voorspellen waarom er nog geen conclusie staat.</a:t>
             </a:r>
             <a:endParaRPr lang="en-US" sz="2000" b="0" u="none" strike="noStrike">
               <a:solidFill>
@@ -6712,17 +5243,6 @@
             <a:pPr indent="0" algn="l">
               <a:buNone/>
             </a:pPr>
-            <a:r>
-              <a:rPr lang="en-US" sz="1400" b="0" u="none" strike="noStrike">
-                <a:solidFill>
-                  <a:srgbClr val="000000"/>
-                </a:solidFill>
-                <a:effectLst/>
-                <a:uFillTx/>
-                <a:latin typeface="Arial"/>
-              </a:rPr>
-              <a:t>- Eerst bereken je de opbrengst per alternatief. Tarwe levert €500 per hectare op, dus 10 hectare tarwe levert €5.000 op. Maïs levert €350 per hectare op, dus 10 hectare maïs levert €3.500 op.</a:t>
-            </a:r>
             <a:endParaRPr lang="en-US" sz="2000" b="0" u="none" strike="noStrike">
               <a:solidFill>
                 <a:srgbClr val="000000"/>
@@ -6745,7 +5265,7 @@
                 <a:uFillTx/>
                 <a:latin typeface="Arial"/>
               </a:rPr>
-              <a:t>- Let op: je trekt nog geen conclusie. Je maakt eerst beide alternatieven vergelijkbaar.</a:t>
+              <a:t>Pitfall:</a:t>
             </a:r>
             <a:endParaRPr lang="en-US" sz="2000" b="0" u="none" strike="noStrike">
               <a:solidFill>
@@ -6760,6 +5280,17 @@
             <a:pPr indent="0" algn="l">
               <a:buNone/>
             </a:pPr>
+            <a:r>
+              <a:rPr lang="en-US" sz="1400" b="0" u="none" strike="noStrike">
+                <a:solidFill>
+                  <a:srgbClr val="000000"/>
+                </a:solidFill>
+                <a:effectLst/>
+                <a:uFillTx/>
+                <a:latin typeface="Arial"/>
+              </a:rPr>
+              <a:t>Geen specifieke valkuil.</a:t>
+            </a:r>
             <a:endParaRPr lang="en-US" sz="2000" b="0" u="none" strike="noStrike">
               <a:solidFill>
                 <a:srgbClr val="000000"/>
@@ -6773,17 +5304,6 @@
             <a:pPr indent="0" algn="l">
               <a:buNone/>
             </a:pPr>
-            <a:r>
-              <a:rPr lang="en-US" sz="1400" b="0" u="none" strike="noStrike">
-                <a:solidFill>
-                  <a:srgbClr val="000000"/>
-                </a:solidFill>
-                <a:effectLst/>
-                <a:uFillTx/>
-                <a:latin typeface="Arial"/>
-              </a:rPr>
-              <a:t>Docentcue:</a:t>
-            </a:r>
             <a:endParaRPr lang="en-US" sz="2000" b="0" u="none" strike="noStrike">
               <a:solidFill>
                 <a:srgbClr val="000000"/>
@@ -6806,166 +5326,7 @@
                 <a:uFillTx/>
                 <a:latin typeface="Arial"/>
               </a:rPr>
-              <a:t>- Stop na de tabel en laat leerlingen voorspellen waarom er nog geen conclusie staat.</a:t>
-            </a:r>
-            <a:endParaRPr lang="en-US" sz="2000" b="0" u="none" strike="noStrike">
-              <a:solidFill>
-                <a:srgbClr val="000000"/>
-              </a:solidFill>
-              <a:effectLst/>
-              <a:uFillTx/>
-              <a:latin typeface="Arial"/>
-            </a:endParaRPr>
-          </a:p>
-          <a:p>
-            <a:pPr indent="0" algn="l">
-              <a:buNone/>
-            </a:pPr>
-            <a:endParaRPr lang="en-US" sz="2000" b="0" u="none" strike="noStrike">
-              <a:solidFill>
-                <a:srgbClr val="000000"/>
-              </a:solidFill>
-              <a:effectLst/>
-              <a:uFillTx/>
-              <a:latin typeface="Arial"/>
-            </a:endParaRPr>
-          </a:p>
-          <a:p>
-            <a:pPr indent="0" algn="l">
-              <a:buNone/>
-            </a:pPr>
-            <a:r>
-              <a:rPr lang="en-US" sz="1400" b="0" u="none" strike="noStrike">
-                <a:solidFill>
-                  <a:srgbClr val="000000"/>
-                </a:solidFill>
-                <a:effectLst/>
-                <a:uFillTx/>
-                <a:latin typeface="Arial"/>
-              </a:rPr>
               <a:t>Overgang:</a:t>
-            </a:r>
-            <a:endParaRPr lang="en-US" sz="2000" b="0" u="none" strike="noStrike">
-              <a:solidFill>
-                <a:srgbClr val="000000"/>
-              </a:solidFill>
-              <a:effectLst/>
-              <a:uFillTx/>
-              <a:latin typeface="Arial"/>
-            </a:endParaRPr>
-          </a:p>
-          <a:p>
-            <a:pPr indent="0" algn="l">
-              <a:buNone/>
-            </a:pPr>
-            <a:r>
-              <a:rPr lang="en-US" sz="1400" b="0" u="none" strike="noStrike">
-                <a:solidFill>
-                  <a:srgbClr val="000000"/>
-                </a:solidFill>
-                <a:effectLst/>
-                <a:uFillTx/>
-                <a:latin typeface="Arial"/>
-              </a:rPr>
-              <a:t>Na het rekenen volgt de interpretatie: wat geeft de boer op en wat blijft netto over?</a:t>
-            </a:r>
-            <a:endParaRPr lang="en-US" sz="2000" b="0" u="none" strike="noStrike">
-              <a:solidFill>
-                <a:srgbClr val="000000"/>
-              </a:solidFill>
-              <a:effectLst/>
-              <a:uFillTx/>
-              <a:latin typeface="Arial"/>
-            </a:endParaRPr>
-          </a:p>
-          <a:p>
-            <a:pPr indent="0" algn="l">
-              <a:buNone/>
-            </a:pPr>
-            <a:endParaRPr lang="en-US" sz="2000" b="0" u="none" strike="noStrike">
-              <a:solidFill>
-                <a:srgbClr val="000000"/>
-              </a:solidFill>
-              <a:effectLst/>
-              <a:uFillTx/>
-              <a:latin typeface="Arial"/>
-            </a:endParaRPr>
-          </a:p>
-          <a:p>
-            <a:pPr indent="0" algn="l">
-              <a:buNone/>
-            </a:pPr>
-            <a:r>
-              <a:rPr lang="en-US" sz="1400" b="0" u="none" strike="noStrike">
-                <a:solidFill>
-                  <a:srgbClr val="000000"/>
-                </a:solidFill>
-                <a:effectLst/>
-                <a:uFillTx/>
-                <a:latin typeface="Arial"/>
-              </a:rPr>
-              <a:t>Visual:</a:t>
-            </a:r>
-            <a:endParaRPr lang="en-US" sz="2000" b="0" u="none" strike="noStrike">
-              <a:solidFill>
-                <a:srgbClr val="000000"/>
-              </a:solidFill>
-              <a:effectLst/>
-              <a:uFillTx/>
-              <a:latin typeface="Arial"/>
-            </a:endParaRPr>
-          </a:p>
-          <a:p>
-            <a:pPr indent="0" algn="l">
-              <a:buNone/>
-            </a:pPr>
-            <a:r>
-              <a:rPr lang="en-US" sz="1400" b="0" u="none" strike="noStrike">
-                <a:solidFill>
-                  <a:srgbClr val="000000"/>
-                </a:solidFill>
-                <a:effectLst/>
-                <a:uFillTx/>
-                <a:latin typeface="Arial"/>
-              </a:rPr>
-              <a:t>Een rekentabel maakt beide alternatieven vergelijkbaar voordat de conclusie volgt.</a:t>
-            </a:r>
-            <a:endParaRPr lang="en-US" sz="2000" b="0" u="none" strike="noStrike">
-              <a:solidFill>
-                <a:srgbClr val="000000"/>
-              </a:solidFill>
-              <a:effectLst/>
-              <a:uFillTx/>
-              <a:latin typeface="Arial"/>
-            </a:endParaRPr>
-          </a:p>
-          <a:p>
-            <a:pPr indent="0" algn="l">
-              <a:buNone/>
-            </a:pPr>
-            <a:endParaRPr lang="en-US" sz="2000" b="0" u="none" strike="noStrike">
-              <a:solidFill>
-                <a:srgbClr val="000000"/>
-              </a:solidFill>
-              <a:effectLst/>
-              <a:uFillTx/>
-              <a:latin typeface="Arial"/>
-            </a:endParaRPr>
-          </a:p>
-          <a:p>
-            <a:pPr indent="0" algn="l">
-              <a:buNone/>
-            </a:pPr>
-            <a:r>
-              <a:rPr lang="en-US" sz="1400" b="0" u="none" strike="noStrike">
-                <a:solidFill>
-                  <a:srgbClr val="000000"/>
-                </a:solidFill>
-                <a:effectLst/>
-                <a:uFillTx/>
-                <a:latin typeface="Arial"/>
-              </a:rPr>
-              <a:t>Actie op de dia:</a:t>
             </a:r>
             <a:endParaRPr lang="en-US" sz="2000" b="0" u="none" strike="noStrike">
               <a:solidFill>
@@ -6992,7 +5353,7 @@
                 <a:uFillTx/>
                 <a:latin typeface="Arial"/>
               </a:rPr>
-              <a:t>Vraag: wat levert elk gewas op als alle 10 hectare daarvoor worden gebruikt?</a:t>
+              <a:t>Na het rekenen volgt de interpretatie: wat geeft de boer op en wat blijft netto over?</a:t>
             </a:r>
             <a:endParaRPr lang="en-US" sz="2000" b="0" u="none" strike="noStrike">
               <a:solidFill>
@@ -7056,7 +5417,7 @@
               </a:lnSpc>
               <a:buNone/>
             </a:pPr>
-            <a:fld id="{C8768804-B72C-44CC-947F-046013C86F5A}" type="slidenum">
+            <a:fld id="{72103C89-2296-4FEF-818A-605155C1D51D}" type="slidenum">
               <a:rPr lang="en-US" sz="1400" b="0" u="none" strike="noStrike">
                 <a:solidFill>
                   <a:schemeClr val="dk1"/>
@@ -7203,17 +5564,6 @@
             <a:pPr indent="0" algn="l">
               <a:buNone/>
             </a:pPr>
-            <a:r>
-              <a:rPr lang="en-US" sz="1400" b="0" u="none" strike="noStrike">
-                <a:solidFill>
-                  <a:srgbClr val="000000"/>
-                </a:solidFill>
-                <a:effectLst/>
-                <a:uFillTx/>
-                <a:latin typeface="Arial"/>
-              </a:rPr>
-              <a:t>Rol: worked_example_interpretation</a:t>
-            </a:r>
             <a:endParaRPr lang="en-US" sz="2000" b="0" u="none" strike="noStrike">
               <a:solidFill>
                 <a:srgbClr val="000000"/>
@@ -7236,7 +5586,7 @@
                 <a:uFillTx/>
                 <a:latin typeface="Arial"/>
               </a:rPr>
-              <a:t>Layout: workedInterpretation</a:t>
+              <a:t>Vraag:</a:t>
             </a:r>
             <a:endParaRPr lang="en-US" sz="2000" b="0" u="none" strike="noStrike">
               <a:solidFill>
@@ -7251,6 +5601,17 @@
             <a:pPr indent="0" algn="l">
               <a:buNone/>
             </a:pPr>
+            <a:r>
+              <a:rPr lang="en-US" sz="1400" b="0" u="none" strike="noStrike">
+                <a:solidFill>
+                  <a:srgbClr val="000000"/>
+                </a:solidFill>
+                <a:effectLst/>
+                <a:uFillTx/>
+                <a:latin typeface="Arial"/>
+              </a:rPr>
+              <a:t>Nettowaarde: €5.000 − €3.500 = €1.500.</a:t>
+            </a:r>
             <a:endParaRPr lang="en-US" sz="2000" b="0" u="none" strike="noStrike">
               <a:solidFill>
                 <a:srgbClr val="000000"/>
@@ -7264,17 +5625,6 @@
             <a:pPr indent="0" algn="l">
               <a:buNone/>
             </a:pPr>
-            <a:r>
-              <a:rPr lang="en-US" sz="1400" b="0" u="none" strike="noStrike">
-                <a:solidFill>
-                  <a:srgbClr val="000000"/>
-                </a:solidFill>
-                <a:effectLst/>
-                <a:uFillTx/>
-                <a:latin typeface="Arial"/>
-              </a:rPr>
-              <a:t>Kernzin:</a:t>
-            </a:r>
             <a:endParaRPr lang="en-US" sz="2000" b="0" u="none" strike="noStrike">
               <a:solidFill>
                 <a:srgbClr val="000000"/>
@@ -7297,7 +5647,7 @@
                 <a:uFillTx/>
                 <a:latin typeface="Arial"/>
               </a:rPr>
-              <a:t>Maïs is dan het beste niet-gekozen alternatief; daarom zijn de alternatieve kosten €3.500.</a:t>
+              <a:t>Uitleg:</a:t>
             </a:r>
             <a:endParaRPr lang="en-US" sz="2000" b="0" u="none" strike="noStrike">
               <a:solidFill>
@@ -7312,6 +5662,17 @@
             <a:pPr indent="0" algn="l">
               <a:buNone/>
             </a:pPr>
+            <a:r>
+              <a:rPr lang="en-US" sz="1400" b="0" u="none" strike="noStrike">
+                <a:solidFill>
+                  <a:srgbClr val="000000"/>
+                </a:solidFill>
+                <a:effectLst/>
+                <a:uFillTx/>
+                <a:latin typeface="Arial"/>
+              </a:rPr>
+              <a:t>- Maïs is dan het beste niet-gekozen alternatief; daarom zijn de alternatieve kosten €3.500.</a:t>
+            </a:r>
             <a:endParaRPr lang="en-US" sz="2000" b="0" u="none" strike="noStrike">
               <a:solidFill>
                 <a:srgbClr val="000000"/>
@@ -7334,7 +5695,7 @@
                 <a:uFillTx/>
                 <a:latin typeface="Arial"/>
               </a:rPr>
-              <a:t>Studentuitleg:</a:t>
+              <a:t>- Stel dat de boer tarwe kiest. Dan krijgt hij €5.000 opbrengst, maar hij geeft de maïsopbrengst op.</a:t>
             </a:r>
             <a:endParaRPr lang="en-US" sz="2000" b="0" u="none" strike="noStrike">
               <a:solidFill>
@@ -7358,7 +5719,7 @@
                 <a:uFillTx/>
                 <a:latin typeface="Arial"/>
               </a:rPr>
-              <a:t>- Stel dat de boer tarwe kiest. Dan krijgt hij €5.000 opbrengst, maar hij geeft de maïsopbrengst op.</a:t>
+              <a:t>- Benadruk dat nettowaarde een vergelijking boven het beste alternatief is, geen totale winstclaim.</a:t>
             </a:r>
             <a:endParaRPr lang="en-US" sz="2000" b="0" u="none" strike="noStrike">
               <a:solidFill>
@@ -7373,17 +5734,6 @@
             <a:pPr indent="0" algn="l">
               <a:buNone/>
             </a:pPr>
-            <a:r>
-              <a:rPr lang="en-US" sz="1400" b="0" u="none" strike="noStrike">
-                <a:solidFill>
-                  <a:srgbClr val="000000"/>
-                </a:solidFill>
-                <a:effectLst/>
-                <a:uFillTx/>
-                <a:latin typeface="Arial"/>
-              </a:rPr>
-              <a:t>- Omdat maïs het beste niet-gekozen alternatief is, zijn de alternatieve kosten €3.500.</a:t>
-            </a:r>
             <a:endParaRPr lang="en-US" sz="2000" b="0" u="none" strike="noStrike">
               <a:solidFill>
                 <a:srgbClr val="000000"/>
@@ -7406,7 +5756,7 @@
                 <a:uFillTx/>
                 <a:latin typeface="Arial"/>
               </a:rPr>
-              <a:t>- De nettowaarde van tarwe boven maïs is dan €5.000 min €3.500 is €1.500. Dat bedrag laat zien hoeveel beter tarwe is dan het alternatief dat hij opgeeft.</a:t>
+              <a:t>Pitfall:</a:t>
             </a:r>
             <a:endParaRPr lang="en-US" sz="2000" b="0" u="none" strike="noStrike">
               <a:solidFill>
@@ -7421,6 +5771,17 @@
             <a:pPr indent="0" algn="l">
               <a:buNone/>
             </a:pPr>
+            <a:r>
+              <a:rPr lang="en-US" sz="1400" b="0" u="none" strike="noStrike">
+                <a:solidFill>
+                  <a:srgbClr val="000000"/>
+                </a:solidFill>
+                <a:effectLst/>
+                <a:uFillTx/>
+                <a:latin typeface="Arial"/>
+              </a:rPr>
+              <a:t>Geen specifieke valkuil.</a:t>
+            </a:r>
             <a:endParaRPr lang="en-US" sz="2000" b="0" u="none" strike="noStrike">
               <a:solidFill>
                 <a:srgbClr val="000000"/>
@@ -7434,17 +5795,6 @@
             <a:pPr indent="0" algn="l">
               <a:buNone/>
             </a:pPr>
-            <a:r>
-              <a:rPr lang="en-US" sz="1400" b="0" u="none" strike="noStrike">
-                <a:solidFill>
-                  <a:srgbClr val="000000"/>
-                </a:solidFill>
-                <a:effectLst/>
-                <a:uFillTx/>
-                <a:latin typeface="Arial"/>
-              </a:rPr>
-              <a:t>Docentcue:</a:t>
-            </a:r>
             <a:endParaRPr lang="en-US" sz="2000" b="0" u="none" strike="noStrike">
               <a:solidFill>
                 <a:srgbClr val="000000"/>
@@ -7467,166 +5817,7 @@
                 <a:uFillTx/>
                 <a:latin typeface="Arial"/>
               </a:rPr>
-              <a:t>- Benadruk dat nettowaarde een vergelijking boven het beste alternatief is, geen totale winstclaim.</a:t>
-            </a:r>
-            <a:endParaRPr lang="en-US" sz="2000" b="0" u="none" strike="noStrike">
-              <a:solidFill>
-                <a:srgbClr val="000000"/>
-              </a:solidFill>
-              <a:effectLst/>
-              <a:uFillTx/>
-              <a:latin typeface="Arial"/>
-            </a:endParaRPr>
-          </a:p>
-          <a:p>
-            <a:pPr indent="0" algn="l">
-              <a:buNone/>
-            </a:pPr>
-            <a:endParaRPr lang="en-US" sz="2000" b="0" u="none" strike="noStrike">
-              <a:solidFill>
-                <a:srgbClr val="000000"/>
-              </a:solidFill>
-              <a:effectLst/>
-              <a:uFillTx/>
-              <a:latin typeface="Arial"/>
-            </a:endParaRPr>
-          </a:p>
-          <a:p>
-            <a:pPr indent="0" algn="l">
-              <a:buNone/>
-            </a:pPr>
-            <a:r>
-              <a:rPr lang="en-US" sz="1400" b="0" u="none" strike="noStrike">
-                <a:solidFill>
-                  <a:srgbClr val="000000"/>
-                </a:solidFill>
-                <a:effectLst/>
-                <a:uFillTx/>
-                <a:latin typeface="Arial"/>
-              </a:rPr>
               <a:t>Overgang:</a:t>
-            </a:r>
-            <a:endParaRPr lang="en-US" sz="2000" b="0" u="none" strike="noStrike">
-              <a:solidFill>
-                <a:srgbClr val="000000"/>
-              </a:solidFill>
-              <a:effectLst/>
-              <a:uFillTx/>
-              <a:latin typeface="Arial"/>
-            </a:endParaRPr>
-          </a:p>
-          <a:p>
-            <a:pPr indent="0" algn="l">
-              <a:buNone/>
-            </a:pPr>
-            <a:r>
-              <a:rPr lang="en-US" sz="1400" b="0" u="none" strike="noStrike">
-                <a:solidFill>
-                  <a:srgbClr val="000000"/>
-                </a:solidFill>
-                <a:effectLst/>
-                <a:uFillTx/>
-                <a:latin typeface="Arial"/>
-              </a:rPr>
-              <a:t>Daarna controleren leerlingen of ze het patroon zelf kunnen terughalen.</a:t>
-            </a:r>
-            <a:endParaRPr lang="en-US" sz="2000" b="0" u="none" strike="noStrike">
-              <a:solidFill>
-                <a:srgbClr val="000000"/>
-              </a:solidFill>
-              <a:effectLst/>
-              <a:uFillTx/>
-              <a:latin typeface="Arial"/>
-            </a:endParaRPr>
-          </a:p>
-          <a:p>
-            <a:pPr indent="0" algn="l">
-              <a:buNone/>
-            </a:pPr>
-            <a:endParaRPr lang="en-US" sz="2000" b="0" u="none" strike="noStrike">
-              <a:solidFill>
-                <a:srgbClr val="000000"/>
-              </a:solidFill>
-              <a:effectLst/>
-              <a:uFillTx/>
-              <a:latin typeface="Arial"/>
-            </a:endParaRPr>
-          </a:p>
-          <a:p>
-            <a:pPr indent="0" algn="l">
-              <a:buNone/>
-            </a:pPr>
-            <a:r>
-              <a:rPr lang="en-US" sz="1400" b="0" u="none" strike="noStrike">
-                <a:solidFill>
-                  <a:srgbClr val="000000"/>
-                </a:solidFill>
-                <a:effectLst/>
-                <a:uFillTx/>
-                <a:latin typeface="Arial"/>
-              </a:rPr>
-              <a:t>Visual:</a:t>
-            </a:r>
-            <a:endParaRPr lang="en-US" sz="2000" b="0" u="none" strike="noStrike">
-              <a:solidFill>
-                <a:srgbClr val="000000"/>
-              </a:solidFill>
-              <a:effectLst/>
-              <a:uFillTx/>
-              <a:latin typeface="Arial"/>
-            </a:endParaRPr>
-          </a:p>
-          <a:p>
-            <a:pPr indent="0" algn="l">
-              <a:buNone/>
-            </a:pPr>
-            <a:r>
-              <a:rPr lang="en-US" sz="1400" b="0" u="none" strike="noStrike">
-                <a:solidFill>
-                  <a:srgbClr val="000000"/>
-                </a:solidFill>
-                <a:effectLst/>
-                <a:uFillTx/>
-                <a:latin typeface="Arial"/>
-              </a:rPr>
-              <a:t>Een nettowaarde-vergelijking toont opbrengst min alternatieve kosten.</a:t>
-            </a:r>
-            <a:endParaRPr lang="en-US" sz="2000" b="0" u="none" strike="noStrike">
-              <a:solidFill>
-                <a:srgbClr val="000000"/>
-              </a:solidFill>
-              <a:effectLst/>
-              <a:uFillTx/>
-              <a:latin typeface="Arial"/>
-            </a:endParaRPr>
-          </a:p>
-          <a:p>
-            <a:pPr indent="0" algn="l">
-              <a:buNone/>
-            </a:pPr>
-            <a:endParaRPr lang="en-US" sz="2000" b="0" u="none" strike="noStrike">
-              <a:solidFill>
-                <a:srgbClr val="000000"/>
-              </a:solidFill>
-              <a:effectLst/>
-              <a:uFillTx/>
-              <a:latin typeface="Arial"/>
-            </a:endParaRPr>
-          </a:p>
-          <a:p>
-            <a:pPr indent="0" algn="l">
-              <a:buNone/>
-            </a:pPr>
-            <a:r>
-              <a:rPr lang="en-US" sz="1400" b="0" u="none" strike="noStrike">
-                <a:solidFill>
-                  <a:srgbClr val="000000"/>
-                </a:solidFill>
-                <a:effectLst/>
-                <a:uFillTx/>
-                <a:latin typeface="Arial"/>
-              </a:rPr>
-              <a:t>Actie op de dia:</a:t>
             </a:r>
             <a:endParaRPr lang="en-US" sz="2000" b="0" u="none" strike="noStrike">
               <a:solidFill>
@@ -7653,7 +5844,7 @@
                 <a:uFillTx/>
                 <a:latin typeface="Arial"/>
               </a:rPr>
-              <a:t>Nettowaarde: €5.000 − €3.500 = €1.500.</a:t>
+              <a:t>Daarna controleren leerlingen of ze het patroon zelf kunnen terughalen.</a:t>
             </a:r>
             <a:endParaRPr lang="en-US" sz="2000" b="0" u="none" strike="noStrike">
               <a:solidFill>
@@ -7717,7 +5908,7 @@
               </a:lnSpc>
               <a:buNone/>
             </a:pPr>
-            <a:fld id="{78A26227-46CC-4DAB-B2EC-979F1ABB0D65}" type="slidenum">
+            <a:fld id="{2AD8BBA3-274E-47E8-A7C6-C0C5BDDC8941}" type="slidenum">
               <a:rPr lang="en-US" sz="1400" b="0" u="none" strike="noStrike">
                 <a:solidFill>
                   <a:schemeClr val="dk1"/>
@@ -10302,7 +8493,7 @@
                 <a:latin typeface="Segoe UI"/>
                 <a:ea typeface="Segoe UI"/>
               </a:rPr>
-              <a:t>Lisa’s €20.</a:t>
+              <a:t>denk aan haar budget</a:t>
             </a:r>
             <a:endParaRPr lang="en-US" sz="1800" b="0" u="none" strike="noStrike">
               <a:solidFill>
@@ -10533,7 +8724,7 @@
                 <a:latin typeface="Segoe UI"/>
                 <a:ea typeface="Segoe UI"/>
               </a:rPr>
-              <a:t>Het boek lezen, met de waarde die dat voor haar heeft.</a:t>
+              <a:t>niet de prijs noemen</a:t>
             </a:r>
             <a:endParaRPr lang="en-US" sz="1800" b="0" u="none" strike="noStrike">
               <a:solidFill>
@@ -10764,7 +8955,7 @@
                 <a:latin typeface="Segoe UI"/>
                 <a:ea typeface="Segoe UI"/>
               </a:rPr>
-              <a:t>De opbrengst van maïs: €3.500.</a:t>
+              <a:t>gebruik de tabel</a:t>
             </a:r>
             <a:endParaRPr lang="en-US" sz="1800" b="0" u="none" strike="noStrike">
               <a:solidFill>

</xml_diff>

<commit_message>
Refresh PPTX presentation outputs after base sync
</commit_message>
<xml_diff>
--- a/Boek 1 - Grondslagen, vraag en aanbod/1.1 Hoofdstuk Economisch denken en rekenen/1.1.1 Schaarste en economisch denken/1.1.1 Schaarste en economisch denken – presentatie.pptx
+++ b/Boek 1 - Grondslagen, vraag en aanbod/1.1 Hoofdstuk Economisch denken en rekenen/1.1.1 Schaarste en economisch denken/1.1.1 Schaarste en economisch denken – presentatie.pptx
@@ -374,7 +374,7 @@
             <a:pPr indent="0" algn="r">
               <a:buNone/>
             </a:pPr>
-            <a:fld id="{1C046D76-6527-4277-A579-F3DEA8CA8657}" type="slidenum">
+            <a:fld id="{20DD783C-78C6-4753-A711-3C48D4A34B84}" type="slidenum">
               <a:rPr lang="en-US" sz="1400" b="0" u="none" strike="noStrike">
                 <a:solidFill>
                   <a:srgbClr val="000000"/>
@@ -865,7 +865,7 @@
               </a:lnSpc>
               <a:buNone/>
             </a:pPr>
-            <a:fld id="{D2F98409-F010-47D6-8191-17EE5CD1E6B6}" type="slidenum">
+            <a:fld id="{DAFFBCED-8214-40D8-A107-6C6014B8300F}" type="slidenum">
               <a:rPr lang="en-US" sz="1400" b="0" u="none" strike="noStrike">
                 <a:solidFill>
                   <a:schemeClr val="dk1"/>
@@ -1441,7 +1441,7 @@
               </a:lnSpc>
               <a:buNone/>
             </a:pPr>
-            <a:fld id="{12D1ACBB-9B4E-4323-856A-1560CECE6887}" type="slidenum">
+            <a:fld id="{CA82B535-4068-4F7F-8009-5F4F1A193E9F}" type="slidenum">
               <a:rPr lang="en-US" sz="1400" b="0" u="none" strike="noStrike">
                 <a:solidFill>
                   <a:schemeClr val="dk1"/>
@@ -1956,7 +1956,7 @@
               </a:lnSpc>
               <a:buNone/>
             </a:pPr>
-            <a:fld id="{C804F74C-0343-4E1D-93E1-6197A63AA20E}" type="slidenum">
+            <a:fld id="{76F6044A-81C9-413F-BD1F-182D8173096F}" type="slidenum">
               <a:rPr lang="en-US" sz="1400" b="0" u="none" strike="noStrike">
                 <a:solidFill>
                   <a:schemeClr val="dk1"/>
@@ -2447,7 +2447,7 @@
               </a:lnSpc>
               <a:buNone/>
             </a:pPr>
-            <a:fld id="{216FE983-39BB-4B60-8915-F1CD1A61550A}" type="slidenum">
+            <a:fld id="{C0A9C160-E269-434B-9D8E-DE1FA6B7A381}" type="slidenum">
               <a:rPr lang="en-US" sz="1400" b="0" u="none" strike="noStrike">
                 <a:solidFill>
                   <a:schemeClr val="dk1"/>
@@ -2938,7 +2938,7 @@
               </a:lnSpc>
               <a:buNone/>
             </a:pPr>
-            <a:fld id="{0826CB84-D3D8-4AEA-8D9F-EB9CA9F6936E}" type="slidenum">
+            <a:fld id="{72DC95DD-1E9A-4326-B96E-016E6D405D3B}" type="slidenum">
               <a:rPr lang="en-US" sz="1400" b="0" u="none" strike="noStrike">
                 <a:solidFill>
                   <a:schemeClr val="dk1"/>
@@ -3429,7 +3429,7 @@
               </a:lnSpc>
               <a:buNone/>
             </a:pPr>
-            <a:fld id="{DCC1B2EF-74A2-4FE7-9FC6-8A4A6E5CA0C1}" type="slidenum">
+            <a:fld id="{9699D8A5-0BE0-4472-9E59-FF46765A547B}" type="slidenum">
               <a:rPr lang="en-US" sz="1400" b="0" u="none" strike="noStrike">
                 <a:solidFill>
                   <a:schemeClr val="dk1"/>
@@ -3920,7 +3920,7 @@
               </a:lnSpc>
               <a:buNone/>
             </a:pPr>
-            <a:fld id="{9B4EB52E-E7E3-4F2A-BE65-07F70FAAB0B3}" type="slidenum">
+            <a:fld id="{79DE1455-6EC6-4668-BA30-0AB0960B23E2}" type="slidenum">
               <a:rPr lang="en-US" sz="1400" b="0" u="none" strike="noStrike">
                 <a:solidFill>
                   <a:schemeClr val="dk1"/>
@@ -4435,7 +4435,7 @@
               </a:lnSpc>
               <a:buNone/>
             </a:pPr>
-            <a:fld id="{36AC1059-11E1-4FC4-81F0-2C3318265564}" type="slidenum">
+            <a:fld id="{68022C86-3B84-4E1F-8EFD-236B7EBBB103}" type="slidenum">
               <a:rPr lang="en-US" sz="1400" b="0" u="none" strike="noStrike">
                 <a:solidFill>
                   <a:schemeClr val="dk1"/>
@@ -4926,7 +4926,7 @@
               </a:lnSpc>
               <a:buNone/>
             </a:pPr>
-            <a:fld id="{A33CC4B8-20CD-428B-96FA-3B4E32FEE9C4}" type="slidenum">
+            <a:fld id="{BFD643E3-E61D-4836-8254-01BDBB8F0F19}" type="slidenum">
               <a:rPr lang="en-US" sz="1400" b="0" u="none" strike="noStrike">
                 <a:solidFill>
                   <a:schemeClr val="dk1"/>
@@ -5417,7 +5417,7 @@
               </a:lnSpc>
               <a:buNone/>
             </a:pPr>
-            <a:fld id="{72103C89-2296-4FEF-818A-605155C1D51D}" type="slidenum">
+            <a:fld id="{D86D1061-72E5-485B-82F4-0388C768A689}" type="slidenum">
               <a:rPr lang="en-US" sz="1400" b="0" u="none" strike="noStrike">
                 <a:solidFill>
                   <a:schemeClr val="dk1"/>
@@ -5908,7 +5908,7 @@
               </a:lnSpc>
               <a:buNone/>
             </a:pPr>
-            <a:fld id="{2AD8BBA3-274E-47E8-A7C6-C0C5BDDC8941}" type="slidenum">
+            <a:fld id="{38D7169D-1837-42C1-B109-E29CBFDB1EB0}" type="slidenum">
               <a:rPr lang="en-US" sz="1400" b="0" u="none" strike="noStrike">
                 <a:solidFill>
                   <a:schemeClr val="dk1"/>

</xml_diff>